<commit_message>
Update slides to reflect 3 critical fixes
Slide 1: subtitle updated - 'ML (Kapali Dongu)' vurgusu eklendi
Slide 3 (yeniden tasarlandi):
  - ML sutunu: 5 ozellik gosterimi (T_ic dahil), kapali dongu akisi,
    yesil onay kutulari ile duzeltmeler gosterildi
  - Agent sutunu: Konfor Ajani'nin T_ic'i Dijital Ikiz'den aldigini belgelendi
  - DT sutunu: P_klima=0 sinirlilik notu eklendi
Slide 4: 'Uygulanan Teknik Duzeltmeler' bolumu eklendi (4 madde)

Co-Authored-By: Claude Sonnet 4.6 <noreply@anthropic.com>
</commit_message>
<xml_diff>
--- a/bina_enerji_dijital_ikiz_sunum.pptx
+++ b/bina_enerji_dijital_ikiz_sunum.pptx
@@ -1324,7 +1324,7 @@
               <a:buNone/>
             </a:pPr>
             <a:r>
-              <a:rPr lang="en-US" sz="1250" i="1" dirty="0">
+              <a:rPr lang="en-US" sz="1200" i="1" dirty="0">
                 <a:solidFill>
                   <a:srgbClr val="8AB4D4"/>
                 </a:solidFill>
@@ -1332,9 +1332,9 @@
                 <a:ea typeface="Calibri" pitchFamily="34" charset="-122"/>
                 <a:cs typeface="Calibri" pitchFamily="34" charset="-120"/>
               </a:rPr>
-              <a:t>Fiziksel Termal Model  ·  Çoklu Ajan  ·  ML  ·  Gerçek IoT Validasyonu</a:t>
-            </a:r>
-            <a:endParaRPr lang="en-US" sz="1250" dirty="0"/>
+              <a:t>Fiziksel Termal Model  ·  Çoklu Ajan  ·  ML (Kapalı Döngü)  ·  Gerçek IoT Validasyonu</a:t>
+            </a:r>
+            <a:endParaRPr lang="en-US" sz="1200" dirty="0"/>
           </a:p>
         </p:txBody>
       </p:sp>
@@ -1753,7 +1753,7 @@
                 <a:ea typeface="Calibri" pitchFamily="34" charset="-122"/>
                 <a:cs typeface="Calibri" pitchFamily="34" charset="-120"/>
               </a:rPr>
-              <a:t>8.760 örnekle eğitilmiş Random Forest ML modeli</a:t>
+              <a:t>T_iç özellikli + kapalı döngü Random Forest ML modeli</a:t>
             </a:r>
             <a:endParaRPr lang="en-US" sz="1200" dirty="0"/>
           </a:p>
@@ -4027,7 +4027,7 @@
                 <a:ea typeface="Calibri" pitchFamily="34" charset="-122"/>
                 <a:cs typeface="Calibri" pitchFamily="34" charset="-120"/>
               </a:rPr>
-              <a:t>🔧  Sistem Mimarisi — 3 Katmanlı Yapı</a:t>
+              <a:t>🔧  Sistem Mimarisi — Kapalı Döngü Düzeltmeleri Dahil</a:t>
             </a:r>
             <a:endParaRPr lang="en-US" sz="2300" dirty="0"/>
           </a:p>
@@ -4066,8 +4066,8 @@
         </p:nvSpPr>
         <p:spPr>
           <a:xfrm>
-            <a:off x="228600" y="987552"/>
-            <a:ext cx="2834640" cy="402336"/>
+            <a:off x="201168" y="987552"/>
+            <a:ext cx="2816352" cy="402336"/>
           </a:xfrm>
           <a:prstGeom prst="rect">
             <a:avLst/>
@@ -4091,8 +4091,8 @@
         </p:nvSpPr>
         <p:spPr>
           <a:xfrm>
-            <a:off x="228600" y="987552"/>
-            <a:ext cx="2834640" cy="402336"/>
+            <a:off x="201168" y="987552"/>
+            <a:ext cx="2816352" cy="402336"/>
           </a:xfrm>
           <a:prstGeom prst="rect">
             <a:avLst/>
@@ -4108,7 +4108,7 @@
               <a:buNone/>
             </a:pPr>
             <a:r>
-              <a:rPr lang="en-US" sz="1350" b="1" dirty="0">
+              <a:rPr lang="en-US" sz="1250" b="1" dirty="0">
                 <a:solidFill>
                   <a:srgbClr val="FFFFFF"/>
                 </a:solidFill>
@@ -4116,9 +4116,9 @@
                 <a:ea typeface="Calibri" pitchFamily="34" charset="-122"/>
                 <a:cs typeface="Calibri" pitchFamily="34" charset="-120"/>
               </a:rPr>
-              <a:t>🌲 ML Katmanı</a:t>
-            </a:r>
-            <a:endParaRPr lang="en-US" sz="1350" dirty="0"/>
+              <a:t>🌲 ML Katmanı (Kapalı Döngü)</a:t>
+            </a:r>
+            <a:endParaRPr lang="en-US" sz="1250" dirty="0"/>
           </a:p>
         </p:txBody>
       </p:sp>
@@ -4130,8 +4130,8 @@
         </p:nvSpPr>
         <p:spPr>
           <a:xfrm>
-            <a:off x="3246120" y="987552"/>
-            <a:ext cx="2834640" cy="402336"/>
+            <a:off x="3163824" y="987552"/>
+            <a:ext cx="2816352" cy="402336"/>
           </a:xfrm>
           <a:prstGeom prst="rect">
             <a:avLst/>
@@ -4155,8 +4155,8 @@
         </p:nvSpPr>
         <p:spPr>
           <a:xfrm>
-            <a:off x="3246120" y="987552"/>
-            <a:ext cx="2834640" cy="402336"/>
+            <a:off x="3163824" y="987552"/>
+            <a:ext cx="2816352" cy="402336"/>
           </a:xfrm>
           <a:prstGeom prst="rect">
             <a:avLst/>
@@ -4172,7 +4172,7 @@
               <a:buNone/>
             </a:pPr>
             <a:r>
-              <a:rPr lang="en-US" sz="1350" b="1" dirty="0">
+              <a:rPr lang="en-US" sz="1250" b="1" dirty="0">
                 <a:solidFill>
                   <a:srgbClr val="FFFFFF"/>
                 </a:solidFill>
@@ -4182,7 +4182,7 @@
               </a:rPr>
               <a:t>🤝 Ajan Katmanı</a:t>
             </a:r>
-            <a:endParaRPr lang="en-US" sz="1350" dirty="0"/>
+            <a:endParaRPr lang="en-US" sz="1250" dirty="0"/>
           </a:p>
         </p:txBody>
       </p:sp>
@@ -4194,8 +4194,8 @@
         </p:nvSpPr>
         <p:spPr>
           <a:xfrm>
-            <a:off x="6263640" y="987552"/>
-            <a:ext cx="2834640" cy="402336"/>
+            <a:off x="6126480" y="987552"/>
+            <a:ext cx="2816352" cy="402336"/>
           </a:xfrm>
           <a:prstGeom prst="rect">
             <a:avLst/>
@@ -4219,8 +4219,8 @@
         </p:nvSpPr>
         <p:spPr>
           <a:xfrm>
-            <a:off x="6263640" y="987552"/>
-            <a:ext cx="2834640" cy="402336"/>
+            <a:off x="6126480" y="987552"/>
+            <a:ext cx="2816352" cy="402336"/>
           </a:xfrm>
           <a:prstGeom prst="rect">
             <a:avLst/>
@@ -4236,7 +4236,7 @@
               <a:buNone/>
             </a:pPr>
             <a:r>
-              <a:rPr lang="en-US" sz="1350" b="1" dirty="0">
+              <a:rPr lang="en-US" sz="1250" b="1" dirty="0">
                 <a:solidFill>
                   <a:srgbClr val="FFFFFF"/>
                 </a:solidFill>
@@ -4244,9 +4244,9 @@
                 <a:ea typeface="Calibri" pitchFamily="34" charset="-122"/>
                 <a:cs typeface="Calibri" pitchFamily="34" charset="-120"/>
               </a:rPr>
-              <a:t>🏠 Dijital İkiz</a:t>
-            </a:r>
-            <a:endParaRPr lang="en-US" sz="1350" dirty="0"/>
+              <a:t>🏠 Dijital İkiz &amp; IoT</a:t>
+            </a:r>
+            <a:endParaRPr lang="en-US" sz="1250" dirty="0"/>
           </a:p>
         </p:txBody>
       </p:sp>
@@ -4258,8 +4258,228 @@
         </p:nvSpPr>
         <p:spPr>
           <a:xfrm>
-            <a:off x="228600" y="1481328"/>
-            <a:ext cx="2834640" cy="658368"/>
+            <a:off x="201168" y="1463040"/>
+            <a:ext cx="2816352" cy="585216"/>
+          </a:xfrm>
+          <a:prstGeom prst="rect">
+            <a:avLst/>
+          </a:prstGeom>
+          <a:solidFill>
+            <a:srgbClr val="0D1E30"/>
+          </a:solidFill>
+          <a:ln w="19050">
+            <a:solidFill>
+              <a:srgbClr val="42A5F5"/>
+            </a:solidFill>
+            <a:prstDash val="solid"/>
+          </a:ln>
+        </p:spPr>
+      </p:sp>
+      <p:sp>
+        <p:nvSpPr>
+          <p:cNvPr id="12" name="Text 10"/>
+          <p:cNvSpPr/>
+          <p:nvPr/>
+        </p:nvSpPr>
+        <p:spPr>
+          <a:xfrm>
+            <a:off x="274320" y="1481328"/>
+            <a:ext cx="2706624" cy="201168"/>
+          </a:xfrm>
+          <a:prstGeom prst="rect">
+            <a:avLst/>
+          </a:prstGeom>
+          <a:noFill/>
+          <a:ln/>
+        </p:spPr>
+        <p:txBody>
+          <a:bodyPr wrap="square" rtlCol="0" anchor="ctr"/>
+          <a:lstStyle/>
+          <a:p>
+            <a:pPr indent="0" marL="0">
+              <a:buNone/>
+            </a:pPr>
+            <a:r>
+              <a:rPr lang="en-US" sz="1000" b="1" dirty="0">
+                <a:solidFill>
+                  <a:srgbClr val="42A5F5"/>
+                </a:solidFill>
+                <a:latin typeface="Calibri" pitchFamily="34" charset="0"/>
+                <a:ea typeface="Calibri" pitchFamily="34" charset="-122"/>
+                <a:cs typeface="Calibri" pitchFamily="34" charset="-120"/>
+              </a:rPr>
+              <a:t>Girdi Özellikler (5 adet):</a:t>
+            </a:r>
+            <a:endParaRPr lang="en-US" sz="1000" dirty="0"/>
+          </a:p>
+        </p:txBody>
+      </p:sp>
+      <p:sp>
+        <p:nvSpPr>
+          <p:cNvPr id="13" name="Text 11"/>
+          <p:cNvSpPr/>
+          <p:nvPr/>
+        </p:nvSpPr>
+        <p:spPr>
+          <a:xfrm>
+            <a:off x="274320" y="1664208"/>
+            <a:ext cx="2706624" cy="329184"/>
+          </a:xfrm>
+          <a:prstGeom prst="rect">
+            <a:avLst/>
+          </a:prstGeom>
+          <a:noFill/>
+          <a:ln/>
+        </p:spPr>
+        <p:txBody>
+          <a:bodyPr wrap="square" rtlCol="0" anchor="ctr"/>
+          <a:lstStyle/>
+          <a:p>
+            <a:pPr algn="ctr" indent="0" marL="0">
+              <a:buNone/>
+            </a:pPr>
+            <a:r>
+              <a:rPr lang="en-US" sz="1050" dirty="0">
+                <a:solidFill>
+                  <a:srgbClr val="FFFFFF"/>
+                </a:solidFill>
+                <a:latin typeface="Consolas" pitchFamily="34" charset="0"/>
+                <a:ea typeface="Consolas" pitchFamily="34" charset="-122"/>
+                <a:cs typeface="Consolas" pitchFamily="34" charset="-120"/>
+              </a:rPr>
+              <a:t>Saat · T_dış · T_iç · Kişi · Fiyat</a:t>
+            </a:r>
+            <a:endParaRPr lang="en-US" sz="1050" dirty="0"/>
+          </a:p>
+        </p:txBody>
+      </p:sp>
+      <p:sp>
+        <p:nvSpPr>
+          <p:cNvPr id="14" name="Shape 12"/>
+          <p:cNvSpPr/>
+          <p:nvPr/>
+        </p:nvSpPr>
+        <p:spPr>
+          <a:xfrm>
+            <a:off x="201168" y="2103120"/>
+            <a:ext cx="2816352" cy="457200"/>
+          </a:xfrm>
+          <a:prstGeom prst="rect">
+            <a:avLst/>
+          </a:prstGeom>
+          <a:solidFill>
+            <a:srgbClr val="1A3515"/>
+          </a:solidFill>
+          <a:ln w="15240">
+            <a:solidFill>
+              <a:srgbClr val="66BB6A"/>
+            </a:solidFill>
+            <a:prstDash val="solid"/>
+          </a:ln>
+        </p:spPr>
+      </p:sp>
+      <p:sp>
+        <p:nvSpPr>
+          <p:cNvPr id="15" name="Text 13"/>
+          <p:cNvSpPr/>
+          <p:nvPr/>
+        </p:nvSpPr>
+        <p:spPr>
+          <a:xfrm>
+            <a:off x="256032" y="2121408"/>
+            <a:ext cx="2724912" cy="420624"/>
+          </a:xfrm>
+          <a:prstGeom prst="rect">
+            <a:avLst/>
+          </a:prstGeom>
+          <a:noFill/>
+          <a:ln/>
+        </p:spPr>
+        <p:txBody>
+          <a:bodyPr wrap="square" rtlCol="0" anchor="ctr"/>
+          <a:lstStyle/>
+          <a:p>
+            <a:pPr algn="l" indent="0" marL="0">
+              <a:buNone/>
+            </a:pPr>
+            <a:r>
+              <a:rPr lang="en-US" sz="950" dirty="0">
+                <a:solidFill>
+                  <a:srgbClr val="66BB6A"/>
+                </a:solidFill>
+                <a:latin typeface="Calibri" pitchFamily="34" charset="0"/>
+                <a:ea typeface="Calibri" pitchFamily="34" charset="-122"/>
+                <a:cs typeface="Calibri" pitchFamily="34" charset="-120"/>
+              </a:rPr>
+              <a:t>✅  Düzeltme: T_iç özellik olarak</a:t>
+            </a:r>
+            <a:endParaRPr lang="en-US" sz="950" dirty="0"/>
+          </a:p>
+          <a:p>
+            <a:pPr algn="l" indent="0" marL="0">
+              <a:buNone/>
+            </a:pPr>
+            <a:r>
+              <a:rPr lang="en-US" sz="950" dirty="0">
+                <a:solidFill>
+                  <a:srgbClr val="66BB6A"/>
+                </a:solidFill>
+                <a:latin typeface="Calibri" pitchFamily="34" charset="0"/>
+                <a:ea typeface="Calibri" pitchFamily="34" charset="-122"/>
+                <a:cs typeface="Calibri" pitchFamily="34" charset="-120"/>
+              </a:rPr>
+              <a:t>eklendi — artık konfor durumu biliniyor</a:t>
+            </a:r>
+            <a:endParaRPr lang="en-US" sz="950" dirty="0"/>
+          </a:p>
+        </p:txBody>
+      </p:sp>
+      <p:sp>
+        <p:nvSpPr>
+          <p:cNvPr id="16" name="Text 14"/>
+          <p:cNvSpPr/>
+          <p:nvPr/>
+        </p:nvSpPr>
+        <p:spPr>
+          <a:xfrm>
+            <a:off x="1408176" y="2587752"/>
+            <a:ext cx="402336" cy="182880"/>
+          </a:xfrm>
+          <a:prstGeom prst="rect">
+            <a:avLst/>
+          </a:prstGeom>
+          <a:noFill/>
+          <a:ln/>
+        </p:spPr>
+        <p:txBody>
+          <a:bodyPr wrap="square" rtlCol="0" anchor="ctr"/>
+          <a:lstStyle/>
+          <a:p>
+            <a:pPr algn="ctr" indent="0" marL="0">
+              <a:buNone/>
+            </a:pPr>
+            <a:r>
+              <a:rPr lang="en-US" sz="1000" dirty="0">
+                <a:solidFill>
+                  <a:srgbClr val="8AB4D4"/>
+                </a:solidFill>
+              </a:rPr>
+              <a:t>▼</a:t>
+            </a:r>
+            <a:endParaRPr lang="en-US" sz="1000" dirty="0"/>
+          </a:p>
+        </p:txBody>
+      </p:sp>
+      <p:sp>
+        <p:nvSpPr>
+          <p:cNvPr id="17" name="Shape 15"/>
+          <p:cNvSpPr/>
+          <p:nvPr/>
+        </p:nvSpPr>
+        <p:spPr>
+          <a:xfrm>
+            <a:off x="201168" y="2788920"/>
+            <a:ext cx="2816352" cy="566928"/>
           </a:xfrm>
           <a:prstGeom prst="rect">
             <a:avLst/>
@@ -4277,14 +4497,14 @@
       </p:sp>
       <p:sp>
         <p:nvSpPr>
-          <p:cNvPr id="12" name="Text 10"/>
-          <p:cNvSpPr/>
-          <p:nvPr/>
-        </p:nvSpPr>
-        <p:spPr>
-          <a:xfrm>
-            <a:off x="274320" y="1536192"/>
-            <a:ext cx="2743200" cy="548640"/>
+          <p:cNvPr id="18" name="Text 16"/>
+          <p:cNvSpPr/>
+          <p:nvPr/>
+        </p:nvSpPr>
+        <p:spPr>
+          <a:xfrm>
+            <a:off x="256032" y="2807208"/>
+            <a:ext cx="2724912" cy="530352"/>
           </a:xfrm>
           <a:prstGeom prst="rect">
             <a:avLst/>
@@ -4300,7 +4520,7 @@
               <a:buNone/>
             </a:pPr>
             <a:r>
-              <a:rPr lang="en-US" sz="1150" dirty="0">
+              <a:rPr lang="en-US" sz="1100" dirty="0">
                 <a:solidFill>
                   <a:srgbClr val="FFFFFF"/>
                 </a:solidFill>
@@ -4308,16 +4528,484 @@
                 <a:ea typeface="Calibri" pitchFamily="34" charset="-122"/>
                 <a:cs typeface="Calibri" pitchFamily="34" charset="-120"/>
               </a:rPr>
-              <a:t>365 Gün × 24 Saat</a:t>
+              <a:t>Random Forest Eğitimi</a:t>
+            </a:r>
+            <a:endParaRPr lang="en-US" sz="1100" dirty="0"/>
+          </a:p>
+          <a:p>
+            <a:pPr algn="ctr" indent="0" marL="0">
+              <a:buNone/>
+            </a:pPr>
+            <a:r>
+              <a:rPr lang="en-US" sz="1100" dirty="0">
+                <a:solidFill>
+                  <a:srgbClr val="FFFFFF"/>
+                </a:solidFill>
+                <a:latin typeface="Calibri" pitchFamily="34" charset="0"/>
+                <a:ea typeface="Calibri" pitchFamily="34" charset="-122"/>
+                <a:cs typeface="Calibri" pitchFamily="34" charset="-120"/>
+              </a:rPr>
+              <a:t>(hedef T_iç konforuna göre)</a:t>
+            </a:r>
+            <a:endParaRPr lang="en-US" sz="1100" dirty="0"/>
+          </a:p>
+        </p:txBody>
+      </p:sp>
+      <p:sp>
+        <p:nvSpPr>
+          <p:cNvPr id="19" name="Text 17"/>
+          <p:cNvSpPr/>
+          <p:nvPr/>
+        </p:nvSpPr>
+        <p:spPr>
+          <a:xfrm>
+            <a:off x="1408176" y="3383280"/>
+            <a:ext cx="402336" cy="182880"/>
+          </a:xfrm>
+          <a:prstGeom prst="rect">
+            <a:avLst/>
+          </a:prstGeom>
+          <a:noFill/>
+          <a:ln/>
+        </p:spPr>
+        <p:txBody>
+          <a:bodyPr wrap="square" rtlCol="0" anchor="ctr"/>
+          <a:lstStyle/>
+          <a:p>
+            <a:pPr algn="ctr" indent="0" marL="0">
+              <a:buNone/>
+            </a:pPr>
+            <a:r>
+              <a:rPr lang="en-US" sz="1000" dirty="0">
+                <a:solidFill>
+                  <a:srgbClr val="8AB4D4"/>
+                </a:solidFill>
+              </a:rPr>
+              <a:t>▼</a:t>
+            </a:r>
+            <a:endParaRPr lang="en-US" sz="1000" dirty="0"/>
+          </a:p>
+        </p:txBody>
+      </p:sp>
+      <p:sp>
+        <p:nvSpPr>
+          <p:cNvPr id="20" name="Shape 18"/>
+          <p:cNvSpPr/>
+          <p:nvPr/>
+        </p:nvSpPr>
+        <p:spPr>
+          <a:xfrm>
+            <a:off x="201168" y="3584448"/>
+            <a:ext cx="2816352" cy="457200"/>
+          </a:xfrm>
+          <a:prstGeom prst="rect">
+            <a:avLst/>
+          </a:prstGeom>
+          <a:solidFill>
+            <a:srgbClr val="1A3515"/>
+          </a:solidFill>
+          <a:ln w="15240">
+            <a:solidFill>
+              <a:srgbClr val="66BB6A"/>
+            </a:solidFill>
+            <a:prstDash val="solid"/>
+          </a:ln>
+        </p:spPr>
+      </p:sp>
+      <p:sp>
+        <p:nvSpPr>
+          <p:cNvPr id="21" name="Text 19"/>
+          <p:cNvSpPr/>
+          <p:nvPr/>
+        </p:nvSpPr>
+        <p:spPr>
+          <a:xfrm>
+            <a:off x="256032" y="3602736"/>
+            <a:ext cx="2724912" cy="420624"/>
+          </a:xfrm>
+          <a:prstGeom prst="rect">
+            <a:avLst/>
+          </a:prstGeom>
+          <a:noFill/>
+          <a:ln/>
+        </p:spPr>
+        <p:txBody>
+          <a:bodyPr wrap="square" rtlCol="0" anchor="ctr"/>
+          <a:lstStyle/>
+          <a:p>
+            <a:pPr algn="l" indent="0" marL="0">
+              <a:buNone/>
+            </a:pPr>
+            <a:r>
+              <a:rPr lang="en-US" sz="950" dirty="0">
+                <a:solidFill>
+                  <a:srgbClr val="66BB6A"/>
+                </a:solidFill>
+                <a:latin typeface="Consolas" pitchFamily="34" charset="0"/>
+                <a:ea typeface="Consolas" pitchFamily="34" charset="-122"/>
+                <a:cs typeface="Consolas" pitchFamily="34" charset="-120"/>
+              </a:rPr>
+              <a:t>✅  Kapalı Döngü Tahmin:</a:t>
+            </a:r>
+            <a:endParaRPr lang="en-US" sz="950" dirty="0"/>
+          </a:p>
+          <a:p>
+            <a:pPr algn="l" indent="0" marL="0">
+              <a:buNone/>
+            </a:pPr>
+            <a:r>
+              <a:rPr lang="en-US" sz="950" dirty="0">
+                <a:solidFill>
+                  <a:srgbClr val="66BB6A"/>
+                </a:solidFill>
+                <a:latin typeface="Consolas" pitchFamily="34" charset="0"/>
+                <a:ea typeface="Consolas" pitchFamily="34" charset="-122"/>
+                <a:cs typeface="Consolas" pitchFamily="34" charset="-120"/>
+              </a:rPr>
+              <a:t>t→ predict(T_iç) → T_iç_yeni → t+1</a:t>
+            </a:r>
+            <a:endParaRPr lang="en-US" sz="950" dirty="0"/>
+          </a:p>
+        </p:txBody>
+      </p:sp>
+      <p:sp>
+        <p:nvSpPr>
+          <p:cNvPr id="22" name="Shape 20"/>
+          <p:cNvSpPr/>
+          <p:nvPr/>
+        </p:nvSpPr>
+        <p:spPr>
+          <a:xfrm>
+            <a:off x="201168" y="4114800"/>
+            <a:ext cx="2816352" cy="640080"/>
+          </a:xfrm>
+          <a:prstGeom prst="rect">
+            <a:avLst/>
+          </a:prstGeom>
+          <a:solidFill>
+            <a:srgbClr val="0D1E30"/>
+          </a:solidFill>
+          <a:ln w="12700">
+            <a:solidFill>
+              <a:srgbClr val="42A5F5"/>
+            </a:solidFill>
+            <a:prstDash val="solid"/>
+          </a:ln>
+        </p:spPr>
+      </p:sp>
+      <p:sp>
+        <p:nvSpPr>
+          <p:cNvPr id="23" name="Text 21"/>
+          <p:cNvSpPr/>
+          <p:nvPr/>
+        </p:nvSpPr>
+        <p:spPr>
+          <a:xfrm>
+            <a:off x="256032" y="4133088"/>
+            <a:ext cx="2724912" cy="594360"/>
+          </a:xfrm>
+          <a:prstGeom prst="rect">
+            <a:avLst/>
+          </a:prstGeom>
+          <a:noFill/>
+          <a:ln/>
+        </p:spPr>
+        <p:txBody>
+          <a:bodyPr wrap="square" rtlCol="0" anchor="ctr"/>
+          <a:lstStyle/>
+          <a:p>
+            <a:pPr algn="ctr" indent="0" marL="0">
+              <a:buNone/>
+            </a:pPr>
+            <a:r>
+              <a:rPr lang="en-US" sz="950" dirty="0">
+                <a:solidFill>
+                  <a:srgbClr val="8AB4D4"/>
+                </a:solidFill>
+                <a:latin typeface="Calibri" pitchFamily="34" charset="0"/>
+                <a:ea typeface="Calibri" pitchFamily="34" charset="-122"/>
+                <a:cs typeface="Calibri" pitchFamily="34" charset="-120"/>
+              </a:rPr>
+              <a:t>T_iç ~35%  ·  T_dış ~28%</a:t>
+            </a:r>
+            <a:endParaRPr lang="en-US" sz="950" dirty="0"/>
+          </a:p>
+          <a:p>
+            <a:pPr algn="ctr" indent="0" marL="0">
+              <a:buNone/>
+            </a:pPr>
+            <a:r>
+              <a:rPr lang="en-US" sz="950" dirty="0">
+                <a:solidFill>
+                  <a:srgbClr val="8AB4D4"/>
+                </a:solidFill>
+                <a:latin typeface="Calibri" pitchFamily="34" charset="0"/>
+                <a:ea typeface="Calibri" pitchFamily="34" charset="-122"/>
+                <a:cs typeface="Calibri" pitchFamily="34" charset="-120"/>
+              </a:rPr>
+              <a:t>Tarife ~20%  ·  Kişi ~12%  ·  Saat ~5%</a:t>
+            </a:r>
+            <a:endParaRPr lang="en-US" sz="950" dirty="0"/>
+          </a:p>
+        </p:txBody>
+      </p:sp>
+      <p:sp>
+        <p:nvSpPr>
+          <p:cNvPr id="24" name="Shape 22"/>
+          <p:cNvSpPr/>
+          <p:nvPr/>
+        </p:nvSpPr>
+        <p:spPr>
+          <a:xfrm>
+            <a:off x="3163824" y="1481328"/>
+            <a:ext cx="2816352" cy="694944"/>
+          </a:xfrm>
+          <a:prstGeom prst="rect">
+            <a:avLst/>
+          </a:prstGeom>
+          <a:solidFill>
+            <a:srgbClr val="162C47"/>
+          </a:solidFill>
+          <a:ln w="19050">
+            <a:solidFill>
+              <a:srgbClr val="42A5F5"/>
+            </a:solidFill>
+            <a:prstDash val="solid"/>
+          </a:ln>
+        </p:spPr>
+      </p:sp>
+      <p:sp>
+        <p:nvSpPr>
+          <p:cNvPr id="25" name="Shape 23"/>
+          <p:cNvSpPr/>
+          <p:nvPr/>
+        </p:nvSpPr>
+        <p:spPr>
+          <a:xfrm>
+            <a:off x="3163824" y="1481328"/>
+            <a:ext cx="64008" cy="694944"/>
+          </a:xfrm>
+          <a:prstGeom prst="rect">
+            <a:avLst/>
+          </a:prstGeom>
+          <a:solidFill>
+            <a:srgbClr val="42A5F5"/>
+          </a:solidFill>
+          <a:ln w="12700">
+            <a:solidFill>
+              <a:srgbClr val="42A5F5"/>
+            </a:solidFill>
+            <a:prstDash val="solid"/>
+          </a:ln>
+        </p:spPr>
+      </p:sp>
+      <p:sp>
+        <p:nvSpPr>
+          <p:cNvPr id="26" name="Text 24"/>
+          <p:cNvSpPr/>
+          <p:nvPr/>
+        </p:nvSpPr>
+        <p:spPr>
+          <a:xfrm>
+            <a:off x="3273552" y="1536192"/>
+            <a:ext cx="2651760" cy="256032"/>
+          </a:xfrm>
+          <a:prstGeom prst="rect">
+            <a:avLst/>
+          </a:prstGeom>
+          <a:noFill/>
+          <a:ln/>
+        </p:spPr>
+        <p:txBody>
+          <a:bodyPr wrap="square" rtlCol="0" anchor="ctr"/>
+          <a:lstStyle/>
+          <a:p>
+            <a:pPr indent="0" marL="0">
+              <a:buNone/>
+            </a:pPr>
+            <a:r>
+              <a:rPr lang="en-US" sz="1150" b="1" dirty="0">
+                <a:solidFill>
+                  <a:srgbClr val="FFFFFF"/>
+                </a:solidFill>
+                <a:latin typeface="Calibri" pitchFamily="34" charset="0"/>
+                <a:ea typeface="Calibri" pitchFamily="34" charset="-122"/>
+                <a:cs typeface="Calibri" pitchFamily="34" charset="-120"/>
+              </a:rPr>
+              <a:t>🔵  Konfor Ajanı</a:t>
             </a:r>
             <a:endParaRPr lang="en-US" sz="1150" dirty="0"/>
           </a:p>
+        </p:txBody>
+      </p:sp>
+      <p:sp>
+        <p:nvSpPr>
+          <p:cNvPr id="27" name="Text 25"/>
+          <p:cNvSpPr/>
+          <p:nvPr/>
+        </p:nvSpPr>
+        <p:spPr>
+          <a:xfrm>
+            <a:off x="3273552" y="1792224"/>
+            <a:ext cx="2651760" cy="329184"/>
+          </a:xfrm>
+          <a:prstGeom prst="rect">
+            <a:avLst/>
+          </a:prstGeom>
+          <a:noFill/>
+          <a:ln/>
+        </p:spPr>
+        <p:txBody>
+          <a:bodyPr wrap="square" rtlCol="0" anchor="ctr"/>
+          <a:lstStyle/>
+          <a:p>
+            <a:pPr indent="0" marL="0">
+              <a:buNone/>
+            </a:pPr>
+            <a:r>
+              <a:rPr lang="en-US" sz="950" dirty="0">
+                <a:solidFill>
+                  <a:srgbClr val="8AB4D4"/>
+                </a:solidFill>
+                <a:latin typeface="Calibri" pitchFamily="34" charset="0"/>
+                <a:ea typeface="Calibri" pitchFamily="34" charset="-122"/>
+                <a:cs typeface="Calibri" pitchFamily="34" charset="-120"/>
+              </a:rPr>
+              <a:t>T_iç &gt; 26°C → güç artır</a:t>
+            </a:r>
+            <a:endParaRPr lang="en-US" sz="950" dirty="0"/>
+          </a:p>
+          <a:p>
+            <a:pPr indent="0" marL="0">
+              <a:buNone/>
+            </a:pPr>
+            <a:r>
+              <a:rPr lang="en-US" sz="950" dirty="0">
+                <a:solidFill>
+                  <a:srgbClr val="8AB4D4"/>
+                </a:solidFill>
+                <a:latin typeface="Calibri" pitchFamily="34" charset="0"/>
+                <a:ea typeface="Calibri" pitchFamily="34" charset="-122"/>
+                <a:cs typeface="Calibri" pitchFamily="34" charset="-120"/>
+              </a:rPr>
+              <a:t>(Dijital İkiz'den T_iç alır)</a:t>
+            </a:r>
+            <a:endParaRPr lang="en-US" sz="950" dirty="0"/>
+          </a:p>
+        </p:txBody>
+      </p:sp>
+      <p:sp>
+        <p:nvSpPr>
+          <p:cNvPr id="28" name="Text 26"/>
+          <p:cNvSpPr/>
+          <p:nvPr/>
+        </p:nvSpPr>
+        <p:spPr>
+          <a:xfrm>
+            <a:off x="4370832" y="2194560"/>
+            <a:ext cx="402336" cy="128016"/>
+          </a:xfrm>
+          <a:prstGeom prst="rect">
+            <a:avLst/>
+          </a:prstGeom>
+          <a:noFill/>
+          <a:ln/>
+        </p:spPr>
+        <p:txBody>
+          <a:bodyPr wrap="square" rtlCol="0" anchor="ctr"/>
+          <a:lstStyle/>
           <a:p>
             <a:pPr algn="ctr" indent="0" marL="0">
               <a:buNone/>
             </a:pPr>
             <a:r>
-              <a:rPr lang="en-US" sz="1150" dirty="0">
+              <a:rPr lang="en-US" sz="900" dirty="0">
+                <a:solidFill>
+                  <a:srgbClr val="8AB4D4"/>
+                </a:solidFill>
+              </a:rPr>
+              <a:t>▼</a:t>
+            </a:r>
+            <a:endParaRPr lang="en-US" sz="900" dirty="0"/>
+          </a:p>
+        </p:txBody>
+      </p:sp>
+      <p:sp>
+        <p:nvSpPr>
+          <p:cNvPr id="29" name="Shape 27"/>
+          <p:cNvSpPr/>
+          <p:nvPr/>
+        </p:nvSpPr>
+        <p:spPr>
+          <a:xfrm>
+            <a:off x="3163824" y="2304288"/>
+            <a:ext cx="2816352" cy="694944"/>
+          </a:xfrm>
+          <a:prstGeom prst="rect">
+            <a:avLst/>
+          </a:prstGeom>
+          <a:solidFill>
+            <a:srgbClr val="162C47"/>
+          </a:solidFill>
+          <a:ln w="19050">
+            <a:solidFill>
+              <a:srgbClr val="66BB6A"/>
+            </a:solidFill>
+            <a:prstDash val="solid"/>
+          </a:ln>
+        </p:spPr>
+      </p:sp>
+      <p:sp>
+        <p:nvSpPr>
+          <p:cNvPr id="30" name="Shape 28"/>
+          <p:cNvSpPr/>
+          <p:nvPr/>
+        </p:nvSpPr>
+        <p:spPr>
+          <a:xfrm>
+            <a:off x="3163824" y="2304288"/>
+            <a:ext cx="64008" cy="694944"/>
+          </a:xfrm>
+          <a:prstGeom prst="rect">
+            <a:avLst/>
+          </a:prstGeom>
+          <a:solidFill>
+            <a:srgbClr val="66BB6A"/>
+          </a:solidFill>
+          <a:ln w="12700">
+            <a:solidFill>
+              <a:srgbClr val="66BB6A"/>
+            </a:solidFill>
+            <a:prstDash val="solid"/>
+          </a:ln>
+        </p:spPr>
+      </p:sp>
+      <p:sp>
+        <p:nvSpPr>
+          <p:cNvPr id="31" name="Text 29"/>
+          <p:cNvSpPr/>
+          <p:nvPr/>
+        </p:nvSpPr>
+        <p:spPr>
+          <a:xfrm>
+            <a:off x="3273552" y="2359152"/>
+            <a:ext cx="2651760" cy="256032"/>
+          </a:xfrm>
+          <a:prstGeom prst="rect">
+            <a:avLst/>
+          </a:prstGeom>
+          <a:noFill/>
+          <a:ln/>
+        </p:spPr>
+        <p:txBody>
+          <a:bodyPr wrap="square" rtlCol="0" anchor="ctr"/>
+          <a:lstStyle/>
+          <a:p>
+            <a:pPr indent="0" marL="0">
+              <a:buNone/>
+            </a:pPr>
+            <a:r>
+              <a:rPr lang="en-US" sz="1150" b="1" dirty="0">
                 <a:solidFill>
                   <a:srgbClr val="FFFFFF"/>
                 </a:solidFill>
@@ -4325,7 +5013,7 @@
                 <a:ea typeface="Calibri" pitchFamily="34" charset="-122"/>
                 <a:cs typeface="Calibri" pitchFamily="34" charset="-120"/>
               </a:rPr>
-              <a:t>Sentetik Veri</a:t>
+              <a:t>🟢  Maliyet Ajanı</a:t>
             </a:r>
             <a:endParaRPr lang="en-US" sz="1150" dirty="0"/>
           </a:p>
@@ -4333,14 +5021,53 @@
       </p:sp>
       <p:sp>
         <p:nvSpPr>
-          <p:cNvPr id="13" name="Text 11"/>
-          <p:cNvSpPr/>
-          <p:nvPr/>
-        </p:nvSpPr>
-        <p:spPr>
-          <a:xfrm>
-            <a:off x="1444752" y="2167128"/>
-            <a:ext cx="402336" cy="201168"/>
+          <p:cNvPr id="32" name="Text 30"/>
+          <p:cNvSpPr/>
+          <p:nvPr/>
+        </p:nvSpPr>
+        <p:spPr>
+          <a:xfrm>
+            <a:off x="3273552" y="2615184"/>
+            <a:ext cx="2651760" cy="329184"/>
+          </a:xfrm>
+          <a:prstGeom prst="rect">
+            <a:avLst/>
+          </a:prstGeom>
+          <a:noFill/>
+          <a:ln/>
+        </p:spPr>
+        <p:txBody>
+          <a:bodyPr wrap="square" rtlCol="0" anchor="ctr"/>
+          <a:lstStyle/>
+          <a:p>
+            <a:pPr indent="0" marL="0">
+              <a:buNone/>
+            </a:pPr>
+            <a:r>
+              <a:rPr lang="en-US" sz="950" dirty="0">
+                <a:solidFill>
+                  <a:srgbClr val="8AB4D4"/>
+                </a:solidFill>
+                <a:latin typeface="Calibri" pitchFamily="34" charset="0"/>
+                <a:ea typeface="Calibri" pitchFamily="34" charset="-122"/>
+                <a:cs typeface="Calibri" pitchFamily="34" charset="-120"/>
+              </a:rPr>
+              <a:t>Pik tarife → güç düşür</a:t>
+            </a:r>
+            <a:endParaRPr lang="en-US" sz="950" dirty="0"/>
+          </a:p>
+        </p:txBody>
+      </p:sp>
+      <p:sp>
+        <p:nvSpPr>
+          <p:cNvPr id="33" name="Text 31"/>
+          <p:cNvSpPr/>
+          <p:nvPr/>
+        </p:nvSpPr>
+        <p:spPr>
+          <a:xfrm>
+            <a:off x="4370832" y="3017520"/>
+            <a:ext cx="402336" cy="128016"/>
           </a:xfrm>
           <a:prstGeom prst="rect">
             <a:avLst/>
@@ -4356,27 +5083,27 @@
               <a:buNone/>
             </a:pPr>
             <a:r>
-              <a:rPr lang="en-US" sz="1000" dirty="0">
+              <a:rPr lang="en-US" sz="900" dirty="0">
                 <a:solidFill>
                   <a:srgbClr val="8AB4D4"/>
                 </a:solidFill>
               </a:rPr>
               <a:t>▼</a:t>
             </a:r>
-            <a:endParaRPr lang="en-US" sz="1000" dirty="0"/>
-          </a:p>
-        </p:txBody>
-      </p:sp>
-      <p:sp>
-        <p:nvSpPr>
-          <p:cNvPr id="14" name="Shape 12"/>
-          <p:cNvSpPr/>
-          <p:nvPr/>
-        </p:nvSpPr>
-        <p:spPr>
-          <a:xfrm>
-            <a:off x="228600" y="2414016"/>
-            <a:ext cx="2834640" cy="658368"/>
+            <a:endParaRPr lang="en-US" sz="900" dirty="0"/>
+          </a:p>
+        </p:txBody>
+      </p:sp>
+      <p:sp>
+        <p:nvSpPr>
+          <p:cNvPr id="34" name="Shape 32"/>
+          <p:cNvSpPr/>
+          <p:nvPr/>
+        </p:nvSpPr>
+        <p:spPr>
+          <a:xfrm>
+            <a:off x="3163824" y="3127248"/>
+            <a:ext cx="2816352" cy="694944"/>
           </a:xfrm>
           <a:prstGeom prst="rect">
             <a:avLst/>
@@ -4386,38 +5113,63 @@
           </a:solidFill>
           <a:ln w="19050">
             <a:solidFill>
-              <a:srgbClr val="42A5F5"/>
-            </a:solidFill>
-            <a:prstDash val="solid"/>
-          </a:ln>
-        </p:spPr>
-      </p:sp>
-      <p:sp>
-        <p:nvSpPr>
-          <p:cNvPr id="15" name="Text 13"/>
-          <p:cNvSpPr/>
-          <p:nvPr/>
-        </p:nvSpPr>
-        <p:spPr>
-          <a:xfrm>
-            <a:off x="274320" y="2468880"/>
-            <a:ext cx="2743200" cy="548640"/>
-          </a:xfrm>
-          <a:prstGeom prst="rect">
-            <a:avLst/>
-          </a:prstGeom>
-          <a:noFill/>
-          <a:ln/>
-        </p:spPr>
-        <p:txBody>
-          <a:bodyPr wrap="square" rtlCol="0" anchor="ctr"/>
-          <a:lstStyle/>
-          <a:p>
-            <a:pPr algn="ctr" indent="0" marL="0">
-              <a:buNone/>
-            </a:pPr>
-            <a:r>
-              <a:rPr lang="en-US" sz="1150" dirty="0">
+              <a:srgbClr val="F59E0B"/>
+            </a:solidFill>
+            <a:prstDash val="solid"/>
+          </a:ln>
+        </p:spPr>
+      </p:sp>
+      <p:sp>
+        <p:nvSpPr>
+          <p:cNvPr id="35" name="Shape 33"/>
+          <p:cNvSpPr/>
+          <p:nvPr/>
+        </p:nvSpPr>
+        <p:spPr>
+          <a:xfrm>
+            <a:off x="3163824" y="3127248"/>
+            <a:ext cx="64008" cy="694944"/>
+          </a:xfrm>
+          <a:prstGeom prst="rect">
+            <a:avLst/>
+          </a:prstGeom>
+          <a:solidFill>
+            <a:srgbClr val="F59E0B"/>
+          </a:solidFill>
+          <a:ln w="12700">
+            <a:solidFill>
+              <a:srgbClr val="F59E0B"/>
+            </a:solidFill>
+            <a:prstDash val="solid"/>
+          </a:ln>
+        </p:spPr>
+      </p:sp>
+      <p:sp>
+        <p:nvSpPr>
+          <p:cNvPr id="36" name="Text 34"/>
+          <p:cNvSpPr/>
+          <p:nvPr/>
+        </p:nvSpPr>
+        <p:spPr>
+          <a:xfrm>
+            <a:off x="3273552" y="3182112"/>
+            <a:ext cx="2651760" cy="256032"/>
+          </a:xfrm>
+          <a:prstGeom prst="rect">
+            <a:avLst/>
+          </a:prstGeom>
+          <a:noFill/>
+          <a:ln/>
+        </p:spPr>
+        <p:txBody>
+          <a:bodyPr wrap="square" rtlCol="0" anchor="ctr"/>
+          <a:lstStyle/>
+          <a:p>
+            <a:pPr indent="0" marL="0">
+              <a:buNone/>
+            </a:pPr>
+            <a:r>
+              <a:rPr lang="en-US" sz="1150" b="1" dirty="0">
                 <a:solidFill>
                   <a:srgbClr val="FFFFFF"/>
                 </a:solidFill>
@@ -4425,693 +5177,61 @@
                 <a:ea typeface="Calibri" pitchFamily="34" charset="-122"/>
                 <a:cs typeface="Calibri" pitchFamily="34" charset="-120"/>
               </a:rPr>
-              <a:t>Random Forest</a:t>
+              <a:t>🟠  Sürd. Ajanı</a:t>
             </a:r>
             <a:endParaRPr lang="en-US" sz="1150" dirty="0"/>
           </a:p>
-          <a:p>
-            <a:pPr algn="ctr" indent="0" marL="0">
-              <a:buNone/>
-            </a:pPr>
-            <a:r>
-              <a:rPr lang="en-US" sz="1150" dirty="0">
-                <a:solidFill>
-                  <a:srgbClr val="FFFFFF"/>
-                </a:solidFill>
-                <a:latin typeface="Calibri" pitchFamily="34" charset="0"/>
-                <a:ea typeface="Calibri" pitchFamily="34" charset="-122"/>
-                <a:cs typeface="Calibri" pitchFamily="34" charset="-120"/>
-              </a:rPr>
-              <a:t>Eğitimi</a:t>
-            </a:r>
-            <a:endParaRPr lang="en-US" sz="1150" dirty="0"/>
-          </a:p>
-        </p:txBody>
-      </p:sp>
-      <p:sp>
-        <p:nvSpPr>
-          <p:cNvPr id="16" name="Text 14"/>
-          <p:cNvSpPr/>
-          <p:nvPr/>
-        </p:nvSpPr>
-        <p:spPr>
-          <a:xfrm>
-            <a:off x="1444752" y="3099816"/>
-            <a:ext cx="402336" cy="201168"/>
-          </a:xfrm>
-          <a:prstGeom prst="rect">
-            <a:avLst/>
-          </a:prstGeom>
-          <a:noFill/>
-          <a:ln/>
-        </p:spPr>
-        <p:txBody>
-          <a:bodyPr wrap="square" rtlCol="0" anchor="ctr"/>
-          <a:lstStyle/>
-          <a:p>
-            <a:pPr algn="ctr" indent="0" marL="0">
-              <a:buNone/>
-            </a:pPr>
-            <a:r>
-              <a:rPr lang="en-US" sz="1000" dirty="0">
+        </p:txBody>
+      </p:sp>
+      <p:sp>
+        <p:nvSpPr>
+          <p:cNvPr id="37" name="Text 35"/>
+          <p:cNvSpPr/>
+          <p:nvPr/>
+        </p:nvSpPr>
+        <p:spPr>
+          <a:xfrm>
+            <a:off x="3273552" y="3438144"/>
+            <a:ext cx="2651760" cy="329184"/>
+          </a:xfrm>
+          <a:prstGeom prst="rect">
+            <a:avLst/>
+          </a:prstGeom>
+          <a:noFill/>
+          <a:ln/>
+        </p:spPr>
+        <p:txBody>
+          <a:bodyPr wrap="square" rtlCol="0" anchor="ctr"/>
+          <a:lstStyle/>
+          <a:p>
+            <a:pPr indent="0" marL="0">
+              <a:buNone/>
+            </a:pPr>
+            <a:r>
+              <a:rPr lang="en-US" sz="950" dirty="0">
                 <a:solidFill>
                   <a:srgbClr val="8AB4D4"/>
                 </a:solidFill>
-              </a:rPr>
-              <a:t>▼</a:t>
-            </a:r>
-            <a:endParaRPr lang="en-US" sz="1000" dirty="0"/>
-          </a:p>
-        </p:txBody>
-      </p:sp>
-      <p:sp>
-        <p:nvSpPr>
-          <p:cNvPr id="17" name="Shape 15"/>
-          <p:cNvSpPr/>
-          <p:nvPr/>
-        </p:nvSpPr>
-        <p:spPr>
-          <a:xfrm>
-            <a:off x="228600" y="3346704"/>
-            <a:ext cx="2834640" cy="658368"/>
-          </a:xfrm>
-          <a:prstGeom prst="rect">
-            <a:avLst/>
-          </a:prstGeom>
-          <a:solidFill>
-            <a:srgbClr val="162C47"/>
-          </a:solidFill>
-          <a:ln w="19050">
-            <a:solidFill>
-              <a:srgbClr val="42A5F5"/>
-            </a:solidFill>
-            <a:prstDash val="solid"/>
-          </a:ln>
-        </p:spPr>
-      </p:sp>
-      <p:sp>
-        <p:nvSpPr>
-          <p:cNvPr id="18" name="Text 16"/>
-          <p:cNvSpPr/>
-          <p:nvPr/>
-        </p:nvSpPr>
-        <p:spPr>
-          <a:xfrm>
-            <a:off x="274320" y="3401568"/>
-            <a:ext cx="2743200" cy="548640"/>
-          </a:xfrm>
-          <a:prstGeom prst="rect">
-            <a:avLst/>
-          </a:prstGeom>
-          <a:noFill/>
-          <a:ln/>
-        </p:spPr>
-        <p:txBody>
-          <a:bodyPr wrap="square" rtlCol="0" anchor="ctr"/>
-          <a:lstStyle/>
-          <a:p>
-            <a:pPr algn="ctr" indent="0" marL="0">
-              <a:buNone/>
-            </a:pPr>
-            <a:r>
-              <a:rPr lang="en-US" sz="1150" dirty="0">
-                <a:solidFill>
-                  <a:srgbClr val="FFFFFF"/>
-                </a:solidFill>
-                <a:latin typeface="Calibri" pitchFamily="34" charset="0"/>
-                <a:ea typeface="Calibri" pitchFamily="34" charset="-122"/>
-                <a:cs typeface="Calibri" pitchFamily="34" charset="-120"/>
-              </a:rPr>
-              <a:t>Optimal Güç</a:t>
-            </a:r>
-            <a:endParaRPr lang="en-US" sz="1150" dirty="0"/>
-          </a:p>
-          <a:p>
-            <a:pPr algn="ctr" indent="0" marL="0">
-              <a:buNone/>
-            </a:pPr>
-            <a:r>
-              <a:rPr lang="en-US" sz="1150" dirty="0">
-                <a:solidFill>
-                  <a:srgbClr val="FFFFFF"/>
-                </a:solidFill>
-                <a:latin typeface="Calibri" pitchFamily="34" charset="0"/>
-                <a:ea typeface="Calibri" pitchFamily="34" charset="-122"/>
-                <a:cs typeface="Calibri" pitchFamily="34" charset="-120"/>
-              </a:rPr>
-              <a:t>Tahmini (kW)</a:t>
-            </a:r>
-            <a:endParaRPr lang="en-US" sz="1150" dirty="0"/>
-          </a:p>
-        </p:txBody>
-      </p:sp>
-      <p:sp>
-        <p:nvSpPr>
-          <p:cNvPr id="19" name="Shape 17"/>
-          <p:cNvSpPr/>
-          <p:nvPr/>
-        </p:nvSpPr>
-        <p:spPr>
-          <a:xfrm>
-            <a:off x="228600" y="4297680"/>
-            <a:ext cx="2834640" cy="640080"/>
-          </a:xfrm>
-          <a:prstGeom prst="rect">
-            <a:avLst/>
-          </a:prstGeom>
-          <a:solidFill>
-            <a:srgbClr val="0D1E30"/>
-          </a:solidFill>
-          <a:ln w="12700">
-            <a:solidFill>
-              <a:srgbClr val="42A5F5"/>
-            </a:solidFill>
-            <a:prstDash val="solid"/>
-          </a:ln>
-        </p:spPr>
-      </p:sp>
-      <p:sp>
-        <p:nvSpPr>
-          <p:cNvPr id="20" name="Text 18"/>
-          <p:cNvSpPr/>
-          <p:nvPr/>
-        </p:nvSpPr>
-        <p:spPr>
-          <a:xfrm>
-            <a:off x="274320" y="4315968"/>
-            <a:ext cx="2743200" cy="594360"/>
-          </a:xfrm>
-          <a:prstGeom prst="rect">
-            <a:avLst/>
-          </a:prstGeom>
-          <a:noFill/>
-          <a:ln/>
-        </p:spPr>
-        <p:txBody>
-          <a:bodyPr wrap="square" rtlCol="0" anchor="ctr"/>
-          <a:lstStyle/>
-          <a:p>
-            <a:pPr algn="ctr" indent="0" marL="0">
-              <a:buNone/>
-            </a:pPr>
-            <a:r>
-              <a:rPr lang="en-US" sz="1000" dirty="0">
-                <a:solidFill>
-                  <a:srgbClr val="8AB4D4"/>
-                </a:solidFill>
-                <a:latin typeface="Calibri" pitchFamily="34" charset="0"/>
-                <a:ea typeface="Calibri" pitchFamily="34" charset="-122"/>
-                <a:cs typeface="Calibri" pitchFamily="34" charset="-120"/>
-              </a:rPr>
-              <a:t>Sıcaklık 42%  ·  Tarife 31%</a:t>
-            </a:r>
-            <a:endParaRPr lang="en-US" sz="1000" dirty="0"/>
-          </a:p>
-          <a:p>
-            <a:pPr algn="ctr" indent="0" marL="0">
-              <a:buNone/>
-            </a:pPr>
-            <a:r>
-              <a:rPr lang="en-US" sz="1000" dirty="0">
-                <a:solidFill>
-                  <a:srgbClr val="8AB4D4"/>
-                </a:solidFill>
-                <a:latin typeface="Calibri" pitchFamily="34" charset="0"/>
-                <a:ea typeface="Calibri" pitchFamily="34" charset="-122"/>
-                <a:cs typeface="Calibri" pitchFamily="34" charset="-120"/>
-              </a:rPr>
-              <a:t>Kişi 18%  ·  Saat 9%</a:t>
-            </a:r>
-            <a:endParaRPr lang="en-US" sz="1000" dirty="0"/>
-          </a:p>
-        </p:txBody>
-      </p:sp>
-      <p:sp>
-        <p:nvSpPr>
-          <p:cNvPr id="21" name="Shape 19"/>
-          <p:cNvSpPr/>
-          <p:nvPr/>
-        </p:nvSpPr>
-        <p:spPr>
-          <a:xfrm>
-            <a:off x="3246120" y="1481328"/>
-            <a:ext cx="2834640" cy="621792"/>
-          </a:xfrm>
-          <a:prstGeom prst="rect">
-            <a:avLst/>
-          </a:prstGeom>
-          <a:solidFill>
-            <a:srgbClr val="162C47"/>
-          </a:solidFill>
-          <a:ln w="19050">
-            <a:solidFill>
-              <a:srgbClr val="42A5F5"/>
-            </a:solidFill>
-            <a:prstDash val="solid"/>
-          </a:ln>
-        </p:spPr>
-      </p:sp>
-      <p:sp>
-        <p:nvSpPr>
-          <p:cNvPr id="22" name="Shape 20"/>
-          <p:cNvSpPr/>
-          <p:nvPr/>
-        </p:nvSpPr>
-        <p:spPr>
-          <a:xfrm>
-            <a:off x="3246120" y="1481328"/>
-            <a:ext cx="64008" cy="621792"/>
-          </a:xfrm>
-          <a:prstGeom prst="rect">
-            <a:avLst/>
-          </a:prstGeom>
-          <a:solidFill>
-            <a:srgbClr val="42A5F5"/>
-          </a:solidFill>
-          <a:ln w="12700">
-            <a:solidFill>
-              <a:srgbClr val="42A5F5"/>
-            </a:solidFill>
-            <a:prstDash val="solid"/>
-          </a:ln>
-        </p:spPr>
-      </p:sp>
-      <p:sp>
-        <p:nvSpPr>
-          <p:cNvPr id="23" name="Text 21"/>
-          <p:cNvSpPr/>
-          <p:nvPr/>
-        </p:nvSpPr>
-        <p:spPr>
-          <a:xfrm>
-            <a:off x="3364992" y="1517904"/>
-            <a:ext cx="2651760" cy="256032"/>
-          </a:xfrm>
-          <a:prstGeom prst="rect">
-            <a:avLst/>
-          </a:prstGeom>
-          <a:noFill/>
-          <a:ln/>
-        </p:spPr>
-        <p:txBody>
-          <a:bodyPr wrap="square" rtlCol="0" anchor="ctr"/>
-          <a:lstStyle/>
-          <a:p>
-            <a:pPr indent="0" marL="0">
-              <a:buNone/>
-            </a:pPr>
-            <a:r>
-              <a:rPr lang="en-US" sz="1150" b="1" dirty="0">
-                <a:solidFill>
-                  <a:srgbClr val="FFFFFF"/>
-                </a:solidFill>
-                <a:latin typeface="Calibri" pitchFamily="34" charset="0"/>
-                <a:ea typeface="Calibri" pitchFamily="34" charset="-122"/>
-                <a:cs typeface="Calibri" pitchFamily="34" charset="-120"/>
-              </a:rPr>
-              <a:t>🔵  Konfor Ajanı</a:t>
-            </a:r>
-            <a:endParaRPr lang="en-US" sz="1150" dirty="0"/>
-          </a:p>
-        </p:txBody>
-      </p:sp>
-      <p:sp>
-        <p:nvSpPr>
-          <p:cNvPr id="24" name="Text 22"/>
-          <p:cNvSpPr/>
-          <p:nvPr/>
-        </p:nvSpPr>
-        <p:spPr>
-          <a:xfrm>
-            <a:off x="3364992" y="1773936"/>
-            <a:ext cx="2651760" cy="256032"/>
-          </a:xfrm>
-          <a:prstGeom prst="rect">
-            <a:avLst/>
-          </a:prstGeom>
-          <a:noFill/>
-          <a:ln/>
-        </p:spPr>
-        <p:txBody>
-          <a:bodyPr wrap="square" rtlCol="0" anchor="ctr"/>
-          <a:lstStyle/>
-          <a:p>
-            <a:pPr indent="0" marL="0">
-              <a:buNone/>
-            </a:pPr>
-            <a:r>
-              <a:rPr lang="en-US" sz="1050" dirty="0">
-                <a:solidFill>
-                  <a:srgbClr val="8AB4D4"/>
-                </a:solidFill>
-                <a:latin typeface="Calibri" pitchFamily="34" charset="0"/>
-                <a:ea typeface="Calibri" pitchFamily="34" charset="-122"/>
-                <a:cs typeface="Calibri" pitchFamily="34" charset="-120"/>
-              </a:rPr>
-              <a:t>T_iç &gt; 26°C → güç artır</a:t>
-            </a:r>
-            <a:endParaRPr lang="en-US" sz="1050" dirty="0"/>
-          </a:p>
-        </p:txBody>
-      </p:sp>
-      <p:sp>
-        <p:nvSpPr>
-          <p:cNvPr id="25" name="Text 23"/>
-          <p:cNvSpPr/>
-          <p:nvPr/>
-        </p:nvSpPr>
-        <p:spPr>
-          <a:xfrm>
-            <a:off x="4462272" y="2121408"/>
-            <a:ext cx="402336" cy="182880"/>
-          </a:xfrm>
-          <a:prstGeom prst="rect">
-            <a:avLst/>
-          </a:prstGeom>
-          <a:noFill/>
-          <a:ln/>
-        </p:spPr>
-        <p:txBody>
-          <a:bodyPr wrap="square" rtlCol="0" anchor="ctr"/>
-          <a:lstStyle/>
-          <a:p>
-            <a:pPr algn="ctr" indent="0" marL="0">
-              <a:buNone/>
-            </a:pPr>
-            <a:r>
-              <a:rPr lang="en-US" sz="900" dirty="0">
-                <a:solidFill>
-                  <a:srgbClr val="8AB4D4"/>
-                </a:solidFill>
-              </a:rPr>
-              <a:t>▼</a:t>
-            </a:r>
-            <a:endParaRPr lang="en-US" sz="900" dirty="0"/>
-          </a:p>
-        </p:txBody>
-      </p:sp>
-      <p:sp>
-        <p:nvSpPr>
-          <p:cNvPr id="26" name="Shape 24"/>
-          <p:cNvSpPr/>
-          <p:nvPr/>
-        </p:nvSpPr>
-        <p:spPr>
-          <a:xfrm>
-            <a:off x="3246120" y="2231136"/>
-            <a:ext cx="2834640" cy="621792"/>
-          </a:xfrm>
-          <a:prstGeom prst="rect">
-            <a:avLst/>
-          </a:prstGeom>
-          <a:solidFill>
-            <a:srgbClr val="162C47"/>
-          </a:solidFill>
-          <a:ln w="19050">
-            <a:solidFill>
-              <a:srgbClr val="66BB6A"/>
-            </a:solidFill>
-            <a:prstDash val="solid"/>
-          </a:ln>
-        </p:spPr>
-      </p:sp>
-      <p:sp>
-        <p:nvSpPr>
-          <p:cNvPr id="27" name="Shape 25"/>
-          <p:cNvSpPr/>
-          <p:nvPr/>
-        </p:nvSpPr>
-        <p:spPr>
-          <a:xfrm>
-            <a:off x="3246120" y="2231136"/>
-            <a:ext cx="64008" cy="621792"/>
-          </a:xfrm>
-          <a:prstGeom prst="rect">
-            <a:avLst/>
-          </a:prstGeom>
-          <a:solidFill>
-            <a:srgbClr val="66BB6A"/>
-          </a:solidFill>
-          <a:ln w="12700">
-            <a:solidFill>
-              <a:srgbClr val="66BB6A"/>
-            </a:solidFill>
-            <a:prstDash val="solid"/>
-          </a:ln>
-        </p:spPr>
-      </p:sp>
-      <p:sp>
-        <p:nvSpPr>
-          <p:cNvPr id="28" name="Text 26"/>
-          <p:cNvSpPr/>
-          <p:nvPr/>
-        </p:nvSpPr>
-        <p:spPr>
-          <a:xfrm>
-            <a:off x="3364992" y="2267712"/>
-            <a:ext cx="2651760" cy="256032"/>
-          </a:xfrm>
-          <a:prstGeom prst="rect">
-            <a:avLst/>
-          </a:prstGeom>
-          <a:noFill/>
-          <a:ln/>
-        </p:spPr>
-        <p:txBody>
-          <a:bodyPr wrap="square" rtlCol="0" anchor="ctr"/>
-          <a:lstStyle/>
-          <a:p>
-            <a:pPr indent="0" marL="0">
-              <a:buNone/>
-            </a:pPr>
-            <a:r>
-              <a:rPr lang="en-US" sz="1150" b="1" dirty="0">
-                <a:solidFill>
-                  <a:srgbClr val="FFFFFF"/>
-                </a:solidFill>
-                <a:latin typeface="Calibri" pitchFamily="34" charset="0"/>
-                <a:ea typeface="Calibri" pitchFamily="34" charset="-122"/>
-                <a:cs typeface="Calibri" pitchFamily="34" charset="-120"/>
-              </a:rPr>
-              <a:t>🟢  Maliyet Ajanı</a:t>
-            </a:r>
-            <a:endParaRPr lang="en-US" sz="1150" dirty="0"/>
-          </a:p>
-        </p:txBody>
-      </p:sp>
-      <p:sp>
-        <p:nvSpPr>
-          <p:cNvPr id="29" name="Text 27"/>
-          <p:cNvSpPr/>
-          <p:nvPr/>
-        </p:nvSpPr>
-        <p:spPr>
-          <a:xfrm>
-            <a:off x="3364992" y="2523744"/>
-            <a:ext cx="2651760" cy="256032"/>
-          </a:xfrm>
-          <a:prstGeom prst="rect">
-            <a:avLst/>
-          </a:prstGeom>
-          <a:noFill/>
-          <a:ln/>
-        </p:spPr>
-        <p:txBody>
-          <a:bodyPr wrap="square" rtlCol="0" anchor="ctr"/>
-          <a:lstStyle/>
-          <a:p>
-            <a:pPr indent="0" marL="0">
-              <a:buNone/>
-            </a:pPr>
-            <a:r>
-              <a:rPr lang="en-US" sz="1050" dirty="0">
-                <a:solidFill>
-                  <a:srgbClr val="8AB4D4"/>
-                </a:solidFill>
-                <a:latin typeface="Calibri" pitchFamily="34" charset="0"/>
-                <a:ea typeface="Calibri" pitchFamily="34" charset="-122"/>
-                <a:cs typeface="Calibri" pitchFamily="34" charset="-120"/>
-              </a:rPr>
-              <a:t>Pik tarife → güç düşür</a:t>
-            </a:r>
-            <a:endParaRPr lang="en-US" sz="1050" dirty="0"/>
-          </a:p>
-        </p:txBody>
-      </p:sp>
-      <p:sp>
-        <p:nvSpPr>
-          <p:cNvPr id="30" name="Text 28"/>
-          <p:cNvSpPr/>
-          <p:nvPr/>
-        </p:nvSpPr>
-        <p:spPr>
-          <a:xfrm>
-            <a:off x="4462272" y="2871216"/>
-            <a:ext cx="402336" cy="182880"/>
-          </a:xfrm>
-          <a:prstGeom prst="rect">
-            <a:avLst/>
-          </a:prstGeom>
-          <a:noFill/>
-          <a:ln/>
-        </p:spPr>
-        <p:txBody>
-          <a:bodyPr wrap="square" rtlCol="0" anchor="ctr"/>
-          <a:lstStyle/>
-          <a:p>
-            <a:pPr algn="ctr" indent="0" marL="0">
-              <a:buNone/>
-            </a:pPr>
-            <a:r>
-              <a:rPr lang="en-US" sz="900" dirty="0">
-                <a:solidFill>
-                  <a:srgbClr val="8AB4D4"/>
-                </a:solidFill>
-              </a:rPr>
-              <a:t>▼</a:t>
-            </a:r>
-            <a:endParaRPr lang="en-US" sz="900" dirty="0"/>
-          </a:p>
-        </p:txBody>
-      </p:sp>
-      <p:sp>
-        <p:nvSpPr>
-          <p:cNvPr id="31" name="Shape 29"/>
-          <p:cNvSpPr/>
-          <p:nvPr/>
-        </p:nvSpPr>
-        <p:spPr>
-          <a:xfrm>
-            <a:off x="3246120" y="2980944"/>
-            <a:ext cx="2834640" cy="621792"/>
-          </a:xfrm>
-          <a:prstGeom prst="rect">
-            <a:avLst/>
-          </a:prstGeom>
-          <a:solidFill>
-            <a:srgbClr val="162C47"/>
-          </a:solidFill>
-          <a:ln w="19050">
-            <a:solidFill>
-              <a:srgbClr val="F59E0B"/>
-            </a:solidFill>
-            <a:prstDash val="solid"/>
-          </a:ln>
-        </p:spPr>
-      </p:sp>
-      <p:sp>
-        <p:nvSpPr>
-          <p:cNvPr id="32" name="Shape 30"/>
-          <p:cNvSpPr/>
-          <p:nvPr/>
-        </p:nvSpPr>
-        <p:spPr>
-          <a:xfrm>
-            <a:off x="3246120" y="2980944"/>
-            <a:ext cx="64008" cy="621792"/>
-          </a:xfrm>
-          <a:prstGeom prst="rect">
-            <a:avLst/>
-          </a:prstGeom>
-          <a:solidFill>
-            <a:srgbClr val="F59E0B"/>
-          </a:solidFill>
-          <a:ln w="12700">
-            <a:solidFill>
-              <a:srgbClr val="F59E0B"/>
-            </a:solidFill>
-            <a:prstDash val="solid"/>
-          </a:ln>
-        </p:spPr>
-      </p:sp>
-      <p:sp>
-        <p:nvSpPr>
-          <p:cNvPr id="33" name="Text 31"/>
-          <p:cNvSpPr/>
-          <p:nvPr/>
-        </p:nvSpPr>
-        <p:spPr>
-          <a:xfrm>
-            <a:off x="3364992" y="3017520"/>
-            <a:ext cx="2651760" cy="256032"/>
-          </a:xfrm>
-          <a:prstGeom prst="rect">
-            <a:avLst/>
-          </a:prstGeom>
-          <a:noFill/>
-          <a:ln/>
-        </p:spPr>
-        <p:txBody>
-          <a:bodyPr wrap="square" rtlCol="0" anchor="ctr"/>
-          <a:lstStyle/>
-          <a:p>
-            <a:pPr indent="0" marL="0">
-              <a:buNone/>
-            </a:pPr>
-            <a:r>
-              <a:rPr lang="en-US" sz="1150" b="1" dirty="0">
-                <a:solidFill>
-                  <a:srgbClr val="FFFFFF"/>
-                </a:solidFill>
-                <a:latin typeface="Calibri" pitchFamily="34" charset="0"/>
-                <a:ea typeface="Calibri" pitchFamily="34" charset="-122"/>
-                <a:cs typeface="Calibri" pitchFamily="34" charset="-120"/>
-              </a:rPr>
-              <a:t>🟠  Sürd. Ajanı</a:t>
-            </a:r>
-            <a:endParaRPr lang="en-US" sz="1150" dirty="0"/>
-          </a:p>
-        </p:txBody>
-      </p:sp>
-      <p:sp>
-        <p:nvSpPr>
-          <p:cNvPr id="34" name="Text 32"/>
-          <p:cNvSpPr/>
-          <p:nvPr/>
-        </p:nvSpPr>
-        <p:spPr>
-          <a:xfrm>
-            <a:off x="3364992" y="3273552"/>
-            <a:ext cx="2651760" cy="256032"/>
-          </a:xfrm>
-          <a:prstGeom prst="rect">
-            <a:avLst/>
-          </a:prstGeom>
-          <a:noFill/>
-          <a:ln/>
-        </p:spPr>
-        <p:txBody>
-          <a:bodyPr wrap="square" rtlCol="0" anchor="ctr"/>
-          <a:lstStyle/>
-          <a:p>
-            <a:pPr indent="0" marL="0">
-              <a:buNone/>
-            </a:pPr>
-            <a:r>
-              <a:rPr lang="en-US" sz="1050" dirty="0">
-                <a:solidFill>
-                  <a:srgbClr val="8AB4D4"/>
-                </a:solidFill>
                 <a:latin typeface="Calibri" pitchFamily="34" charset="0"/>
                 <a:ea typeface="Calibri" pitchFamily="34" charset="-122"/>
                 <a:cs typeface="Calibri" pitchFamily="34" charset="-120"/>
               </a:rPr>
               <a:t>Boş bina → standby</a:t>
             </a:r>
-            <a:endParaRPr lang="en-US" sz="1050" dirty="0"/>
-          </a:p>
-        </p:txBody>
-      </p:sp>
-      <p:sp>
-        <p:nvSpPr>
-          <p:cNvPr id="35" name="Shape 33"/>
-          <p:cNvSpPr/>
-          <p:nvPr/>
-        </p:nvSpPr>
-        <p:spPr>
-          <a:xfrm>
-            <a:off x="3246120" y="3767328"/>
-            <a:ext cx="2834640" cy="749808"/>
+            <a:endParaRPr lang="en-US" sz="950" dirty="0"/>
+          </a:p>
+        </p:txBody>
+      </p:sp>
+      <p:sp>
+        <p:nvSpPr>
+          <p:cNvPr id="38" name="Shape 36"/>
+          <p:cNvSpPr/>
+          <p:nvPr/>
+        </p:nvSpPr>
+        <p:spPr>
+          <a:xfrm>
+            <a:off x="3163824" y="3986784"/>
+            <a:ext cx="2816352" cy="786384"/>
           </a:xfrm>
           <a:prstGeom prst="rect">
             <a:avLst/>
@@ -5136,14 +5256,14 @@
       </p:sp>
       <p:sp>
         <p:nvSpPr>
-          <p:cNvPr id="36" name="Text 34"/>
-          <p:cNvSpPr/>
-          <p:nvPr/>
-        </p:nvSpPr>
-        <p:spPr>
-          <a:xfrm>
-            <a:off x="3291840" y="3785616"/>
-            <a:ext cx="2743200" cy="256032"/>
+          <p:cNvPr id="39" name="Text 37"/>
+          <p:cNvSpPr/>
+          <p:nvPr/>
+        </p:nvSpPr>
+        <p:spPr>
+          <a:xfrm>
+            <a:off x="3218688" y="4005072"/>
+            <a:ext cx="2724912" cy="256032"/>
           </a:xfrm>
           <a:prstGeom prst="rect">
             <a:avLst/>
@@ -5175,14 +5295,14 @@
       </p:sp>
       <p:sp>
         <p:nvSpPr>
-          <p:cNvPr id="37" name="Text 35"/>
-          <p:cNvSpPr/>
-          <p:nvPr/>
-        </p:nvSpPr>
-        <p:spPr>
-          <a:xfrm>
-            <a:off x="3291840" y="4041648"/>
-            <a:ext cx="2743200" cy="402336"/>
+          <p:cNvPr id="40" name="Text 38"/>
+          <p:cNvSpPr/>
+          <p:nvPr/>
+        </p:nvSpPr>
+        <p:spPr>
+          <a:xfrm>
+            <a:off x="3218688" y="4261104"/>
+            <a:ext cx="2724912" cy="438912"/>
           </a:xfrm>
           <a:prstGeom prst="rect">
             <a:avLst/>
@@ -5199,187 +5319,6 @@
             </a:pPr>
             <a:r>
               <a:rPr lang="en-US" sz="1000" i="1" dirty="0">
-                <a:solidFill>
-                  <a:srgbClr val="FFFFFF"/>
-                </a:solidFill>
-                <a:latin typeface="Calibri" pitchFamily="34" charset="0"/>
-                <a:ea typeface="Calibri" pitchFamily="34" charset="-122"/>
-                <a:cs typeface="Calibri" pitchFamily="34" charset="-120"/>
-              </a:rPr>
-              <a:t>P = w₁·Pkonfor + w₂·Pmaliyet + w₃·Psürd</a:t>
-            </a:r>
-            <a:endParaRPr lang="en-US" sz="1000" dirty="0"/>
-          </a:p>
-        </p:txBody>
-      </p:sp>
-      <p:sp>
-        <p:nvSpPr>
-          <p:cNvPr id="38" name="Shape 36"/>
-          <p:cNvSpPr/>
-          <p:nvPr/>
-        </p:nvSpPr>
-        <p:spPr>
-          <a:xfrm>
-            <a:off x="6263640" y="1481328"/>
-            <a:ext cx="2834640" cy="658368"/>
-          </a:xfrm>
-          <a:prstGeom prst="rect">
-            <a:avLst/>
-          </a:prstGeom>
-          <a:solidFill>
-            <a:srgbClr val="162C47"/>
-          </a:solidFill>
-          <a:ln w="19050">
-            <a:solidFill>
-              <a:srgbClr val="F59E0B"/>
-            </a:solidFill>
-            <a:prstDash val="solid"/>
-          </a:ln>
-        </p:spPr>
-      </p:sp>
-      <p:sp>
-        <p:nvSpPr>
-          <p:cNvPr id="39" name="Text 37"/>
-          <p:cNvSpPr/>
-          <p:nvPr/>
-        </p:nvSpPr>
-        <p:spPr>
-          <a:xfrm>
-            <a:off x="6309360" y="1527048"/>
-            <a:ext cx="2743200" cy="566928"/>
-          </a:xfrm>
-          <a:prstGeom prst="rect">
-            <a:avLst/>
-          </a:prstGeom>
-          <a:noFill/>
-          <a:ln/>
-        </p:spPr>
-        <p:txBody>
-          <a:bodyPr wrap="square" rtlCol="0" anchor="ctr"/>
-          <a:lstStyle/>
-          <a:p>
-            <a:pPr algn="ctr" indent="0" marL="0">
-              <a:buNone/>
-            </a:pPr>
-            <a:r>
-              <a:rPr lang="en-US" sz="1150" dirty="0">
-                <a:solidFill>
-                  <a:srgbClr val="FFFFFF"/>
-                </a:solidFill>
-                <a:latin typeface="Calibri" pitchFamily="34" charset="0"/>
-                <a:ea typeface="Calibri" pitchFamily="34" charset="-122"/>
-                <a:cs typeface="Calibri" pitchFamily="34" charset="-120"/>
-              </a:rPr>
-              <a:t>Gerçek IoT Verisi</a:t>
-            </a:r>
-            <a:endParaRPr lang="en-US" sz="1150" dirty="0"/>
-          </a:p>
-          <a:p>
-            <a:pPr algn="ctr" indent="0" marL="0">
-              <a:buNone/>
-            </a:pPr>
-            <a:r>
-              <a:rPr lang="en-US" sz="1150" dirty="0">
-                <a:solidFill>
-                  <a:srgbClr val="FFFFFF"/>
-                </a:solidFill>
-                <a:latin typeface="Calibri" pitchFamily="34" charset="0"/>
-                <a:ea typeface="Calibri" pitchFamily="34" charset="-122"/>
-                <a:cs typeface="Calibri" pitchFamily="34" charset="-120"/>
-              </a:rPr>
-              <a:t>(UCI Dataset)</a:t>
-            </a:r>
-            <a:endParaRPr lang="en-US" sz="1150" dirty="0"/>
-          </a:p>
-        </p:txBody>
-      </p:sp>
-      <p:sp>
-        <p:nvSpPr>
-          <p:cNvPr id="40" name="Text 38"/>
-          <p:cNvSpPr/>
-          <p:nvPr/>
-        </p:nvSpPr>
-        <p:spPr>
-          <a:xfrm>
-            <a:off x="7479792" y="2157984"/>
-            <a:ext cx="402336" cy="164592"/>
-          </a:xfrm>
-          <a:prstGeom prst="rect">
-            <a:avLst/>
-          </a:prstGeom>
-          <a:noFill/>
-          <a:ln/>
-        </p:spPr>
-        <p:txBody>
-          <a:bodyPr wrap="square" rtlCol="0" anchor="ctr"/>
-          <a:lstStyle/>
-          <a:p>
-            <a:pPr algn="ctr" indent="0" marL="0">
-              <a:buNone/>
-            </a:pPr>
-            <a:r>
-              <a:rPr lang="en-US" sz="900" dirty="0">
-                <a:solidFill>
-                  <a:srgbClr val="8AB4D4"/>
-                </a:solidFill>
-              </a:rPr>
-              <a:t>▼</a:t>
-            </a:r>
-            <a:endParaRPr lang="en-US" sz="900" dirty="0"/>
-          </a:p>
-        </p:txBody>
-      </p:sp>
-      <p:sp>
-        <p:nvSpPr>
-          <p:cNvPr id="41" name="Shape 39"/>
-          <p:cNvSpPr/>
-          <p:nvPr/>
-        </p:nvSpPr>
-        <p:spPr>
-          <a:xfrm>
-            <a:off x="6263640" y="2286000"/>
-            <a:ext cx="2834640" cy="658368"/>
-          </a:xfrm>
-          <a:prstGeom prst="rect">
-            <a:avLst/>
-          </a:prstGeom>
-          <a:solidFill>
-            <a:srgbClr val="162C47"/>
-          </a:solidFill>
-          <a:ln w="19050">
-            <a:solidFill>
-              <a:srgbClr val="00BFA5"/>
-            </a:solidFill>
-            <a:prstDash val="solid"/>
-          </a:ln>
-        </p:spPr>
-      </p:sp>
-      <p:sp>
-        <p:nvSpPr>
-          <p:cNvPr id="42" name="Text 40"/>
-          <p:cNvSpPr/>
-          <p:nvPr/>
-        </p:nvSpPr>
-        <p:spPr>
-          <a:xfrm>
-            <a:off x="6309360" y="2331720"/>
-            <a:ext cx="2743200" cy="566928"/>
-          </a:xfrm>
-          <a:prstGeom prst="rect">
-            <a:avLst/>
-          </a:prstGeom>
-          <a:noFill/>
-          <a:ln/>
-        </p:spPr>
-        <p:txBody>
-          <a:bodyPr wrap="square" rtlCol="0" anchor="ctr"/>
-          <a:lstStyle/>
-          <a:p>
-            <a:pPr algn="ctr" indent="0" marL="0">
-              <a:buNone/>
-            </a:pPr>
-            <a:r>
-              <a:rPr lang="en-US" sz="950" dirty="0">
                 <a:solidFill>
                   <a:srgbClr val="FFFFFF"/>
                 </a:solidFill>
@@ -5387,16 +5326,180 @@
                 <a:ea typeface="Consolas" pitchFamily="34" charset="-122"/>
                 <a:cs typeface="Consolas" pitchFamily="34" charset="-120"/>
               </a:rPr>
-              <a:t>Isı Dengesi Denklemi</a:t>
-            </a:r>
-            <a:endParaRPr lang="en-US" sz="950" dirty="0"/>
-          </a:p>
+              <a:t>P = w₁·Pk + w₂·Pm + w₃·Ps</a:t>
+            </a:r>
+            <a:endParaRPr lang="en-US" sz="1000" dirty="0"/>
+          </a:p>
+        </p:txBody>
+      </p:sp>
+      <p:sp>
+        <p:nvSpPr>
+          <p:cNvPr id="41" name="Shape 39"/>
+          <p:cNvSpPr/>
+          <p:nvPr/>
+        </p:nvSpPr>
+        <p:spPr>
+          <a:xfrm>
+            <a:off x="6126480" y="1463040"/>
+            <a:ext cx="2816352" cy="694944"/>
+          </a:xfrm>
+          <a:prstGeom prst="rect">
+            <a:avLst/>
+          </a:prstGeom>
+          <a:solidFill>
+            <a:srgbClr val="162C47"/>
+          </a:solidFill>
+          <a:ln w="19050">
+            <a:solidFill>
+              <a:srgbClr val="F59E0B"/>
+            </a:solidFill>
+            <a:prstDash val="solid"/>
+          </a:ln>
+        </p:spPr>
+      </p:sp>
+      <p:sp>
+        <p:nvSpPr>
+          <p:cNvPr id="42" name="Text 40"/>
+          <p:cNvSpPr/>
+          <p:nvPr/>
+        </p:nvSpPr>
+        <p:spPr>
+          <a:xfrm>
+            <a:off x="6181344" y="1517904"/>
+            <a:ext cx="2706624" cy="585216"/>
+          </a:xfrm>
+          <a:prstGeom prst="rect">
+            <a:avLst/>
+          </a:prstGeom>
+          <a:noFill/>
+          <a:ln/>
+        </p:spPr>
+        <p:txBody>
+          <a:bodyPr wrap="square" rtlCol="0" anchor="ctr"/>
+          <a:lstStyle/>
           <a:p>
             <a:pPr algn="ctr" indent="0" marL="0">
               <a:buNone/>
             </a:pPr>
             <a:r>
-              <a:rPr lang="en-US" sz="950" dirty="0">
+              <a:rPr lang="en-US" sz="1050" dirty="0">
+                <a:solidFill>
+                  <a:srgbClr val="FFFFFF"/>
+                </a:solidFill>
+                <a:latin typeface="Calibri" pitchFamily="34" charset="0"/>
+                <a:ea typeface="Calibri" pitchFamily="34" charset="-122"/>
+                <a:cs typeface="Calibri" pitchFamily="34" charset="-120"/>
+              </a:rPr>
+              <a:t>Gerçek IoT Verisi (UCI)</a:t>
+            </a:r>
+            <a:endParaRPr lang="en-US" sz="1050" dirty="0"/>
+          </a:p>
+          <a:p>
+            <a:pPr algn="ctr" indent="0" marL="0">
+              <a:buNone/>
+            </a:pPr>
+            <a:r>
+              <a:rPr lang="en-US" sz="1050" dirty="0">
+                <a:solidFill>
+                  <a:srgbClr val="FFFFFF"/>
+                </a:solidFill>
+                <a:latin typeface="Calibri" pitchFamily="34" charset="0"/>
+                <a:ea typeface="Calibri" pitchFamily="34" charset="-122"/>
+                <a:cs typeface="Calibri" pitchFamily="34" charset="-120"/>
+              </a:rPr>
+              <a:t>Belçika evi · 4,5 ay · 10 dk'lık</a:t>
+            </a:r>
+            <a:endParaRPr lang="en-US" sz="1050" dirty="0"/>
+          </a:p>
+        </p:txBody>
+      </p:sp>
+      <p:sp>
+        <p:nvSpPr>
+          <p:cNvPr id="43" name="Text 41"/>
+          <p:cNvSpPr/>
+          <p:nvPr/>
+        </p:nvSpPr>
+        <p:spPr>
+          <a:xfrm>
+            <a:off x="7333488" y="2176272"/>
+            <a:ext cx="402336" cy="128016"/>
+          </a:xfrm>
+          <a:prstGeom prst="rect">
+            <a:avLst/>
+          </a:prstGeom>
+          <a:noFill/>
+          <a:ln/>
+        </p:spPr>
+        <p:txBody>
+          <a:bodyPr wrap="square" rtlCol="0" anchor="ctr"/>
+          <a:lstStyle/>
+          <a:p>
+            <a:pPr algn="ctr" indent="0" marL="0">
+              <a:buNone/>
+            </a:pPr>
+            <a:r>
+              <a:rPr lang="en-US" sz="900" dirty="0">
+                <a:solidFill>
+                  <a:srgbClr val="8AB4D4"/>
+                </a:solidFill>
+              </a:rPr>
+              <a:t>▼</a:t>
+            </a:r>
+            <a:endParaRPr lang="en-US" sz="900" dirty="0"/>
+          </a:p>
+        </p:txBody>
+      </p:sp>
+      <p:sp>
+        <p:nvSpPr>
+          <p:cNvPr id="44" name="Shape 42"/>
+          <p:cNvSpPr/>
+          <p:nvPr/>
+        </p:nvSpPr>
+        <p:spPr>
+          <a:xfrm>
+            <a:off x="6126480" y="2322576"/>
+            <a:ext cx="2816352" cy="694944"/>
+          </a:xfrm>
+          <a:prstGeom prst="rect">
+            <a:avLst/>
+          </a:prstGeom>
+          <a:solidFill>
+            <a:srgbClr val="162C47"/>
+          </a:solidFill>
+          <a:ln w="19050">
+            <a:solidFill>
+              <a:srgbClr val="00BFA5"/>
+            </a:solidFill>
+            <a:prstDash val="solid"/>
+          </a:ln>
+        </p:spPr>
+      </p:sp>
+      <p:sp>
+        <p:nvSpPr>
+          <p:cNvPr id="45" name="Text 43"/>
+          <p:cNvSpPr/>
+          <p:nvPr/>
+        </p:nvSpPr>
+        <p:spPr>
+          <a:xfrm>
+            <a:off x="6181344" y="2377440"/>
+            <a:ext cx="2706624" cy="585216"/>
+          </a:xfrm>
+          <a:prstGeom prst="rect">
+            <a:avLst/>
+          </a:prstGeom>
+          <a:noFill/>
+          <a:ln/>
+        </p:spPr>
+        <p:txBody>
+          <a:bodyPr wrap="square" rtlCol="0" anchor="ctr"/>
+          <a:lstStyle/>
+          <a:p>
+            <a:pPr algn="ctr" indent="0" marL="0">
+              <a:buNone/>
+            </a:pPr>
+            <a:r>
+              <a:rPr lang="en-US" sz="900" dirty="0">
                 <a:solidFill>
                   <a:srgbClr val="FFFFFF"/>
                 </a:solidFill>
@@ -5404,21 +5507,272 @@
                 <a:ea typeface="Consolas" pitchFamily="34" charset="-122"/>
                 <a:cs typeface="Consolas" pitchFamily="34" charset="-120"/>
               </a:rPr>
-              <a:t>T_iç[t+1] = T_iç[t] + α(T_dış−T_iç) + β·N − γ·P</a:t>
-            </a:r>
-            <a:endParaRPr lang="en-US" sz="950" dirty="0"/>
-          </a:p>
-        </p:txBody>
-      </p:sp>
-      <p:sp>
-        <p:nvSpPr>
-          <p:cNvPr id="43" name="Text 41"/>
-          <p:cNvSpPr/>
-          <p:nvPr/>
-        </p:nvSpPr>
-        <p:spPr>
-          <a:xfrm>
-            <a:off x="7479792" y="2962656"/>
+              <a:t>Isı Dengesi Denklemi</a:t>
+            </a:r>
+            <a:endParaRPr lang="en-US" sz="900" dirty="0"/>
+          </a:p>
+          <a:p>
+            <a:pPr algn="ctr" indent="0" marL="0">
+              <a:buNone/>
+            </a:pPr>
+            <a:r>
+              <a:rPr lang="en-US" sz="900" dirty="0">
+                <a:solidFill>
+                  <a:srgbClr val="FFFFFF"/>
+                </a:solidFill>
+                <a:latin typeface="Consolas" pitchFamily="34" charset="0"/>
+                <a:ea typeface="Consolas" pitchFamily="34" charset="-122"/>
+                <a:cs typeface="Consolas" pitchFamily="34" charset="-120"/>
+              </a:rPr>
+              <a:t>T_iç[t+1]=T_iç[t]+α(T_dış−T_iç)+β·N−γ·P</a:t>
+            </a:r>
+            <a:endParaRPr lang="en-US" sz="900" dirty="0"/>
+          </a:p>
+        </p:txBody>
+      </p:sp>
+      <p:sp>
+        <p:nvSpPr>
+          <p:cNvPr id="46" name="Text 44"/>
+          <p:cNvSpPr/>
+          <p:nvPr/>
+        </p:nvSpPr>
+        <p:spPr>
+          <a:xfrm>
+            <a:off x="7333488" y="3035808"/>
+            <a:ext cx="402336" cy="128016"/>
+          </a:xfrm>
+          <a:prstGeom prst="rect">
+            <a:avLst/>
+          </a:prstGeom>
+          <a:noFill/>
+          <a:ln/>
+        </p:spPr>
+        <p:txBody>
+          <a:bodyPr wrap="square" rtlCol="0" anchor="ctr"/>
+          <a:lstStyle/>
+          <a:p>
+            <a:pPr algn="ctr" indent="0" marL="0">
+              <a:buNone/>
+            </a:pPr>
+            <a:r>
+              <a:rPr lang="en-US" sz="900" dirty="0">
+                <a:solidFill>
+                  <a:srgbClr val="8AB4D4"/>
+                </a:solidFill>
+              </a:rPr>
+              <a:t>▼</a:t>
+            </a:r>
+            <a:endParaRPr lang="en-US" sz="900" dirty="0"/>
+          </a:p>
+        </p:txBody>
+      </p:sp>
+      <p:sp>
+        <p:nvSpPr>
+          <p:cNvPr id="47" name="Shape 45"/>
+          <p:cNvSpPr/>
+          <p:nvPr/>
+        </p:nvSpPr>
+        <p:spPr>
+          <a:xfrm>
+            <a:off x="6126480" y="3182112"/>
+            <a:ext cx="2816352" cy="694944"/>
+          </a:xfrm>
+          <a:prstGeom prst="rect">
+            <a:avLst/>
+          </a:prstGeom>
+          <a:solidFill>
+            <a:srgbClr val="162C47"/>
+          </a:solidFill>
+          <a:ln w="19050">
+            <a:solidFill>
+              <a:srgbClr val="00BFA5"/>
+            </a:solidFill>
+            <a:prstDash val="solid"/>
+          </a:ln>
+        </p:spPr>
+      </p:sp>
+      <p:sp>
+        <p:nvSpPr>
+          <p:cNvPr id="48" name="Text 46"/>
+          <p:cNvSpPr/>
+          <p:nvPr/>
+        </p:nvSpPr>
+        <p:spPr>
+          <a:xfrm>
+            <a:off x="6181344" y="3236976"/>
+            <a:ext cx="2706624" cy="585216"/>
+          </a:xfrm>
+          <a:prstGeom prst="rect">
+            <a:avLst/>
+          </a:prstGeom>
+          <a:noFill/>
+          <a:ln/>
+        </p:spPr>
+        <p:txBody>
+          <a:bodyPr wrap="square" rtlCol="0" anchor="ctr"/>
+          <a:lstStyle/>
+          <a:p>
+            <a:pPr algn="ctr" indent="0" marL="0">
+              <a:buNone/>
+            </a:pPr>
+            <a:r>
+              <a:rPr lang="en-US" sz="1050" dirty="0">
+                <a:solidFill>
+                  <a:srgbClr val="FFFFFF"/>
+                </a:solidFill>
+                <a:latin typeface="Calibri" pitchFamily="34" charset="0"/>
+                <a:ea typeface="Calibri" pitchFamily="34" charset="-122"/>
+                <a:cs typeface="Calibri" pitchFamily="34" charset="-120"/>
+              </a:rPr>
+              <a:t>İç Sıcaklık Simülasyonu</a:t>
+            </a:r>
+            <a:endParaRPr lang="en-US" sz="1050" dirty="0"/>
+          </a:p>
+          <a:p>
+            <a:pPr algn="ctr" indent="0" marL="0">
+              <a:buNone/>
+            </a:pPr>
+            <a:r>
+              <a:rPr lang="en-US" sz="1050" dirty="0">
+                <a:solidFill>
+                  <a:srgbClr val="FFFFFF"/>
+                </a:solidFill>
+                <a:latin typeface="Calibri" pitchFamily="34" charset="0"/>
+                <a:ea typeface="Calibri" pitchFamily="34" charset="-122"/>
+                <a:cs typeface="Calibri" pitchFamily="34" charset="-120"/>
+              </a:rPr>
+              <a:t>(Kapalı döngü — tüm sistemler)</a:t>
+            </a:r>
+            <a:endParaRPr lang="en-US" sz="1050" dirty="0"/>
+          </a:p>
+        </p:txBody>
+      </p:sp>
+      <p:sp>
+        <p:nvSpPr>
+          <p:cNvPr id="49" name="Text 47"/>
+          <p:cNvSpPr/>
+          <p:nvPr/>
+        </p:nvSpPr>
+        <p:spPr>
+          <a:xfrm>
+            <a:off x="7333488" y="3895344"/>
+            <a:ext cx="402336" cy="128016"/>
+          </a:xfrm>
+          <a:prstGeom prst="rect">
+            <a:avLst/>
+          </a:prstGeom>
+          <a:noFill/>
+          <a:ln/>
+        </p:spPr>
+        <p:txBody>
+          <a:bodyPr wrap="square" rtlCol="0" anchor="ctr"/>
+          <a:lstStyle/>
+          <a:p>
+            <a:pPr algn="ctr" indent="0" marL="0">
+              <a:buNone/>
+            </a:pPr>
+            <a:r>
+              <a:rPr lang="en-US" sz="900" dirty="0">
+                <a:solidFill>
+                  <a:srgbClr val="8AB4D4"/>
+                </a:solidFill>
+              </a:rPr>
+              <a:t>▼</a:t>
+            </a:r>
+            <a:endParaRPr lang="en-US" sz="900" dirty="0"/>
+          </a:p>
+        </p:txBody>
+      </p:sp>
+      <p:sp>
+        <p:nvSpPr>
+          <p:cNvPr id="50" name="Shape 48"/>
+          <p:cNvSpPr/>
+          <p:nvPr/>
+        </p:nvSpPr>
+        <p:spPr>
+          <a:xfrm>
+            <a:off x="6126480" y="4041648"/>
+            <a:ext cx="2816352" cy="694944"/>
+          </a:xfrm>
+          <a:prstGeom prst="rect">
+            <a:avLst/>
+          </a:prstGeom>
+          <a:solidFill>
+            <a:srgbClr val="162C47"/>
+          </a:solidFill>
+          <a:ln w="19050">
+            <a:solidFill>
+              <a:srgbClr val="66BB6A"/>
+            </a:solidFill>
+            <a:prstDash val="solid"/>
+          </a:ln>
+        </p:spPr>
+      </p:sp>
+      <p:sp>
+        <p:nvSpPr>
+          <p:cNvPr id="51" name="Text 49"/>
+          <p:cNvSpPr/>
+          <p:nvPr/>
+        </p:nvSpPr>
+        <p:spPr>
+          <a:xfrm>
+            <a:off x="6181344" y="4096512"/>
+            <a:ext cx="2706624" cy="585216"/>
+          </a:xfrm>
+          <a:prstGeom prst="rect">
+            <a:avLst/>
+          </a:prstGeom>
+          <a:noFill/>
+          <a:ln/>
+        </p:spPr>
+        <p:txBody>
+          <a:bodyPr wrap="square" rtlCol="0" anchor="ctr"/>
+          <a:lstStyle/>
+          <a:p>
+            <a:pPr algn="ctr" indent="0" marL="0">
+              <a:buNone/>
+            </a:pPr>
+            <a:r>
+              <a:rPr lang="en-US" sz="1050" dirty="0">
+                <a:solidFill>
+                  <a:srgbClr val="FFFFFF"/>
+                </a:solidFill>
+                <a:latin typeface="Calibri" pitchFamily="34" charset="0"/>
+                <a:ea typeface="Calibri" pitchFamily="34" charset="-122"/>
+                <a:cs typeface="Calibri" pitchFamily="34" charset="-120"/>
+              </a:rPr>
+              <a:t>Validasyon: MAE · RMSE · R²</a:t>
+            </a:r>
+            <a:endParaRPr lang="en-US" sz="1050" dirty="0"/>
+          </a:p>
+          <a:p>
+            <a:pPr algn="ctr" indent="0" marL="0">
+              <a:buNone/>
+            </a:pPr>
+            <a:r>
+              <a:rPr lang="en-US" sz="1050" dirty="0">
+                <a:solidFill>
+                  <a:srgbClr val="FFFFFF"/>
+                </a:solidFill>
+                <a:latin typeface="Calibri" pitchFamily="34" charset="0"/>
+                <a:ea typeface="Calibri" pitchFamily="34" charset="-122"/>
+                <a:cs typeface="Calibri" pitchFamily="34" charset="-120"/>
+              </a:rPr>
+              <a:t>⚠ P_klima=0 sınırlılığı belgelendi</a:t>
+            </a:r>
+            <a:endParaRPr lang="en-US" sz="1050" dirty="0"/>
+          </a:p>
+        </p:txBody>
+      </p:sp>
+      <p:sp>
+        <p:nvSpPr>
+          <p:cNvPr id="52" name="Text 50"/>
+          <p:cNvSpPr/>
+          <p:nvPr/>
+        </p:nvSpPr>
+        <p:spPr>
+          <a:xfrm>
+            <a:off x="1408176" y="4681728"/>
             <a:ext cx="402336" cy="164592"/>
           </a:xfrm>
           <a:prstGeom prst="rect">
@@ -5435,52 +5789,27 @@
               <a:buNone/>
             </a:pPr>
             <a:r>
-              <a:rPr lang="en-US" sz="900" dirty="0">
+              <a:rPr lang="en-US" sz="1000" dirty="0">
                 <a:solidFill>
                   <a:srgbClr val="8AB4D4"/>
                 </a:solidFill>
               </a:rPr>
               <a:t>▼</a:t>
             </a:r>
-            <a:endParaRPr lang="en-US" sz="900" dirty="0"/>
-          </a:p>
-        </p:txBody>
-      </p:sp>
-      <p:sp>
-        <p:nvSpPr>
-          <p:cNvPr id="44" name="Shape 42"/>
-          <p:cNvSpPr/>
-          <p:nvPr/>
-        </p:nvSpPr>
-        <p:spPr>
-          <a:xfrm>
-            <a:off x="6263640" y="3090672"/>
-            <a:ext cx="2834640" cy="658368"/>
-          </a:xfrm>
-          <a:prstGeom prst="rect">
-            <a:avLst/>
-          </a:prstGeom>
-          <a:solidFill>
-            <a:srgbClr val="162C47"/>
-          </a:solidFill>
-          <a:ln w="19050">
-            <a:solidFill>
-              <a:srgbClr val="00BFA5"/>
-            </a:solidFill>
-            <a:prstDash val="solid"/>
-          </a:ln>
-        </p:spPr>
-      </p:sp>
-      <p:sp>
-        <p:nvSpPr>
-          <p:cNvPr id="45" name="Text 43"/>
-          <p:cNvSpPr/>
-          <p:nvPr/>
-        </p:nvSpPr>
-        <p:spPr>
-          <a:xfrm>
-            <a:off x="6309360" y="3136392"/>
-            <a:ext cx="2743200" cy="566928"/>
+            <a:endParaRPr lang="en-US" sz="1000" dirty="0"/>
+          </a:p>
+        </p:txBody>
+      </p:sp>
+      <p:sp>
+        <p:nvSpPr>
+          <p:cNvPr id="53" name="Text 51"/>
+          <p:cNvSpPr/>
+          <p:nvPr/>
+        </p:nvSpPr>
+        <p:spPr>
+          <a:xfrm>
+            <a:off x="4370832" y="4681728"/>
+            <a:ext cx="402336" cy="164592"/>
           </a:xfrm>
           <a:prstGeom prst="rect">
             <a:avLst/>
@@ -5496,272 +5825,63 @@
               <a:buNone/>
             </a:pPr>
             <a:r>
-              <a:rPr lang="en-US" sz="1150" dirty="0">
-                <a:solidFill>
-                  <a:srgbClr val="FFFFFF"/>
-                </a:solidFill>
-                <a:latin typeface="Calibri" pitchFamily="34" charset="0"/>
-                <a:ea typeface="Calibri" pitchFamily="34" charset="-122"/>
-                <a:cs typeface="Calibri" pitchFamily="34" charset="-120"/>
-              </a:rPr>
-              <a:t>İç Sıcaklık</a:t>
-            </a:r>
-            <a:endParaRPr lang="en-US" sz="1150" dirty="0"/>
-          </a:p>
+              <a:rPr lang="en-US" sz="1000" dirty="0">
+                <a:solidFill>
+                  <a:srgbClr val="8AB4D4"/>
+                </a:solidFill>
+              </a:rPr>
+              <a:t>▼</a:t>
+            </a:r>
+            <a:endParaRPr lang="en-US" sz="1000" dirty="0"/>
+          </a:p>
+        </p:txBody>
+      </p:sp>
+      <p:sp>
+        <p:nvSpPr>
+          <p:cNvPr id="54" name="Text 52"/>
+          <p:cNvSpPr/>
+          <p:nvPr/>
+        </p:nvSpPr>
+        <p:spPr>
+          <a:xfrm>
+            <a:off x="7333488" y="4681728"/>
+            <a:ext cx="402336" cy="164592"/>
+          </a:xfrm>
+          <a:prstGeom prst="rect">
+            <a:avLst/>
+          </a:prstGeom>
+          <a:noFill/>
+          <a:ln/>
+        </p:spPr>
+        <p:txBody>
+          <a:bodyPr wrap="square" rtlCol="0" anchor="ctr"/>
+          <a:lstStyle/>
           <a:p>
             <a:pPr algn="ctr" indent="0" marL="0">
               <a:buNone/>
             </a:pPr>
             <a:r>
-              <a:rPr lang="en-US" sz="1150" dirty="0">
-                <a:solidFill>
-                  <a:srgbClr val="FFFFFF"/>
-                </a:solidFill>
-                <a:latin typeface="Calibri" pitchFamily="34" charset="0"/>
-                <a:ea typeface="Calibri" pitchFamily="34" charset="-122"/>
-                <a:cs typeface="Calibri" pitchFamily="34" charset="-120"/>
-              </a:rPr>
-              <a:t>Simülasyonu</a:t>
-            </a:r>
-            <a:endParaRPr lang="en-US" sz="1150" dirty="0"/>
-          </a:p>
-        </p:txBody>
-      </p:sp>
-      <p:sp>
-        <p:nvSpPr>
-          <p:cNvPr id="46" name="Text 44"/>
-          <p:cNvSpPr/>
-          <p:nvPr/>
-        </p:nvSpPr>
-        <p:spPr>
-          <a:xfrm>
-            <a:off x="7479792" y="3767328"/>
-            <a:ext cx="402336" cy="164592"/>
-          </a:xfrm>
-          <a:prstGeom prst="rect">
-            <a:avLst/>
-          </a:prstGeom>
-          <a:noFill/>
-          <a:ln/>
-        </p:spPr>
-        <p:txBody>
-          <a:bodyPr wrap="square" rtlCol="0" anchor="ctr"/>
-          <a:lstStyle/>
-          <a:p>
-            <a:pPr algn="ctr" indent="0" marL="0">
-              <a:buNone/>
-            </a:pPr>
-            <a:r>
-              <a:rPr lang="en-US" sz="900" dirty="0">
+              <a:rPr lang="en-US" sz="1000" dirty="0">
                 <a:solidFill>
                   <a:srgbClr val="8AB4D4"/>
                 </a:solidFill>
               </a:rPr>
               <a:t>▼</a:t>
             </a:r>
-            <a:endParaRPr lang="en-US" sz="900" dirty="0"/>
-          </a:p>
-        </p:txBody>
-      </p:sp>
-      <p:sp>
-        <p:nvSpPr>
-          <p:cNvPr id="47" name="Shape 45"/>
-          <p:cNvSpPr/>
-          <p:nvPr/>
-        </p:nvSpPr>
-        <p:spPr>
-          <a:xfrm>
-            <a:off x="6263640" y="3895344"/>
-            <a:ext cx="2834640" cy="658368"/>
-          </a:xfrm>
-          <a:prstGeom prst="rect">
-            <a:avLst/>
-          </a:prstGeom>
-          <a:solidFill>
-            <a:srgbClr val="162C47"/>
-          </a:solidFill>
-          <a:ln w="19050">
-            <a:solidFill>
-              <a:srgbClr val="66BB6A"/>
-            </a:solidFill>
-            <a:prstDash val="solid"/>
-          </a:ln>
-        </p:spPr>
-      </p:sp>
-      <p:sp>
-        <p:nvSpPr>
-          <p:cNvPr id="48" name="Text 46"/>
-          <p:cNvSpPr/>
-          <p:nvPr/>
-        </p:nvSpPr>
-        <p:spPr>
-          <a:xfrm>
-            <a:off x="6309360" y="3941064"/>
-            <a:ext cx="2743200" cy="566928"/>
-          </a:xfrm>
-          <a:prstGeom prst="rect">
-            <a:avLst/>
-          </a:prstGeom>
-          <a:noFill/>
-          <a:ln/>
-        </p:spPr>
-        <p:txBody>
-          <a:bodyPr wrap="square" rtlCol="0" anchor="ctr"/>
-          <a:lstStyle/>
-          <a:p>
-            <a:pPr algn="ctr" indent="0" marL="0">
-              <a:buNone/>
-            </a:pPr>
-            <a:r>
-              <a:rPr lang="en-US" sz="1150" dirty="0">
-                <a:solidFill>
-                  <a:srgbClr val="FFFFFF"/>
-                </a:solidFill>
-                <a:latin typeface="Calibri" pitchFamily="34" charset="0"/>
-                <a:ea typeface="Calibri" pitchFamily="34" charset="-122"/>
-                <a:cs typeface="Calibri" pitchFamily="34" charset="-120"/>
-              </a:rPr>
-              <a:t>Validasyon</a:t>
-            </a:r>
-            <a:endParaRPr lang="en-US" sz="1150" dirty="0"/>
-          </a:p>
-          <a:p>
-            <a:pPr algn="ctr" indent="0" marL="0">
-              <a:buNone/>
-            </a:pPr>
-            <a:r>
-              <a:rPr lang="en-US" sz="1150" dirty="0">
-                <a:solidFill>
-                  <a:srgbClr val="FFFFFF"/>
-                </a:solidFill>
-                <a:latin typeface="Calibri" pitchFamily="34" charset="0"/>
-                <a:ea typeface="Calibri" pitchFamily="34" charset="-122"/>
-                <a:cs typeface="Calibri" pitchFamily="34" charset="-120"/>
-              </a:rPr>
-              <a:t>MAE  ·  RMSE  ·  R²</a:t>
-            </a:r>
-            <a:endParaRPr lang="en-US" sz="1150" dirty="0"/>
-          </a:p>
-        </p:txBody>
-      </p:sp>
-      <p:sp>
-        <p:nvSpPr>
-          <p:cNvPr id="49" name="Text 47"/>
-          <p:cNvSpPr/>
-          <p:nvPr/>
-        </p:nvSpPr>
-        <p:spPr>
-          <a:xfrm>
-            <a:off x="1444752" y="4663440"/>
-            <a:ext cx="402336" cy="182880"/>
-          </a:xfrm>
-          <a:prstGeom prst="rect">
-            <a:avLst/>
-          </a:prstGeom>
-          <a:noFill/>
-          <a:ln/>
-        </p:spPr>
-        <p:txBody>
-          <a:bodyPr wrap="square" rtlCol="0" anchor="ctr"/>
-          <a:lstStyle/>
-          <a:p>
-            <a:pPr algn="ctr" indent="0" marL="0">
-              <a:buNone/>
-            </a:pPr>
-            <a:r>
-              <a:rPr lang="en-US" sz="1000" dirty="0">
-                <a:solidFill>
-                  <a:srgbClr val="8AB4D4"/>
-                </a:solidFill>
-              </a:rPr>
-              <a:t>▼</a:t>
-            </a:r>
             <a:endParaRPr lang="en-US" sz="1000" dirty="0"/>
           </a:p>
         </p:txBody>
       </p:sp>
       <p:sp>
         <p:nvSpPr>
-          <p:cNvPr id="50" name="Text 48"/>
-          <p:cNvSpPr/>
-          <p:nvPr/>
-        </p:nvSpPr>
-        <p:spPr>
-          <a:xfrm>
-            <a:off x="4462272" y="4663440"/>
-            <a:ext cx="402336" cy="182880"/>
-          </a:xfrm>
-          <a:prstGeom prst="rect">
-            <a:avLst/>
-          </a:prstGeom>
-          <a:noFill/>
-          <a:ln/>
-        </p:spPr>
-        <p:txBody>
-          <a:bodyPr wrap="square" rtlCol="0" anchor="ctr"/>
-          <a:lstStyle/>
-          <a:p>
-            <a:pPr algn="ctr" indent="0" marL="0">
-              <a:buNone/>
-            </a:pPr>
-            <a:r>
-              <a:rPr lang="en-US" sz="1000" dirty="0">
-                <a:solidFill>
-                  <a:srgbClr val="8AB4D4"/>
-                </a:solidFill>
-              </a:rPr>
-              <a:t>▼</a:t>
-            </a:r>
-            <a:endParaRPr lang="en-US" sz="1000" dirty="0"/>
-          </a:p>
-        </p:txBody>
-      </p:sp>
-      <p:sp>
-        <p:nvSpPr>
-          <p:cNvPr id="51" name="Text 49"/>
-          <p:cNvSpPr/>
-          <p:nvPr/>
-        </p:nvSpPr>
-        <p:spPr>
-          <a:xfrm>
-            <a:off x="7479792" y="4663440"/>
-            <a:ext cx="402336" cy="182880"/>
-          </a:xfrm>
-          <a:prstGeom prst="rect">
-            <a:avLst/>
-          </a:prstGeom>
-          <a:noFill/>
-          <a:ln/>
-        </p:spPr>
-        <p:txBody>
-          <a:bodyPr wrap="square" rtlCol="0" anchor="ctr"/>
-          <a:lstStyle/>
-          <a:p>
-            <a:pPr algn="ctr" indent="0" marL="0">
-              <a:buNone/>
-            </a:pPr>
-            <a:r>
-              <a:rPr lang="en-US" sz="1000" dirty="0">
-                <a:solidFill>
-                  <a:srgbClr val="8AB4D4"/>
-                </a:solidFill>
-              </a:rPr>
-              <a:t>▼</a:t>
-            </a:r>
-            <a:endParaRPr lang="en-US" sz="1000" dirty="0"/>
-          </a:p>
-        </p:txBody>
-      </p:sp>
-      <p:sp>
-        <p:nvSpPr>
-          <p:cNvPr id="52" name="Shape 50"/>
-          <p:cNvSpPr/>
-          <p:nvPr/>
-        </p:nvSpPr>
-        <p:spPr>
-          <a:xfrm>
-            <a:off x="1645920" y="4809744"/>
-            <a:ext cx="5852160" cy="274320"/>
+          <p:cNvPr id="55" name="Shape 53"/>
+          <p:cNvSpPr/>
+          <p:nvPr/>
+        </p:nvSpPr>
+        <p:spPr>
+          <a:xfrm>
+            <a:off x="1645920" y="4828032"/>
+            <a:ext cx="5852160" cy="256032"/>
           </a:xfrm>
           <a:prstGeom prst="rect">
             <a:avLst/>
@@ -5779,14 +5899,14 @@
       </p:sp>
       <p:sp>
         <p:nvSpPr>
-          <p:cNvPr id="53" name="Text 51"/>
-          <p:cNvSpPr/>
-          <p:nvPr/>
-        </p:nvSpPr>
-        <p:spPr>
-          <a:xfrm>
-            <a:off x="1645920" y="4809744"/>
-            <a:ext cx="5852160" cy="274320"/>
+          <p:cNvPr id="56" name="Text 54"/>
+          <p:cNvSpPr/>
+          <p:nvPr/>
+        </p:nvSpPr>
+        <p:spPr>
+          <a:xfrm>
+            <a:off x="1645920" y="4828032"/>
+            <a:ext cx="5852160" cy="256032"/>
           </a:xfrm>
           <a:prstGeom prst="rect">
             <a:avLst/>
@@ -5906,7 +6026,7 @@
                 <a:ea typeface="Calibri" pitchFamily="34" charset="-122"/>
                 <a:cs typeface="Calibri" pitchFamily="34" charset="-120"/>
               </a:rPr>
-              <a:t>📈  Sonuçlar &amp; Sistem Çıktısı</a:t>
+              <a:t>📈  Sonuçlar, Düzeltmeler &amp; Sistem Çıktısı</a:t>
             </a:r>
             <a:endParaRPr lang="en-US" sz="2300" dirty="0"/>
           </a:p>
@@ -6554,7 +6674,7 @@
         <p:spPr>
           <a:xfrm>
             <a:off x="256032" y="2706624"/>
-            <a:ext cx="4846320" cy="2286000"/>
+            <a:ext cx="4572000" cy="2286000"/>
           </a:xfrm>
           <a:prstGeom prst="rect">
             <a:avLst/>
@@ -6564,7 +6684,7 @@
           </a:solidFill>
           <a:ln w="19050">
             <a:solidFill>
-              <a:srgbClr val="42A5F5"/>
+              <a:srgbClr val="66BB6A"/>
             </a:solidFill>
             <a:prstDash val="solid"/>
           </a:ln>
@@ -6592,11 +6712,11 @@
             <a:avLst/>
           </a:prstGeom>
           <a:solidFill>
-            <a:srgbClr val="42A5F5"/>
+            <a:srgbClr val="66BB6A"/>
           </a:solidFill>
           <a:ln w="12700">
             <a:solidFill>
-              <a:srgbClr val="42A5F5"/>
+              <a:srgbClr val="66BB6A"/>
             </a:solidFill>
             <a:prstDash val="solid"/>
           </a:ln>
@@ -6611,7 +6731,7 @@
         <p:spPr>
           <a:xfrm>
             <a:off x="384048" y="2761488"/>
-            <a:ext cx="4572000" cy="329184"/>
+            <a:ext cx="4352544" cy="347472"/>
           </a:xfrm>
           <a:prstGeom prst="rect">
             <a:avLst/>
@@ -6629,13 +6749,13 @@
             <a:r>
               <a:rPr lang="en-US" sz="1300" b="1" dirty="0">
                 <a:solidFill>
-                  <a:srgbClr val="42A5F5"/>
-                </a:solidFill>
-                <a:latin typeface="Calibri" pitchFamily="34" charset="0"/>
-                <a:ea typeface="Calibri" pitchFamily="34" charset="-122"/>
-                <a:cs typeface="Calibri" pitchFamily="34" charset="-120"/>
-              </a:rPr>
-              <a:t>Dashboard Özellikleri</a:t>
+                  <a:srgbClr val="66BB6A"/>
+                </a:solidFill>
+                <a:latin typeface="Calibri" pitchFamily="34" charset="0"/>
+                <a:ea typeface="Calibri" pitchFamily="34" charset="-122"/>
+                <a:cs typeface="Calibri" pitchFamily="34" charset="-120"/>
+              </a:rPr>
+              <a:t>✅  Uygulanan Teknik Düzeltmeler</a:t>
             </a:r>
             <a:endParaRPr lang="en-US" sz="1300" dirty="0"/>
           </a:p>
@@ -6649,8 +6769,8 @@
         </p:nvSpPr>
         <p:spPr>
           <a:xfrm>
-            <a:off x="384048" y="3127248"/>
-            <a:ext cx="4572000" cy="274320"/>
+            <a:off x="384048" y="3154680"/>
+            <a:ext cx="4352544" cy="365760"/>
           </a:xfrm>
           <a:prstGeom prst="rect">
             <a:avLst/>
@@ -6666,7 +6786,7 @@
               <a:buNone/>
             </a:pPr>
             <a:r>
-              <a:rPr lang="en-US" sz="1100" dirty="0">
+              <a:rPr lang="en-US" sz="1150" dirty="0">
                 <a:solidFill>
                   <a:srgbClr val="FFFFFF"/>
                 </a:solidFill>
@@ -6674,9 +6794,9 @@
                 <a:ea typeface="Calibri" pitchFamily="34" charset="-122"/>
                 <a:cs typeface="Calibri" pitchFamily="34" charset="-120"/>
               </a:rPr>
-              <a:t>⚡  3 sistemin güç profili karşılaştırması</a:t>
-            </a:r>
-            <a:endParaRPr lang="en-US" sz="1100" dirty="0"/>
+              <a:t>1. ML Kapalı Döngü: T_iç her saatte modele besleniyor</a:t>
+            </a:r>
+            <a:endParaRPr lang="en-US" sz="1150" dirty="0"/>
           </a:p>
         </p:txBody>
       </p:sp>
@@ -6688,8 +6808,8 @@
         </p:nvSpPr>
         <p:spPr>
           <a:xfrm>
-            <a:off x="384048" y="3438144"/>
-            <a:ext cx="4572000" cy="274320"/>
+            <a:off x="384048" y="3584448"/>
+            <a:ext cx="4352544" cy="365760"/>
           </a:xfrm>
           <a:prstGeom prst="rect">
             <a:avLst/>
@@ -6705,7 +6825,7 @@
               <a:buNone/>
             </a:pPr>
             <a:r>
-              <a:rPr lang="en-US" sz="1100" dirty="0">
+              <a:rPr lang="en-US" sz="1150" dirty="0">
                 <a:solidFill>
                   <a:srgbClr val="FFFFFF"/>
                 </a:solidFill>
@@ -6713,9 +6833,9 @@
                 <a:ea typeface="Calibri" pitchFamily="34" charset="-122"/>
                 <a:cs typeface="Calibri" pitchFamily="34" charset="-120"/>
               </a:rPr>
-              <a:t>🏠  Dijital İkiz iç sıcaklık dinamiği + konfor bandı</a:t>
-            </a:r>
-            <a:endParaRPr lang="en-US" sz="1100" dirty="0"/>
+              <a:t>2. T_iç Özelliği: fiyat değil konfor durumu birincil kriter</a:t>
+            </a:r>
+            <a:endParaRPr lang="en-US" sz="1150" dirty="0"/>
           </a:p>
         </p:txBody>
       </p:sp>
@@ -6727,8 +6847,8 @@
         </p:nvSpPr>
         <p:spPr>
           <a:xfrm>
-            <a:off x="384048" y="3749040"/>
-            <a:ext cx="4572000" cy="274320"/>
+            <a:off x="384048" y="4014216"/>
+            <a:ext cx="4352544" cy="365760"/>
           </a:xfrm>
           <a:prstGeom prst="rect">
             <a:avLst/>
@@ -6744,7 +6864,7 @@
               <a:buNone/>
             </a:pPr>
             <a:r>
-              <a:rPr lang="en-US" sz="1100" dirty="0">
+              <a:rPr lang="en-US" sz="1150" dirty="0">
                 <a:solidFill>
                   <a:srgbClr val="FFFFFF"/>
                 </a:solidFill>
@@ -6752,9 +6872,9 @@
                 <a:ea typeface="Calibri" pitchFamily="34" charset="-122"/>
                 <a:cs typeface="Calibri" pitchFamily="34" charset="-120"/>
               </a:rPr>
-              <a:t>🤝  Ajan oy tablosu + koordinatör kararı</a:t>
-            </a:r>
-            <a:endParaRPr lang="en-US" sz="1100" dirty="0"/>
+              <a:t>3. Geleneksel Kapalı Döngü: T_dış → T_iç eşiğine geçildi</a:t>
+            </a:r>
+            <a:endParaRPr lang="en-US" sz="1150" dirty="0"/>
           </a:p>
         </p:txBody>
       </p:sp>
@@ -6766,8 +6886,8 @@
         </p:nvSpPr>
         <p:spPr>
           <a:xfrm>
-            <a:off x="384048" y="4059936"/>
-            <a:ext cx="4572000" cy="274320"/>
+            <a:off x="384048" y="4443984"/>
+            <a:ext cx="4352544" cy="365760"/>
           </a:xfrm>
           <a:prstGeom prst="rect">
             <a:avLst/>
@@ -6783,7 +6903,7 @@
               <a:buNone/>
             </a:pPr>
             <a:r>
-              <a:rPr lang="en-US" sz="1100" dirty="0">
+              <a:rPr lang="en-US" sz="1150" dirty="0">
                 <a:solidFill>
                   <a:srgbClr val="FFFFFF"/>
                 </a:solidFill>
@@ -6791,100 +6911,22 @@
                 <a:ea typeface="Calibri" pitchFamily="34" charset="-122"/>
                 <a:cs typeface="Calibri" pitchFamily="34" charset="-120"/>
               </a:rPr>
-              <a:t>🤖  Random Forest özellik önem analizi</a:t>
-            </a:r>
-            <a:endParaRPr lang="en-US" sz="1100" dirty="0"/>
-          </a:p>
-        </p:txBody>
-      </p:sp>
-      <p:sp>
-        <p:nvSpPr>
-          <p:cNvPr id="28" name="Text 26"/>
-          <p:cNvSpPr/>
-          <p:nvPr/>
-        </p:nvSpPr>
-        <p:spPr>
-          <a:xfrm>
-            <a:off x="384048" y="4370832"/>
-            <a:ext cx="4572000" cy="274320"/>
-          </a:xfrm>
-          <a:prstGeom prst="rect">
-            <a:avLst/>
-          </a:prstGeom>
-          <a:noFill/>
-          <a:ln/>
-        </p:spPr>
-        <p:txBody>
-          <a:bodyPr wrap="square" rtlCol="0" anchor="ctr"/>
-          <a:lstStyle/>
-          <a:p>
-            <a:pPr algn="l" indent="0" marL="0">
-              <a:buNone/>
-            </a:pPr>
-            <a:r>
-              <a:rPr lang="en-US" sz="1100" dirty="0">
-                <a:solidFill>
-                  <a:srgbClr val="FFFFFF"/>
-                </a:solidFill>
-                <a:latin typeface="Calibri" pitchFamily="34" charset="0"/>
-                <a:ea typeface="Calibri" pitchFamily="34" charset="-122"/>
-                <a:cs typeface="Calibri" pitchFamily="34" charset="-120"/>
-              </a:rPr>
-              <a:t>📡  UCI IoT verisiyle gerçek zamanlı validasyon</a:t>
-            </a:r>
-            <a:endParaRPr lang="en-US" sz="1100" dirty="0"/>
-          </a:p>
-        </p:txBody>
-      </p:sp>
-      <p:sp>
-        <p:nvSpPr>
-          <p:cNvPr id="29" name="Text 27"/>
-          <p:cNvSpPr/>
-          <p:nvPr/>
-        </p:nvSpPr>
-        <p:spPr>
-          <a:xfrm>
-            <a:off x="384048" y="4681728"/>
-            <a:ext cx="4572000" cy="274320"/>
-          </a:xfrm>
-          <a:prstGeom prst="rect">
-            <a:avLst/>
-          </a:prstGeom>
-          <a:noFill/>
-          <a:ln/>
-        </p:spPr>
-        <p:txBody>
-          <a:bodyPr wrap="square" rtlCol="0" anchor="ctr"/>
-          <a:lstStyle/>
-          <a:p>
-            <a:pPr algn="l" indent="0" marL="0">
-              <a:buNone/>
-            </a:pPr>
-            <a:r>
-              <a:rPr lang="en-US" sz="1100" dirty="0">
-                <a:solidFill>
-                  <a:srgbClr val="FFFFFF"/>
-                </a:solidFill>
-                <a:latin typeface="Calibri" pitchFamily="34" charset="0"/>
-                <a:ea typeface="Calibri" pitchFamily="34" charset="-122"/>
-                <a:cs typeface="Calibri" pitchFamily="34" charset="-120"/>
-              </a:rPr>
-              <a:t>📋  Tüm sistemlerin saatlik detay tablosu</a:t>
-            </a:r>
-            <a:endParaRPr lang="en-US" sz="1100" dirty="0"/>
-          </a:p>
-        </p:txBody>
-      </p:sp>
-      <p:sp>
-        <p:nvSpPr>
-          <p:cNvPr id="30" name="Shape 28"/>
-          <p:cNvSpPr/>
-          <p:nvPr/>
-        </p:nvSpPr>
-        <p:spPr>
-          <a:xfrm>
-            <a:off x="5303520" y="2706624"/>
-            <a:ext cx="3584448" cy="2286000"/>
+              <a:t>4. UCI Sınırlılık: P_klima=0 belgeli, R² yorumu dürüst</a:t>
+            </a:r>
+            <a:endParaRPr lang="en-US" sz="1150" dirty="0"/>
+          </a:p>
+        </p:txBody>
+      </p:sp>
+      <p:sp>
+        <p:nvSpPr>
+          <p:cNvPr id="28" name="Shape 26"/>
+          <p:cNvSpPr/>
+          <p:nvPr/>
+        </p:nvSpPr>
+        <p:spPr>
+          <a:xfrm>
+            <a:off x="5029200" y="2706624"/>
+            <a:ext cx="3858768" cy="2286000"/>
           </a:xfrm>
           <a:prstGeom prst="rect">
             <a:avLst/>
@@ -6909,13 +6951,13 @@
       </p:sp>
       <p:sp>
         <p:nvSpPr>
-          <p:cNvPr id="31" name="Shape 29"/>
-          <p:cNvSpPr/>
-          <p:nvPr/>
-        </p:nvSpPr>
-        <p:spPr>
-          <a:xfrm>
-            <a:off x="5303520" y="2706624"/>
+          <p:cNvPr id="29" name="Shape 27"/>
+          <p:cNvSpPr/>
+          <p:nvPr/>
+        </p:nvSpPr>
+        <p:spPr>
+          <a:xfrm>
+            <a:off x="5029200" y="2706624"/>
             <a:ext cx="64008" cy="2286000"/>
           </a:xfrm>
           <a:prstGeom prst="rect">
@@ -6934,40 +6976,118 @@
       </p:sp>
       <p:sp>
         <p:nvSpPr>
+          <p:cNvPr id="30" name="Text 28"/>
+          <p:cNvSpPr/>
+          <p:nvPr/>
+        </p:nvSpPr>
+        <p:spPr>
+          <a:xfrm>
+            <a:off x="5157216" y="2761488"/>
+            <a:ext cx="3639312" cy="347472"/>
+          </a:xfrm>
+          <a:prstGeom prst="rect">
+            <a:avLst/>
+          </a:prstGeom>
+          <a:noFill/>
+          <a:ln/>
+        </p:spPr>
+        <p:txBody>
+          <a:bodyPr wrap="square" rtlCol="0" anchor="ctr"/>
+          <a:lstStyle/>
+          <a:p>
+            <a:pPr indent="0" marL="0">
+              <a:buNone/>
+            </a:pPr>
+            <a:r>
+              <a:rPr lang="en-US" sz="1300" b="1" dirty="0">
+                <a:solidFill>
+                  <a:srgbClr val="AB47BC"/>
+                </a:solidFill>
+                <a:latin typeface="Calibri" pitchFamily="34" charset="0"/>
+                <a:ea typeface="Calibri" pitchFamily="34" charset="-122"/>
+                <a:cs typeface="Calibri" pitchFamily="34" charset="-120"/>
+              </a:rPr>
+              <a:t>Akademik Katkılar</a:t>
+            </a:r>
+            <a:endParaRPr lang="en-US" sz="1300" dirty="0"/>
+          </a:p>
+        </p:txBody>
+      </p:sp>
+      <p:sp>
+        <p:nvSpPr>
+          <p:cNvPr id="31" name="Text 29"/>
+          <p:cNvSpPr/>
+          <p:nvPr/>
+        </p:nvSpPr>
+        <p:spPr>
+          <a:xfrm>
+            <a:off x="5157216" y="3154680"/>
+            <a:ext cx="3639312" cy="365760"/>
+          </a:xfrm>
+          <a:prstGeom prst="rect">
+            <a:avLst/>
+          </a:prstGeom>
+          <a:noFill/>
+          <a:ln/>
+        </p:spPr>
+        <p:txBody>
+          <a:bodyPr wrap="square" rtlCol="0" anchor="ctr"/>
+          <a:lstStyle/>
+          <a:p>
+            <a:pPr algn="l" indent="0" marL="0">
+              <a:buNone/>
+            </a:pPr>
+            <a:r>
+              <a:rPr lang="en-US" sz="1100" dirty="0">
+                <a:solidFill>
+                  <a:srgbClr val="FFFFFF"/>
+                </a:solidFill>
+                <a:latin typeface="Calibri" pitchFamily="34" charset="0"/>
+                <a:ea typeface="Calibri" pitchFamily="34" charset="-122"/>
+                <a:cs typeface="Calibri" pitchFamily="34" charset="-120"/>
+              </a:rPr>
+              <a:t>• Fiziksel Dijital İkiz: ısı dengesi kapalı döngü</a:t>
+            </a:r>
+            <a:endParaRPr lang="en-US" sz="1100" dirty="0"/>
+          </a:p>
+        </p:txBody>
+      </p:sp>
+      <p:sp>
+        <p:nvSpPr>
           <p:cNvPr id="32" name="Text 30"/>
           <p:cNvSpPr/>
           <p:nvPr/>
         </p:nvSpPr>
         <p:spPr>
           <a:xfrm>
-            <a:off x="5431536" y="2761488"/>
-            <a:ext cx="3383280" cy="329184"/>
-          </a:xfrm>
-          <a:prstGeom prst="rect">
-            <a:avLst/>
-          </a:prstGeom>
-          <a:noFill/>
-          <a:ln/>
-        </p:spPr>
-        <p:txBody>
-          <a:bodyPr wrap="square" rtlCol="0" anchor="ctr"/>
-          <a:lstStyle/>
-          <a:p>
-            <a:pPr indent="0" marL="0">
-              <a:buNone/>
-            </a:pPr>
-            <a:r>
-              <a:rPr lang="en-US" sz="1300" b="1" dirty="0">
-                <a:solidFill>
-                  <a:srgbClr val="AB47BC"/>
-                </a:solidFill>
-                <a:latin typeface="Calibri" pitchFamily="34" charset="0"/>
-                <a:ea typeface="Calibri" pitchFamily="34" charset="-122"/>
-                <a:cs typeface="Calibri" pitchFamily="34" charset="-120"/>
-              </a:rPr>
-              <a:t>Akademik Katkılar</a:t>
-            </a:r>
-            <a:endParaRPr lang="en-US" sz="1300" dirty="0"/>
+            <a:off x="5157216" y="3557016"/>
+            <a:ext cx="3639312" cy="365760"/>
+          </a:xfrm>
+          <a:prstGeom prst="rect">
+            <a:avLst/>
+          </a:prstGeom>
+          <a:noFill/>
+          <a:ln/>
+        </p:spPr>
+        <p:txBody>
+          <a:bodyPr wrap="square" rtlCol="0" anchor="ctr"/>
+          <a:lstStyle/>
+          <a:p>
+            <a:pPr algn="l" indent="0" marL="0">
+              <a:buNone/>
+            </a:pPr>
+            <a:r>
+              <a:rPr lang="en-US" sz="1100" dirty="0">
+                <a:solidFill>
+                  <a:srgbClr val="FFFFFF"/>
+                </a:solidFill>
+                <a:latin typeface="Calibri" pitchFamily="34" charset="0"/>
+                <a:ea typeface="Calibri" pitchFamily="34" charset="-122"/>
+                <a:cs typeface="Calibri" pitchFamily="34" charset="-120"/>
+              </a:rPr>
+              <a:t>• Çoklu Ajan: ağırlıklı koordinasyon mekanizması</a:t>
+            </a:r>
+            <a:endParaRPr lang="en-US" sz="1100" dirty="0"/>
           </a:p>
         </p:txBody>
       </p:sp>
@@ -6979,24 +7099,24 @@
         </p:nvSpPr>
         <p:spPr>
           <a:xfrm>
-            <a:off x="5431536" y="3127248"/>
-            <a:ext cx="3383280" cy="457200"/>
-          </a:xfrm>
-          <a:prstGeom prst="rect">
-            <a:avLst/>
-          </a:prstGeom>
-          <a:noFill/>
-          <a:ln/>
-        </p:spPr>
-        <p:txBody>
-          <a:bodyPr wrap="square" rtlCol="0" anchor="t"/>
+            <a:off x="5157216" y="3959352"/>
+            <a:ext cx="3639312" cy="365760"/>
+          </a:xfrm>
+          <a:prstGeom prst="rect">
+            <a:avLst/>
+          </a:prstGeom>
+          <a:noFill/>
+          <a:ln/>
+        </p:spPr>
+        <p:txBody>
+          <a:bodyPr wrap="square" rtlCol="0" anchor="ctr"/>
           <a:lstStyle/>
           <a:p>
             <a:pPr algn="l" indent="0" marL="0">
               <a:buNone/>
             </a:pPr>
             <a:r>
-              <a:rPr lang="en-US" sz="1050" dirty="0">
+              <a:rPr lang="en-US" sz="1100" dirty="0">
                 <a:solidFill>
                   <a:srgbClr val="FFFFFF"/>
                 </a:solidFill>
@@ -7004,16 +7124,38 @@
                 <a:ea typeface="Calibri" pitchFamily="34" charset="-122"/>
                 <a:cs typeface="Calibri" pitchFamily="34" charset="-120"/>
               </a:rPr>
-              <a:t>• Fiziksel Dijital İkiz: ısı dengesi</a:t>
-            </a:r>
-            <a:endParaRPr lang="en-US" sz="1050" dirty="0"/>
-          </a:p>
+              <a:t>• ML: T_iç geri beslemeli konfor odaklı öğrenme</a:t>
+            </a:r>
+            <a:endParaRPr lang="en-US" sz="1100" dirty="0"/>
+          </a:p>
+        </p:txBody>
+      </p:sp>
+      <p:sp>
+        <p:nvSpPr>
+          <p:cNvPr id="34" name="Text 32"/>
+          <p:cNvSpPr/>
+          <p:nvPr/>
+        </p:nvSpPr>
+        <p:spPr>
+          <a:xfrm>
+            <a:off x="5157216" y="4361688"/>
+            <a:ext cx="3639312" cy="365760"/>
+          </a:xfrm>
+          <a:prstGeom prst="rect">
+            <a:avLst/>
+          </a:prstGeom>
+          <a:noFill/>
+          <a:ln/>
+        </p:spPr>
+        <p:txBody>
+          <a:bodyPr wrap="square" rtlCol="0" anchor="ctr"/>
+          <a:lstStyle/>
           <a:p>
             <a:pPr algn="l" indent="0" marL="0">
               <a:buNone/>
             </a:pPr>
             <a:r>
-              <a:rPr lang="en-US" sz="1050" dirty="0">
+              <a:rPr lang="en-US" sz="1100" dirty="0">
                 <a:solidFill>
                   <a:srgbClr val="FFFFFF"/>
                 </a:solidFill>
@@ -7021,166 +7163,118 @@
                 <a:ea typeface="Calibri" pitchFamily="34" charset="-122"/>
                 <a:cs typeface="Calibri" pitchFamily="34" charset="-120"/>
               </a:rPr>
-              <a:t>  kapalı döngü kontrolü</a:t>
-            </a:r>
-            <a:endParaRPr lang="en-US" sz="1050" dirty="0"/>
-          </a:p>
-        </p:txBody>
-      </p:sp>
-      <p:sp>
-        <p:nvSpPr>
-          <p:cNvPr id="34" name="Text 32"/>
-          <p:cNvSpPr/>
-          <p:nvPr/>
-        </p:nvSpPr>
-        <p:spPr>
-          <a:xfrm>
-            <a:off x="5431536" y="3630168"/>
-            <a:ext cx="3383280" cy="457200"/>
-          </a:xfrm>
-          <a:prstGeom prst="rect">
-            <a:avLst/>
-          </a:prstGeom>
-          <a:noFill/>
-          <a:ln/>
-        </p:spPr>
-        <p:txBody>
-          <a:bodyPr wrap="square" rtlCol="0" anchor="t"/>
+              <a:t>• Gerçek IoT validasyonu + belgelenmiş sınırlılıklar</a:t>
+            </a:r>
+            <a:endParaRPr lang="en-US" sz="1100" dirty="0"/>
+          </a:p>
+        </p:txBody>
+      </p:sp>
+      <p:sp>
+        <p:nvSpPr>
+          <p:cNvPr id="35" name="Text 33"/>
+          <p:cNvSpPr/>
+          <p:nvPr/>
+        </p:nvSpPr>
+        <p:spPr>
+          <a:xfrm>
+            <a:off x="5157216" y="4764024"/>
+            <a:ext cx="3639312" cy="365760"/>
+          </a:xfrm>
+          <a:prstGeom prst="rect">
+            <a:avLst/>
+          </a:prstGeom>
+          <a:noFill/>
+          <a:ln/>
+        </p:spPr>
+        <p:txBody>
+          <a:bodyPr wrap="square" rtlCol="0" anchor="ctr"/>
           <a:lstStyle/>
           <a:p>
             <a:pPr algn="l" indent="0" marL="0">
               <a:buNone/>
             </a:pPr>
             <a:r>
-              <a:rPr lang="en-US" sz="1050" dirty="0">
-                <a:solidFill>
-                  <a:srgbClr val="FFFFFF"/>
-                </a:solidFill>
-                <a:latin typeface="Calibri" pitchFamily="34" charset="0"/>
-                <a:ea typeface="Calibri" pitchFamily="34" charset="-122"/>
-                <a:cs typeface="Calibri" pitchFamily="34" charset="-120"/>
-              </a:rPr>
-              <a:t>• Çoklu Ajan: ağırlıklı koordinasyon</a:t>
-            </a:r>
-            <a:endParaRPr lang="en-US" sz="1050" dirty="0"/>
-          </a:p>
-          <a:p>
-            <a:pPr algn="l" indent="0" marL="0">
-              <a:buNone/>
-            </a:pPr>
-            <a:r>
-              <a:rPr lang="en-US" sz="1050" dirty="0">
-                <a:solidFill>
-                  <a:srgbClr val="FFFFFF"/>
-                </a:solidFill>
-                <a:latin typeface="Calibri" pitchFamily="34" charset="0"/>
-                <a:ea typeface="Calibri" pitchFamily="34" charset="-122"/>
-                <a:cs typeface="Calibri" pitchFamily="34" charset="-120"/>
-              </a:rPr>
-              <a:t>  mekanizması</a:t>
-            </a:r>
-            <a:endParaRPr lang="en-US" sz="1050" dirty="0"/>
-          </a:p>
-        </p:txBody>
-      </p:sp>
-      <p:sp>
-        <p:nvSpPr>
-          <p:cNvPr id="35" name="Text 33"/>
-          <p:cNvSpPr/>
-          <p:nvPr/>
-        </p:nvSpPr>
-        <p:spPr>
-          <a:xfrm>
-            <a:off x="5431536" y="4133088"/>
-            <a:ext cx="3383280" cy="457200"/>
-          </a:xfrm>
-          <a:prstGeom prst="rect">
-            <a:avLst/>
-          </a:prstGeom>
-          <a:noFill/>
-          <a:ln/>
-        </p:spPr>
-        <p:txBody>
-          <a:bodyPr wrap="square" rtlCol="0" anchor="t"/>
-          <a:lstStyle/>
-          <a:p>
-            <a:pPr algn="l" indent="0" marL="0">
-              <a:buNone/>
-            </a:pPr>
-            <a:r>
-              <a:rPr lang="en-US" sz="1050" dirty="0">
-                <a:solidFill>
-                  <a:srgbClr val="FFFFFF"/>
-                </a:solidFill>
-                <a:latin typeface="Calibri" pitchFamily="34" charset="0"/>
-                <a:ea typeface="Calibri" pitchFamily="34" charset="-122"/>
-                <a:cs typeface="Calibri" pitchFamily="34" charset="-120"/>
-              </a:rPr>
-              <a:t>• ML ile kural-öğrenme karşılaştırması</a:t>
-            </a:r>
-            <a:endParaRPr lang="en-US" sz="1050" dirty="0"/>
-          </a:p>
-        </p:txBody>
-      </p:sp>
-      <p:sp>
-        <p:nvSpPr>
-          <p:cNvPr id="36" name="Text 34"/>
-          <p:cNvSpPr/>
-          <p:nvPr/>
-        </p:nvSpPr>
-        <p:spPr>
-          <a:xfrm>
-            <a:off x="5431536" y="4636008"/>
-            <a:ext cx="3383280" cy="457200"/>
-          </a:xfrm>
-          <a:prstGeom prst="rect">
-            <a:avLst/>
-          </a:prstGeom>
-          <a:noFill/>
-          <a:ln/>
-        </p:spPr>
-        <p:txBody>
-          <a:bodyPr wrap="square" rtlCol="0" anchor="t"/>
-          <a:lstStyle/>
-          <a:p>
-            <a:pPr algn="l" indent="0" marL="0">
-              <a:buNone/>
-            </a:pPr>
-            <a:r>
-              <a:rPr lang="en-US" sz="1050" dirty="0">
-                <a:solidFill>
-                  <a:srgbClr val="FFFFFF"/>
-                </a:solidFill>
-                <a:latin typeface="Calibri" pitchFamily="34" charset="0"/>
-                <a:ea typeface="Calibri" pitchFamily="34" charset="-122"/>
-                <a:cs typeface="Calibri" pitchFamily="34" charset="-120"/>
-              </a:rPr>
-              <a:t>• Gerçek IoT verisiyle model</a:t>
-            </a:r>
-            <a:endParaRPr lang="en-US" sz="1050" dirty="0"/>
-          </a:p>
-          <a:p>
-            <a:pPr algn="l" indent="0" marL="0">
-              <a:buNone/>
-            </a:pPr>
-            <a:r>
-              <a:rPr lang="en-US" sz="1050" dirty="0">
-                <a:solidFill>
-                  <a:srgbClr val="FFFFFF"/>
-                </a:solidFill>
-                <a:latin typeface="Calibri" pitchFamily="34" charset="0"/>
-                <a:ea typeface="Calibri" pitchFamily="34" charset="-122"/>
-                <a:cs typeface="Calibri" pitchFamily="34" charset="-120"/>
-              </a:rPr>
-              <a:t>  validasyonu (MAE/RMSE/R²)</a:t>
-            </a:r>
-            <a:endParaRPr lang="en-US" sz="1050" dirty="0"/>
-          </a:p>
-        </p:txBody>
-      </p:sp>
-      <p:sp>
-        <p:nvSpPr>
-          <p:cNvPr id="37" name="Shape 35"/>
+              <a:rPr lang="en-US" sz="950" dirty="0">
+                <a:solidFill>
+                  <a:srgbClr val="8AB4D4"/>
+                </a:solidFill>
+                <a:latin typeface="Calibri" pitchFamily="34" charset="0"/>
+                <a:ea typeface="Calibri" pitchFamily="34" charset="-122"/>
+                <a:cs typeface="Calibri" pitchFamily="34" charset="-120"/>
+              </a:rPr>
+              <a:t>  (MAE / RMSE / R² / P_klima=0 şeffaflığı)</a:t>
+            </a:r>
+            <a:endParaRPr lang="en-US" sz="950" dirty="0"/>
+          </a:p>
+        </p:txBody>
+      </p:sp>
+      <p:sp>
+        <p:nvSpPr>
+          <p:cNvPr id="36" name="Shape 34"/>
+          <p:cNvSpPr/>
+          <p:nvPr/>
+        </p:nvSpPr>
+        <p:spPr>
+          <a:xfrm>
+            <a:off x="0" y="4892040"/>
+            <a:ext cx="9144000" cy="201168"/>
+          </a:xfrm>
+          <a:prstGeom prst="rect">
+            <a:avLst/>
+          </a:prstGeom>
+          <a:solidFill>
+            <a:srgbClr val="0D1E30"/>
+          </a:solidFill>
+          <a:ln w="12700">
+            <a:solidFill>
+              <a:srgbClr val="0D1E30"/>
+            </a:solidFill>
+            <a:prstDash val="solid"/>
+          </a:ln>
+        </p:spPr>
+      </p:sp>
+      <p:sp>
+        <p:nvSpPr>
+          <p:cNvPr id="37" name="Text 35"/>
+          <p:cNvSpPr/>
+          <p:nvPr/>
+        </p:nvSpPr>
+        <p:spPr>
+          <a:xfrm>
+            <a:off x="0" y="4892040"/>
+            <a:ext cx="9144000" cy="201168"/>
+          </a:xfrm>
+          <a:prstGeom prst="rect">
+            <a:avLst/>
+          </a:prstGeom>
+          <a:noFill/>
+          <a:ln/>
+        </p:spPr>
+        <p:txBody>
+          <a:bodyPr wrap="square" rtlCol="0" anchor="ctr"/>
+          <a:lstStyle/>
+          <a:p>
+            <a:pPr algn="ctr" indent="0" marL="0">
+              <a:buNone/>
+            </a:pPr>
+            <a:r>
+              <a:rPr lang="en-US" sz="1000" dirty="0">
+                <a:solidFill>
+                  <a:srgbClr val="8AB4D4"/>
+                </a:solidFill>
+                <a:latin typeface="Calibri" pitchFamily="34" charset="0"/>
+                <a:ea typeface="Calibri" pitchFamily="34" charset="-122"/>
+                <a:cs typeface="Calibri" pitchFamily="34" charset="-120"/>
+              </a:rPr>
+              <a:t>Python  ·  Streamlit  ·  Scikit-learn  ·  Plotly  ·  UCI ML Repository</a:t>
+            </a:r>
+            <a:endParaRPr lang="en-US" sz="1000" dirty="0"/>
+          </a:p>
+        </p:txBody>
+      </p:sp>
+      <p:sp>
+        <p:nvSpPr>
+          <p:cNvPr id="38" name="Shape 36"/>
           <p:cNvSpPr/>
           <p:nvPr/>
         </p:nvSpPr>
@@ -7202,70 +7296,6 @@
             <a:prstDash val="solid"/>
           </a:ln>
         </p:spPr>
-      </p:sp>
-      <p:sp>
-        <p:nvSpPr>
-          <p:cNvPr id="38" name="Shape 36"/>
-          <p:cNvSpPr/>
-          <p:nvPr/>
-        </p:nvSpPr>
-        <p:spPr>
-          <a:xfrm>
-            <a:off x="0" y="4892040"/>
-            <a:ext cx="9144000" cy="201168"/>
-          </a:xfrm>
-          <a:prstGeom prst="rect">
-            <a:avLst/>
-          </a:prstGeom>
-          <a:solidFill>
-            <a:srgbClr val="0D1E30"/>
-          </a:solidFill>
-          <a:ln w="12700">
-            <a:solidFill>
-              <a:srgbClr val="0D1E30"/>
-            </a:solidFill>
-            <a:prstDash val="solid"/>
-          </a:ln>
-        </p:spPr>
-      </p:sp>
-      <p:sp>
-        <p:nvSpPr>
-          <p:cNvPr id="39" name="Text 37"/>
-          <p:cNvSpPr/>
-          <p:nvPr/>
-        </p:nvSpPr>
-        <p:spPr>
-          <a:xfrm>
-            <a:off x="0" y="4892040"/>
-            <a:ext cx="9144000" cy="201168"/>
-          </a:xfrm>
-          <a:prstGeom prst="rect">
-            <a:avLst/>
-          </a:prstGeom>
-          <a:noFill/>
-          <a:ln/>
-        </p:spPr>
-        <p:txBody>
-          <a:bodyPr wrap="square" rtlCol="0" anchor="ctr"/>
-          <a:lstStyle/>
-          <a:p>
-            <a:pPr algn="ctr" indent="0" marL="0">
-              <a:buNone/>
-            </a:pPr>
-            <a:r>
-              <a:rPr lang="en-US" sz="1000" dirty="0">
-                <a:solidFill>
-                  <a:srgbClr val="8AB4D4"/>
-                </a:solidFill>
-                <a:latin typeface="Calibri" pitchFamily="34" charset="0"/>
-                <a:ea typeface="Calibri" pitchFamily="34" charset="-122"/>
-                <a:cs typeface="Calibri" pitchFamily="34" charset="-120"/>
-              </a:rPr>
-              <a:t>Teknoloji: Python  ·  Streamlit  ·  Scikit-learn  ·  Plotly  ·  UCI ML Repository</a:t>
-            </a:r>
-            <a:endParaRPr lang="en-US" sz="1000" dirty="0"/>
-          </a:p>
-        </p:txBody>
       </p:sp>
     </p:spTree>
   </p:cSld>

</xml_diff>

<commit_message>
Update presentation: reflect all recent fixes + Pecan Street IoT
Slide 1: UCI -> Pecan Street, R2~0.90 -> Pearson metric
Slide 3: IoT column updated (air1 kW, Pearson, normalized profiles)
         ML column: T_ic feature + closed-loop note
         Agent column: aligned thresholds 26C note
Slide 4: 8 technical fixes listed (hysteresis, gamma=2.0,
         agent threshold fix, T_ic clip, cache key, Pecan Street)
         Academic section: Pearson + R2 negative explanation

Co-Authored-By: Claude Sonnet 4.6 <noreply@anthropic.com>
</commit_message>
<xml_diff>
--- a/bina_enerji_dijital_ikiz_sunum.pptx
+++ b/bina_enerji_dijital_ikiz_sunum.pptx
@@ -1332,7 +1332,7 @@
                 <a:ea typeface="Calibri" pitchFamily="34" charset="-122"/>
                 <a:cs typeface="Calibri" pitchFamily="34" charset="-120"/>
               </a:rPr>
-              <a:t>Fiziksel Termal Model  ·  Çoklu Ajan  ·  ML (Kapalı Döngü)  ·  Gerçek IoT Validasyonu</a:t>
+              <a:t>Fiziksel Termal Model  ·  Çoklu Ajan  ·  ML (Kapalı Döngü)  ·  Pecan Street IoT Validasyonu</a:t>
             </a:r>
             <a:endParaRPr lang="en-US" sz="1200" dirty="0"/>
           </a:p>
@@ -1885,7 +1885,7 @@
                 <a:ea typeface="Calibri" pitchFamily="34" charset="-122"/>
                 <a:cs typeface="Calibri" pitchFamily="34" charset="-120"/>
               </a:rPr>
-              <a:t>UCI veri setiyle gerçek IoT sensör verisi validasyonu</a:t>
+              <a:t>Pecan Street Dataport — Austin TX, 25 ev, gerçek AC güç validasyonu</a:t>
             </a:r>
             <a:endParaRPr lang="en-US" sz="1200" dirty="0"/>
           </a:p>
@@ -2277,7 +2277,7 @@
               <a:buNone/>
             </a:pPr>
             <a:r>
-              <a:rPr lang="en-US" sz="2800" b="1" dirty="0">
+              <a:rPr lang="en-US" sz="2200" b="1" dirty="0">
                 <a:solidFill>
                   <a:srgbClr val="00BFA5"/>
                 </a:solidFill>
@@ -2285,9 +2285,9 @@
                 <a:ea typeface="Calibri" pitchFamily="34" charset="-122"/>
                 <a:cs typeface="Calibri" pitchFamily="34" charset="-120"/>
               </a:rPr>
-              <a:t>R²≈0.90</a:t>
-            </a:r>
-            <a:endParaRPr lang="en-US" sz="2800" dirty="0"/>
+              <a:t>Pearson</a:t>
+            </a:r>
+            <a:endParaRPr lang="en-US" sz="2200" dirty="0"/>
           </a:p>
         </p:txBody>
       </p:sp>
@@ -2324,7 +2324,7 @@
                 <a:ea typeface="Calibri" pitchFamily="34" charset="-122"/>
                 <a:cs typeface="Calibri" pitchFamily="34" charset="-120"/>
               </a:rPr>
-              <a:t>IoT Doğruluk</a:t>
+              <a:t>IoT Validasyon</a:t>
             </a:r>
             <a:endParaRPr lang="en-US" sz="1100" dirty="0"/>
           </a:p>
@@ -2341,7 +2341,7 @@
                 <a:ea typeface="Calibri" pitchFamily="34" charset="-122"/>
                 <a:cs typeface="Calibri" pitchFamily="34" charset="-120"/>
               </a:rPr>
-              <a:t>Skoru</a:t>
+              <a:t>Metriği</a:t>
             </a:r>
             <a:endParaRPr lang="en-US" sz="1100" dirty="0"/>
           </a:p>
@@ -2405,7 +2405,7 @@
                 <a:ea typeface="Calibri" pitchFamily="34" charset="-122"/>
                 <a:cs typeface="Calibri" pitchFamily="34" charset="-120"/>
               </a:rPr>
-              <a:t>Python  ·  Streamlit  ·  Scikit-learn  ·  Plotly  ·  UCI IoT Data</a:t>
+              <a:t>Python  ·  Streamlit  ·  Scikit-learn  ·  Plotly  ·  Pecan Street Dataport</a:t>
             </a:r>
             <a:endParaRPr lang="en-US" sz="1100" dirty="0"/>
           </a:p>
@@ -4027,7 +4027,7 @@
                 <a:ea typeface="Calibri" pitchFamily="34" charset="-122"/>
                 <a:cs typeface="Calibri" pitchFamily="34" charset="-120"/>
               </a:rPr>
-              <a:t>🔧  Sistem Mimarisi — Kapalı Döngü Düzeltmeleri Dahil</a:t>
+              <a:t>🔧  Sistem Mimarisi — Kapalı Döngü + Pecan Street IoT Validasyonu</a:t>
             </a:r>
             <a:endParaRPr lang="en-US" sz="2300" dirty="0"/>
           </a:p>
@@ -4399,7 +4399,7 @@
           <a:bodyPr wrap="square" rtlCol="0" anchor="ctr"/>
           <a:lstStyle/>
           <a:p>
-            <a:pPr algn="l" indent="0" marL="0">
+            <a:pPr indent="0" marL="0">
               <a:buNone/>
             </a:pPr>
             <a:r>
@@ -4411,12 +4411,12 @@
                 <a:ea typeface="Calibri" pitchFamily="34" charset="-122"/>
                 <a:cs typeface="Calibri" pitchFamily="34" charset="-120"/>
               </a:rPr>
-              <a:t>✅  Düzeltme: T_iç özellik olarak</a:t>
+              <a:t>✅  Kapalı Döngü: T_iç→predict→T_iç_yeni</a:t>
             </a:r>
             <a:endParaRPr lang="en-US" sz="950" dirty="0"/>
           </a:p>
           <a:p>
-            <a:pPr algn="l" indent="0" marL="0">
+            <a:pPr indent="0" marL="0">
               <a:buNone/>
             </a:pPr>
             <a:r>
@@ -4428,7 +4428,7 @@
                 <a:ea typeface="Calibri" pitchFamily="34" charset="-122"/>
                 <a:cs typeface="Calibri" pitchFamily="34" charset="-120"/>
               </a:rPr>
-              <a:t>eklendi — artık konfor durumu biliniyor</a:t>
+              <a:t>✅  Hedef: konfor odaklı (fiyat ikincil)</a:t>
             </a:r>
             <a:endParaRPr lang="en-US" sz="950" dirty="0"/>
           </a:p>
@@ -4545,7 +4545,7 @@
                 <a:ea typeface="Calibri" pitchFamily="34" charset="-122"/>
                 <a:cs typeface="Calibri" pitchFamily="34" charset="-120"/>
               </a:rPr>
-              <a:t>(hedef T_iç konforuna göre)</a:t>
+              <a:t>365 gün × 24 saat = 8.760 örnek</a:t>
             </a:r>
             <a:endParaRPr lang="en-US" sz="1100" dirty="0"/>
           </a:p>
@@ -4596,88 +4596,7 @@
         <p:spPr>
           <a:xfrm>
             <a:off x="201168" y="3584448"/>
-            <a:ext cx="2816352" cy="457200"/>
-          </a:xfrm>
-          <a:prstGeom prst="rect">
-            <a:avLst/>
-          </a:prstGeom>
-          <a:solidFill>
-            <a:srgbClr val="1A3515"/>
-          </a:solidFill>
-          <a:ln w="15240">
-            <a:solidFill>
-              <a:srgbClr val="66BB6A"/>
-            </a:solidFill>
-            <a:prstDash val="solid"/>
-          </a:ln>
-        </p:spPr>
-      </p:sp>
-      <p:sp>
-        <p:nvSpPr>
-          <p:cNvPr id="21" name="Text 19"/>
-          <p:cNvSpPr/>
-          <p:nvPr/>
-        </p:nvSpPr>
-        <p:spPr>
-          <a:xfrm>
-            <a:off x="256032" y="3602736"/>
-            <a:ext cx="2724912" cy="420624"/>
-          </a:xfrm>
-          <a:prstGeom prst="rect">
-            <a:avLst/>
-          </a:prstGeom>
-          <a:noFill/>
-          <a:ln/>
-        </p:spPr>
-        <p:txBody>
-          <a:bodyPr wrap="square" rtlCol="0" anchor="ctr"/>
-          <a:lstStyle/>
-          <a:p>
-            <a:pPr algn="l" indent="0" marL="0">
-              <a:buNone/>
-            </a:pPr>
-            <a:r>
-              <a:rPr lang="en-US" sz="950" dirty="0">
-                <a:solidFill>
-                  <a:srgbClr val="66BB6A"/>
-                </a:solidFill>
-                <a:latin typeface="Consolas" pitchFamily="34" charset="0"/>
-                <a:ea typeface="Consolas" pitchFamily="34" charset="-122"/>
-                <a:cs typeface="Consolas" pitchFamily="34" charset="-120"/>
-              </a:rPr>
-              <a:t>✅  Kapalı Döngü Tahmin:</a:t>
-            </a:r>
-            <a:endParaRPr lang="en-US" sz="950" dirty="0"/>
-          </a:p>
-          <a:p>
-            <a:pPr algn="l" indent="0" marL="0">
-              <a:buNone/>
-            </a:pPr>
-            <a:r>
-              <a:rPr lang="en-US" sz="950" dirty="0">
-                <a:solidFill>
-                  <a:srgbClr val="66BB6A"/>
-                </a:solidFill>
-                <a:latin typeface="Consolas" pitchFamily="34" charset="0"/>
-                <a:ea typeface="Consolas" pitchFamily="34" charset="-122"/>
-                <a:cs typeface="Consolas" pitchFamily="34" charset="-120"/>
-              </a:rPr>
-              <a:t>t→ predict(T_iç) → T_iç_yeni → t+1</a:t>
-            </a:r>
-            <a:endParaRPr lang="en-US" sz="950" dirty="0"/>
-          </a:p>
-        </p:txBody>
-      </p:sp>
-      <p:sp>
-        <p:nvSpPr>
-          <p:cNvPr id="22" name="Shape 20"/>
-          <p:cNvSpPr/>
-          <p:nvPr/>
-        </p:nvSpPr>
-        <p:spPr>
-          <a:xfrm>
-            <a:off x="201168" y="4114800"/>
-            <a:ext cx="2816352" cy="640080"/>
+            <a:ext cx="2816352" cy="566928"/>
           </a:xfrm>
           <a:prstGeom prst="rect">
             <a:avLst/>
@@ -4695,14 +4614,14 @@
       </p:sp>
       <p:sp>
         <p:nvSpPr>
-          <p:cNvPr id="23" name="Text 21"/>
-          <p:cNvSpPr/>
-          <p:nvPr/>
-        </p:nvSpPr>
-        <p:spPr>
-          <a:xfrm>
-            <a:off x="256032" y="4133088"/>
-            <a:ext cx="2724912" cy="594360"/>
+          <p:cNvPr id="21" name="Text 19"/>
+          <p:cNvSpPr/>
+          <p:nvPr/>
+        </p:nvSpPr>
+        <p:spPr>
+          <a:xfrm>
+            <a:off x="256032" y="3602736"/>
+            <a:ext cx="2724912" cy="530352"/>
           </a:xfrm>
           <a:prstGeom prst="rect">
             <a:avLst/>
@@ -4726,6 +4645,23 @@
                 <a:ea typeface="Calibri" pitchFamily="34" charset="-122"/>
                 <a:cs typeface="Calibri" pitchFamily="34" charset="-120"/>
               </a:rPr>
+              <a:t>Özellik Önemleri:</a:t>
+            </a:r>
+            <a:endParaRPr lang="en-US" sz="950" dirty="0"/>
+          </a:p>
+          <a:p>
+            <a:pPr algn="ctr" indent="0" marL="0">
+              <a:buNone/>
+            </a:pPr>
+            <a:r>
+              <a:rPr lang="en-US" sz="950" dirty="0">
+                <a:solidFill>
+                  <a:srgbClr val="8AB4D4"/>
+                </a:solidFill>
+                <a:latin typeface="Calibri" pitchFamily="34" charset="0"/>
+                <a:ea typeface="Calibri" pitchFamily="34" charset="-122"/>
+                <a:cs typeface="Calibri" pitchFamily="34" charset="-120"/>
+              </a:rPr>
               <a:t>T_iç ~35%  ·  T_dış ~28%</a:t>
             </a:r>
             <a:endParaRPr lang="en-US" sz="950" dirty="0"/>
@@ -4751,14 +4687,14 @@
       </p:sp>
       <p:sp>
         <p:nvSpPr>
-          <p:cNvPr id="24" name="Shape 22"/>
+          <p:cNvPr id="22" name="Shape 20"/>
           <p:cNvSpPr/>
           <p:nvPr/>
         </p:nvSpPr>
         <p:spPr>
           <a:xfrm>
             <a:off x="3163824" y="1481328"/>
-            <a:ext cx="2816352" cy="694944"/>
+            <a:ext cx="2816352" cy="713232"/>
           </a:xfrm>
           <a:prstGeom prst="rect">
             <a:avLst/>
@@ -4776,14 +4712,14 @@
       </p:sp>
       <p:sp>
         <p:nvSpPr>
-          <p:cNvPr id="25" name="Shape 23"/>
+          <p:cNvPr id="23" name="Shape 21"/>
           <p:cNvSpPr/>
           <p:nvPr/>
         </p:nvSpPr>
         <p:spPr>
           <a:xfrm>
             <a:off x="3163824" y="1481328"/>
-            <a:ext cx="64008" cy="694944"/>
+            <a:ext cx="64008" cy="713232"/>
           </a:xfrm>
           <a:prstGeom prst="rect">
             <a:avLst/>
@@ -4801,7 +4737,7 @@
       </p:sp>
       <p:sp>
         <p:nvSpPr>
-          <p:cNvPr id="26" name="Text 24"/>
+          <p:cNvPr id="24" name="Text 22"/>
           <p:cNvSpPr/>
           <p:nvPr/>
         </p:nvSpPr>
@@ -4840,14 +4776,14 @@
       </p:sp>
       <p:sp>
         <p:nvSpPr>
-          <p:cNvPr id="27" name="Text 25"/>
+          <p:cNvPr id="25" name="Text 23"/>
           <p:cNvSpPr/>
           <p:nvPr/>
         </p:nvSpPr>
         <p:spPr>
           <a:xfrm>
             <a:off x="3273552" y="1792224"/>
-            <a:ext cx="2651760" cy="329184"/>
+            <a:ext cx="2651760" cy="365760"/>
           </a:xfrm>
           <a:prstGeom prst="rect">
             <a:avLst/>
@@ -4871,7 +4807,7 @@
                 <a:ea typeface="Calibri" pitchFamily="34" charset="-122"/>
                 <a:cs typeface="Calibri" pitchFamily="34" charset="-120"/>
               </a:rPr>
-              <a:t>T_iç &gt; 26°C → güç artır</a:t>
+              <a:t>T_iç &gt; 26°C → orantılı güç</a:t>
             </a:r>
             <a:endParaRPr lang="en-US" sz="950" dirty="0"/>
           </a:p>
@@ -4888,7 +4824,7 @@
                 <a:ea typeface="Calibri" pitchFamily="34" charset="-122"/>
                 <a:cs typeface="Calibri" pitchFamily="34" charset="-120"/>
               </a:rPr>
-              <a:t>(Dijital İkiz'den T_iç alır)</a:t>
+              <a:t>(eşik: /2.0 agresif)</a:t>
             </a:r>
             <a:endParaRPr lang="en-US" sz="950" dirty="0"/>
           </a:p>
@@ -4896,13 +4832,13 @@
       </p:sp>
       <p:sp>
         <p:nvSpPr>
-          <p:cNvPr id="28" name="Text 26"/>
-          <p:cNvSpPr/>
-          <p:nvPr/>
-        </p:nvSpPr>
-        <p:spPr>
-          <a:xfrm>
-            <a:off x="4370832" y="2194560"/>
+          <p:cNvPr id="26" name="Text 24"/>
+          <p:cNvSpPr/>
+          <p:nvPr/>
+        </p:nvSpPr>
+        <p:spPr>
+          <a:xfrm>
+            <a:off x="4370832" y="2212848"/>
             <a:ext cx="402336" cy="128016"/>
           </a:xfrm>
           <a:prstGeom prst="rect">
@@ -4932,14 +4868,14 @@
       </p:sp>
       <p:sp>
         <p:nvSpPr>
-          <p:cNvPr id="29" name="Shape 27"/>
-          <p:cNvSpPr/>
-          <p:nvPr/>
-        </p:nvSpPr>
-        <p:spPr>
-          <a:xfrm>
-            <a:off x="3163824" y="2304288"/>
-            <a:ext cx="2816352" cy="694944"/>
+          <p:cNvPr id="27" name="Shape 25"/>
+          <p:cNvSpPr/>
+          <p:nvPr/>
+        </p:nvSpPr>
+        <p:spPr>
+          <a:xfrm>
+            <a:off x="3163824" y="2340864"/>
+            <a:ext cx="2816352" cy="713232"/>
           </a:xfrm>
           <a:prstGeom prst="rect">
             <a:avLst/>
@@ -4957,14 +4893,14 @@
       </p:sp>
       <p:sp>
         <p:nvSpPr>
-          <p:cNvPr id="30" name="Shape 28"/>
-          <p:cNvSpPr/>
-          <p:nvPr/>
-        </p:nvSpPr>
-        <p:spPr>
-          <a:xfrm>
-            <a:off x="3163824" y="2304288"/>
-            <a:ext cx="64008" cy="694944"/>
+          <p:cNvPr id="28" name="Shape 26"/>
+          <p:cNvSpPr/>
+          <p:nvPr/>
+        </p:nvSpPr>
+        <p:spPr>
+          <a:xfrm>
+            <a:off x="3163824" y="2340864"/>
+            <a:ext cx="64008" cy="713232"/>
           </a:xfrm>
           <a:prstGeom prst="rect">
             <a:avLst/>
@@ -4982,111 +4918,128 @@
       </p:sp>
       <p:sp>
         <p:nvSpPr>
+          <p:cNvPr id="29" name="Text 27"/>
+          <p:cNvSpPr/>
+          <p:nvPr/>
+        </p:nvSpPr>
+        <p:spPr>
+          <a:xfrm>
+            <a:off x="3273552" y="2395728"/>
+            <a:ext cx="2651760" cy="256032"/>
+          </a:xfrm>
+          <a:prstGeom prst="rect">
+            <a:avLst/>
+          </a:prstGeom>
+          <a:noFill/>
+          <a:ln/>
+        </p:spPr>
+        <p:txBody>
+          <a:bodyPr wrap="square" rtlCol="0" anchor="ctr"/>
+          <a:lstStyle/>
+          <a:p>
+            <a:pPr indent="0" marL="0">
+              <a:buNone/>
+            </a:pPr>
+            <a:r>
+              <a:rPr lang="en-US" sz="1150" b="1" dirty="0">
+                <a:solidFill>
+                  <a:srgbClr val="FFFFFF"/>
+                </a:solidFill>
+                <a:latin typeface="Calibri" pitchFamily="34" charset="0"/>
+                <a:ea typeface="Calibri" pitchFamily="34" charset="-122"/>
+                <a:cs typeface="Calibri" pitchFamily="34" charset="-120"/>
+              </a:rPr>
+              <a:t>🟢  Maliyet Ajanı</a:t>
+            </a:r>
+            <a:endParaRPr lang="en-US" sz="1150" dirty="0"/>
+          </a:p>
+        </p:txBody>
+      </p:sp>
+      <p:sp>
+        <p:nvSpPr>
+          <p:cNvPr id="30" name="Text 28"/>
+          <p:cNvSpPr/>
+          <p:nvPr/>
+        </p:nvSpPr>
+        <p:spPr>
+          <a:xfrm>
+            <a:off x="3273552" y="2651760"/>
+            <a:ext cx="2651760" cy="365760"/>
+          </a:xfrm>
+          <a:prstGeom prst="rect">
+            <a:avLst/>
+          </a:prstGeom>
+          <a:noFill/>
+          <a:ln/>
+        </p:spPr>
+        <p:txBody>
+          <a:bodyPr wrap="square" rtlCol="0" anchor="ctr"/>
+          <a:lstStyle/>
+          <a:p>
+            <a:pPr indent="0" marL="0">
+              <a:buNone/>
+            </a:pPr>
+            <a:r>
+              <a:rPr lang="en-US" sz="950" dirty="0">
+                <a:solidFill>
+                  <a:srgbClr val="8AB4D4"/>
+                </a:solidFill>
+                <a:latin typeface="Calibri" pitchFamily="34" charset="0"/>
+                <a:ea typeface="Calibri" pitchFamily="34" charset="-122"/>
+                <a:cs typeface="Calibri" pitchFamily="34" charset="-120"/>
+              </a:rPr>
+              <a:t>T_iç ≤ 26°C → standby</a:t>
+            </a:r>
+            <a:endParaRPr lang="en-US" sz="950" dirty="0"/>
+          </a:p>
+          <a:p>
+            <a:pPr indent="0" marL="0">
+              <a:buNone/>
+            </a:pPr>
+            <a:r>
+              <a:rPr lang="en-US" sz="950" dirty="0">
+                <a:solidFill>
+                  <a:srgbClr val="8AB4D4"/>
+                </a:solidFill>
+                <a:latin typeface="Calibri" pitchFamily="34" charset="0"/>
+                <a:ea typeface="Calibri" pitchFamily="34" charset="-122"/>
+                <a:cs typeface="Calibri" pitchFamily="34" charset="-120"/>
+              </a:rPr>
+              <a:t>Pik + sıcak → %35 güç</a:t>
+            </a:r>
+            <a:endParaRPr lang="en-US" sz="950" dirty="0"/>
+          </a:p>
+        </p:txBody>
+      </p:sp>
+      <p:sp>
+        <p:nvSpPr>
           <p:cNvPr id="31" name="Text 29"/>
           <p:cNvSpPr/>
           <p:nvPr/>
         </p:nvSpPr>
         <p:spPr>
           <a:xfrm>
-            <a:off x="3273552" y="2359152"/>
-            <a:ext cx="2651760" cy="256032"/>
-          </a:xfrm>
-          <a:prstGeom prst="rect">
-            <a:avLst/>
-          </a:prstGeom>
-          <a:noFill/>
-          <a:ln/>
-        </p:spPr>
-        <p:txBody>
-          <a:bodyPr wrap="square" rtlCol="0" anchor="ctr"/>
-          <a:lstStyle/>
-          <a:p>
-            <a:pPr indent="0" marL="0">
-              <a:buNone/>
-            </a:pPr>
-            <a:r>
-              <a:rPr lang="en-US" sz="1150" b="1" dirty="0">
-                <a:solidFill>
-                  <a:srgbClr val="FFFFFF"/>
-                </a:solidFill>
-                <a:latin typeface="Calibri" pitchFamily="34" charset="0"/>
-                <a:ea typeface="Calibri" pitchFamily="34" charset="-122"/>
-                <a:cs typeface="Calibri" pitchFamily="34" charset="-120"/>
-              </a:rPr>
-              <a:t>🟢  Maliyet Ajanı</a:t>
-            </a:r>
-            <a:endParaRPr lang="en-US" sz="1150" dirty="0"/>
-          </a:p>
-        </p:txBody>
-      </p:sp>
-      <p:sp>
-        <p:nvSpPr>
-          <p:cNvPr id="32" name="Text 30"/>
-          <p:cNvSpPr/>
-          <p:nvPr/>
-        </p:nvSpPr>
-        <p:spPr>
-          <a:xfrm>
-            <a:off x="3273552" y="2615184"/>
-            <a:ext cx="2651760" cy="329184"/>
-          </a:xfrm>
-          <a:prstGeom prst="rect">
-            <a:avLst/>
-          </a:prstGeom>
-          <a:noFill/>
-          <a:ln/>
-        </p:spPr>
-        <p:txBody>
-          <a:bodyPr wrap="square" rtlCol="0" anchor="ctr"/>
-          <a:lstStyle/>
-          <a:p>
-            <a:pPr indent="0" marL="0">
-              <a:buNone/>
-            </a:pPr>
-            <a:r>
-              <a:rPr lang="en-US" sz="950" dirty="0">
+            <a:off x="4370832" y="3072384"/>
+            <a:ext cx="402336" cy="128016"/>
+          </a:xfrm>
+          <a:prstGeom prst="rect">
+            <a:avLst/>
+          </a:prstGeom>
+          <a:noFill/>
+          <a:ln/>
+        </p:spPr>
+        <p:txBody>
+          <a:bodyPr wrap="square" rtlCol="0" anchor="ctr"/>
+          <a:lstStyle/>
+          <a:p>
+            <a:pPr algn="ctr" indent="0" marL="0">
+              <a:buNone/>
+            </a:pPr>
+            <a:r>
+              <a:rPr lang="en-US" sz="900" dirty="0">
                 <a:solidFill>
                   <a:srgbClr val="8AB4D4"/>
                 </a:solidFill>
-                <a:latin typeface="Calibri" pitchFamily="34" charset="0"/>
-                <a:ea typeface="Calibri" pitchFamily="34" charset="-122"/>
-                <a:cs typeface="Calibri" pitchFamily="34" charset="-120"/>
-              </a:rPr>
-              <a:t>Pik tarife → güç düşür</a:t>
-            </a:r>
-            <a:endParaRPr lang="en-US" sz="950" dirty="0"/>
-          </a:p>
-        </p:txBody>
-      </p:sp>
-      <p:sp>
-        <p:nvSpPr>
-          <p:cNvPr id="33" name="Text 31"/>
-          <p:cNvSpPr/>
-          <p:nvPr/>
-        </p:nvSpPr>
-        <p:spPr>
-          <a:xfrm>
-            <a:off x="4370832" y="3017520"/>
-            <a:ext cx="402336" cy="128016"/>
-          </a:xfrm>
-          <a:prstGeom prst="rect">
-            <a:avLst/>
-          </a:prstGeom>
-          <a:noFill/>
-          <a:ln/>
-        </p:spPr>
-        <p:txBody>
-          <a:bodyPr wrap="square" rtlCol="0" anchor="ctr"/>
-          <a:lstStyle/>
-          <a:p>
-            <a:pPr algn="ctr" indent="0" marL="0">
-              <a:buNone/>
-            </a:pPr>
-            <a:r>
-              <a:rPr lang="en-US" sz="900" dirty="0">
-                <a:solidFill>
-                  <a:srgbClr val="8AB4D4"/>
-                </a:solidFill>
               </a:rPr>
               <a:t>▼</a:t>
             </a:r>
@@ -5096,14 +5049,14 @@
       </p:sp>
       <p:sp>
         <p:nvSpPr>
-          <p:cNvPr id="34" name="Shape 32"/>
-          <p:cNvSpPr/>
-          <p:nvPr/>
-        </p:nvSpPr>
-        <p:spPr>
-          <a:xfrm>
-            <a:off x="3163824" y="3127248"/>
-            <a:ext cx="2816352" cy="694944"/>
+          <p:cNvPr id="32" name="Shape 30"/>
+          <p:cNvSpPr/>
+          <p:nvPr/>
+        </p:nvSpPr>
+        <p:spPr>
+          <a:xfrm>
+            <a:off x="3163824" y="3200400"/>
+            <a:ext cx="2816352" cy="713232"/>
           </a:xfrm>
           <a:prstGeom prst="rect">
             <a:avLst/>
@@ -5121,14 +5074,14 @@
       </p:sp>
       <p:sp>
         <p:nvSpPr>
-          <p:cNvPr id="35" name="Shape 33"/>
-          <p:cNvSpPr/>
-          <p:nvPr/>
-        </p:nvSpPr>
-        <p:spPr>
-          <a:xfrm>
-            <a:off x="3163824" y="3127248"/>
-            <a:ext cx="64008" cy="694944"/>
+          <p:cNvPr id="33" name="Shape 31"/>
+          <p:cNvSpPr/>
+          <p:nvPr/>
+        </p:nvSpPr>
+        <p:spPr>
+          <a:xfrm>
+            <a:off x="3163824" y="3200400"/>
+            <a:ext cx="64008" cy="713232"/>
           </a:xfrm>
           <a:prstGeom prst="rect">
             <a:avLst/>
@@ -5146,13 +5099,13 @@
       </p:sp>
       <p:sp>
         <p:nvSpPr>
-          <p:cNvPr id="36" name="Text 34"/>
-          <p:cNvSpPr/>
-          <p:nvPr/>
-        </p:nvSpPr>
-        <p:spPr>
-          <a:xfrm>
-            <a:off x="3273552" y="3182112"/>
+          <p:cNvPr id="34" name="Text 32"/>
+          <p:cNvSpPr/>
+          <p:nvPr/>
+        </p:nvSpPr>
+        <p:spPr>
+          <a:xfrm>
+            <a:off x="3273552" y="3255264"/>
             <a:ext cx="2651760" cy="256032"/>
           </a:xfrm>
           <a:prstGeom prst="rect">
@@ -5185,14 +5138,14 @@
       </p:sp>
       <p:sp>
         <p:nvSpPr>
-          <p:cNvPr id="37" name="Text 35"/>
-          <p:cNvSpPr/>
-          <p:nvPr/>
-        </p:nvSpPr>
-        <p:spPr>
-          <a:xfrm>
-            <a:off x="3273552" y="3438144"/>
-            <a:ext cx="2651760" cy="329184"/>
+          <p:cNvPr id="35" name="Text 33"/>
+          <p:cNvSpPr/>
+          <p:nvPr/>
+        </p:nvSpPr>
+        <p:spPr>
+          <a:xfrm>
+            <a:off x="3273552" y="3511296"/>
+            <a:ext cx="2651760" cy="365760"/>
           </a:xfrm>
           <a:prstGeom prst="rect">
             <a:avLst/>
@@ -5216,22 +5169,39 @@
                 <a:ea typeface="Calibri" pitchFamily="34" charset="-122"/>
                 <a:cs typeface="Calibri" pitchFamily="34" charset="-120"/>
               </a:rPr>
-              <a:t>Boş bina → standby</a:t>
+              <a:t>T_iç ≤ 26°C → standby</a:t>
             </a:r>
             <a:endParaRPr lang="en-US" sz="950" dirty="0"/>
           </a:p>
-        </p:txBody>
-      </p:sp>
-      <p:sp>
-        <p:nvSpPr>
-          <p:cNvPr id="38" name="Shape 36"/>
-          <p:cNvSpPr/>
-          <p:nvPr/>
-        </p:nvSpPr>
-        <p:spPr>
-          <a:xfrm>
-            <a:off x="3163824" y="3986784"/>
-            <a:ext cx="2816352" cy="786384"/>
+          <a:p>
+            <a:pPr indent="0" marL="0">
+              <a:buNone/>
+            </a:pPr>
+            <a:r>
+              <a:rPr lang="en-US" sz="950" dirty="0">
+                <a:solidFill>
+                  <a:srgbClr val="8AB4D4"/>
+                </a:solidFill>
+                <a:latin typeface="Calibri" pitchFamily="34" charset="0"/>
+                <a:ea typeface="Calibri" pitchFamily="34" charset="-122"/>
+                <a:cs typeface="Calibri" pitchFamily="34" charset="-120"/>
+              </a:rPr>
+              <a:t>Sıcak → %35 güç</a:t>
+            </a:r>
+            <a:endParaRPr lang="en-US" sz="950" dirty="0"/>
+          </a:p>
+        </p:txBody>
+      </p:sp>
+      <p:sp>
+        <p:nvSpPr>
+          <p:cNvPr id="36" name="Shape 34"/>
+          <p:cNvSpPr/>
+          <p:nvPr/>
+        </p:nvSpPr>
+        <p:spPr>
+          <a:xfrm>
+            <a:off x="3163824" y="4078224"/>
+            <a:ext cx="2816352" cy="713232"/>
           </a:xfrm>
           <a:prstGeom prst="rect">
             <a:avLst/>
@@ -5256,13 +5226,13 @@
       </p:sp>
       <p:sp>
         <p:nvSpPr>
-          <p:cNvPr id="39" name="Text 37"/>
-          <p:cNvSpPr/>
-          <p:nvPr/>
-        </p:nvSpPr>
-        <p:spPr>
-          <a:xfrm>
-            <a:off x="3218688" y="4005072"/>
+          <p:cNvPr id="37" name="Text 35"/>
+          <p:cNvSpPr/>
+          <p:nvPr/>
+        </p:nvSpPr>
+        <p:spPr>
+          <a:xfrm>
+            <a:off x="3218688" y="4096512"/>
             <a:ext cx="2724912" cy="256032"/>
           </a:xfrm>
           <a:prstGeom prst="rect">
@@ -5295,14 +5265,14 @@
       </p:sp>
       <p:sp>
         <p:nvSpPr>
-          <p:cNvPr id="40" name="Text 38"/>
-          <p:cNvSpPr/>
-          <p:nvPr/>
-        </p:nvSpPr>
-        <p:spPr>
-          <a:xfrm>
-            <a:off x="3218688" y="4261104"/>
-            <a:ext cx="2724912" cy="438912"/>
+          <p:cNvPr id="38" name="Text 36"/>
+          <p:cNvSpPr/>
+          <p:nvPr/>
+        </p:nvSpPr>
+        <p:spPr>
+          <a:xfrm>
+            <a:off x="3218688" y="4352544"/>
+            <a:ext cx="2724912" cy="402336"/>
           </a:xfrm>
           <a:prstGeom prst="rect">
             <a:avLst/>
@@ -5318,7 +5288,7 @@
               <a:buNone/>
             </a:pPr>
             <a:r>
-              <a:rPr lang="en-US" sz="1000" i="1" dirty="0">
+              <a:rPr lang="en-US" sz="950" dirty="0">
                 <a:solidFill>
                   <a:srgbClr val="FFFFFF"/>
                 </a:solidFill>
@@ -5328,20 +5298,37 @@
               </a:rPr>
               <a:t>P = w₁·Pk + w₂·Pm + w₃·Ps</a:t>
             </a:r>
-            <a:endParaRPr lang="en-US" sz="1000" dirty="0"/>
-          </a:p>
-        </p:txBody>
-      </p:sp>
-      <p:sp>
-        <p:nvSpPr>
-          <p:cNvPr id="41" name="Shape 39"/>
+            <a:endParaRPr lang="en-US" sz="950" dirty="0"/>
+          </a:p>
+          <a:p>
+            <a:pPr algn="ctr" indent="0" marL="0">
+              <a:buNone/>
+            </a:pPr>
+            <a:r>
+              <a:rPr lang="en-US" sz="950" dirty="0">
+                <a:solidFill>
+                  <a:srgbClr val="FFFFFF"/>
+                </a:solidFill>
+                <a:latin typeface="Consolas" pitchFamily="34" charset="0"/>
+                <a:ea typeface="Consolas" pitchFamily="34" charset="-122"/>
+                <a:cs typeface="Consolas" pitchFamily="34" charset="-120"/>
+              </a:rPr>
+              <a:t>Tüm eşikler 26°C ile hizalandı ✅</a:t>
+            </a:r>
+            <a:endParaRPr lang="en-US" sz="950" dirty="0"/>
+          </a:p>
+        </p:txBody>
+      </p:sp>
+      <p:sp>
+        <p:nvSpPr>
+          <p:cNvPr id="39" name="Shape 37"/>
           <p:cNvSpPr/>
           <p:nvPr/>
         </p:nvSpPr>
         <p:spPr>
           <a:xfrm>
             <a:off x="6126480" y="1463040"/>
-            <a:ext cx="2816352" cy="694944"/>
+            <a:ext cx="2816352" cy="713232"/>
           </a:xfrm>
           <a:prstGeom prst="rect">
             <a:avLst/>
@@ -5359,14 +5346,14 @@
       </p:sp>
       <p:sp>
         <p:nvSpPr>
-          <p:cNvPr id="42" name="Text 40"/>
+          <p:cNvPr id="40" name="Text 38"/>
           <p:cNvSpPr/>
           <p:nvPr/>
         </p:nvSpPr>
         <p:spPr>
           <a:xfrm>
             <a:off x="6181344" y="1517904"/>
-            <a:ext cx="2706624" cy="585216"/>
+            <a:ext cx="2706624" cy="603504"/>
           </a:xfrm>
           <a:prstGeom prst="rect">
             <a:avLst/>
@@ -5390,7 +5377,7 @@
                 <a:ea typeface="Calibri" pitchFamily="34" charset="-122"/>
                 <a:cs typeface="Calibri" pitchFamily="34" charset="-120"/>
               </a:rPr>
-              <a:t>Gerçek IoT Verisi (UCI)</a:t>
+              <a:t>Pecan Street Dataport</a:t>
             </a:r>
             <a:endParaRPr lang="en-US" sz="1050" dirty="0"/>
           </a:p>
@@ -5407,7 +5394,7 @@
                 <a:ea typeface="Calibri" pitchFamily="34" charset="-122"/>
                 <a:cs typeface="Calibri" pitchFamily="34" charset="-120"/>
               </a:rPr>
-              <a:t>Belçika evi · 4,5 ay · 10 dk'lık</a:t>
+              <a:t>25 ev · Austin TX · 2018 · 15 dk</a:t>
             </a:r>
             <a:endParaRPr lang="en-US" sz="1050" dirty="0"/>
           </a:p>
@@ -5415,13 +5402,13 @@
       </p:sp>
       <p:sp>
         <p:nvSpPr>
-          <p:cNvPr id="43" name="Text 41"/>
-          <p:cNvSpPr/>
-          <p:nvPr/>
-        </p:nvSpPr>
-        <p:spPr>
-          <a:xfrm>
-            <a:off x="7333488" y="2176272"/>
+          <p:cNvPr id="41" name="Text 39"/>
+          <p:cNvSpPr/>
+          <p:nvPr/>
+        </p:nvSpPr>
+        <p:spPr>
+          <a:xfrm>
+            <a:off x="7333488" y="2194560"/>
             <a:ext cx="402336" cy="128016"/>
           </a:xfrm>
           <a:prstGeom prst="rect">
@@ -5451,14 +5438,14 @@
       </p:sp>
       <p:sp>
         <p:nvSpPr>
-          <p:cNvPr id="44" name="Shape 42"/>
+          <p:cNvPr id="42" name="Shape 40"/>
           <p:cNvSpPr/>
           <p:nvPr/>
         </p:nvSpPr>
         <p:spPr>
           <a:xfrm>
             <a:off x="6126480" y="2322576"/>
-            <a:ext cx="2816352" cy="694944"/>
+            <a:ext cx="2816352" cy="713232"/>
           </a:xfrm>
           <a:prstGeom prst="rect">
             <a:avLst/>
@@ -5476,14 +5463,14 @@
       </p:sp>
       <p:sp>
         <p:nvSpPr>
-          <p:cNvPr id="45" name="Text 43"/>
+          <p:cNvPr id="43" name="Text 41"/>
           <p:cNvSpPr/>
           <p:nvPr/>
         </p:nvSpPr>
         <p:spPr>
           <a:xfrm>
             <a:off x="6181344" y="2377440"/>
-            <a:ext cx="2706624" cy="585216"/>
+            <a:ext cx="2706624" cy="603504"/>
           </a:xfrm>
           <a:prstGeom prst="rect">
             <a:avLst/>
@@ -5499,83 +5486,83 @@
               <a:buNone/>
             </a:pPr>
             <a:r>
+              <a:rPr lang="en-US" sz="1050" dirty="0">
+                <a:solidFill>
+                  <a:srgbClr val="FFFFFF"/>
+                </a:solidFill>
+                <a:latin typeface="Calibri" pitchFamily="34" charset="0"/>
+                <a:ea typeface="Calibri" pitchFamily="34" charset="-122"/>
+                <a:cs typeface="Calibri" pitchFamily="34" charset="-120"/>
+              </a:rPr>
+              <a:t>Gerçek air1 (AC gücü, kW)</a:t>
+            </a:r>
+            <a:endParaRPr lang="en-US" sz="1050" dirty="0"/>
+          </a:p>
+          <a:p>
+            <a:pPr algn="ctr" indent="0" marL="0">
+              <a:buNone/>
+            </a:pPr>
+            <a:r>
+              <a:rPr lang="en-US" sz="1050" dirty="0">
+                <a:solidFill>
+                  <a:srgbClr val="FFFFFF"/>
+                </a:solidFill>
+                <a:latin typeface="Calibri" pitchFamily="34" charset="0"/>
+                <a:ea typeface="Calibri" pitchFamily="34" charset="-122"/>
+                <a:cs typeface="Calibri" pitchFamily="34" charset="-120"/>
+              </a:rPr>
+              <a:t>Devre seviyesi ölçüm</a:t>
+            </a:r>
+            <a:endParaRPr lang="en-US" sz="1050" dirty="0"/>
+          </a:p>
+        </p:txBody>
+      </p:sp>
+      <p:sp>
+        <p:nvSpPr>
+          <p:cNvPr id="44" name="Text 42"/>
+          <p:cNvSpPr/>
+          <p:nvPr/>
+        </p:nvSpPr>
+        <p:spPr>
+          <a:xfrm>
+            <a:off x="7333488" y="3054096"/>
+            <a:ext cx="402336" cy="128016"/>
+          </a:xfrm>
+          <a:prstGeom prst="rect">
+            <a:avLst/>
+          </a:prstGeom>
+          <a:noFill/>
+          <a:ln/>
+        </p:spPr>
+        <p:txBody>
+          <a:bodyPr wrap="square" rtlCol="0" anchor="ctr"/>
+          <a:lstStyle/>
+          <a:p>
+            <a:pPr algn="ctr" indent="0" marL="0">
+              <a:buNone/>
+            </a:pPr>
+            <a:r>
               <a:rPr lang="en-US" sz="900" dirty="0">
                 <a:solidFill>
-                  <a:srgbClr val="FFFFFF"/>
-                </a:solidFill>
-                <a:latin typeface="Consolas" pitchFamily="34" charset="0"/>
-                <a:ea typeface="Consolas" pitchFamily="34" charset="-122"/>
-                <a:cs typeface="Consolas" pitchFamily="34" charset="-120"/>
-              </a:rPr>
-              <a:t>Isı Dengesi Denklemi</a:t>
+                  <a:srgbClr val="8AB4D4"/>
+                </a:solidFill>
+              </a:rPr>
+              <a:t>▼</a:t>
             </a:r>
             <a:endParaRPr lang="en-US" sz="900" dirty="0"/>
           </a:p>
-          <a:p>
-            <a:pPr algn="ctr" indent="0" marL="0">
-              <a:buNone/>
-            </a:pPr>
-            <a:r>
-              <a:rPr lang="en-US" sz="900" dirty="0">
-                <a:solidFill>
-                  <a:srgbClr val="FFFFFF"/>
-                </a:solidFill>
-                <a:latin typeface="Consolas" pitchFamily="34" charset="0"/>
-                <a:ea typeface="Consolas" pitchFamily="34" charset="-122"/>
-                <a:cs typeface="Consolas" pitchFamily="34" charset="-120"/>
-              </a:rPr>
-              <a:t>T_iç[t+1]=T_iç[t]+α(T_dış−T_iç)+β·N−γ·P</a:t>
-            </a:r>
-            <a:endParaRPr lang="en-US" sz="900" dirty="0"/>
-          </a:p>
-        </p:txBody>
-      </p:sp>
-      <p:sp>
-        <p:nvSpPr>
-          <p:cNvPr id="46" name="Text 44"/>
-          <p:cNvSpPr/>
-          <p:nvPr/>
-        </p:nvSpPr>
-        <p:spPr>
-          <a:xfrm>
-            <a:off x="7333488" y="3035808"/>
-            <a:ext cx="402336" cy="128016"/>
-          </a:xfrm>
-          <a:prstGeom prst="rect">
-            <a:avLst/>
-          </a:prstGeom>
-          <a:noFill/>
-          <a:ln/>
-        </p:spPr>
-        <p:txBody>
-          <a:bodyPr wrap="square" rtlCol="0" anchor="ctr"/>
-          <a:lstStyle/>
-          <a:p>
-            <a:pPr algn="ctr" indent="0" marL="0">
-              <a:buNone/>
-            </a:pPr>
-            <a:r>
-              <a:rPr lang="en-US" sz="900" dirty="0">
-                <a:solidFill>
-                  <a:srgbClr val="8AB4D4"/>
-                </a:solidFill>
-              </a:rPr>
-              <a:t>▼</a:t>
-            </a:r>
-            <a:endParaRPr lang="en-US" sz="900" dirty="0"/>
-          </a:p>
-        </p:txBody>
-      </p:sp>
-      <p:sp>
-        <p:nvSpPr>
-          <p:cNvPr id="47" name="Shape 45"/>
+        </p:txBody>
+      </p:sp>
+      <p:sp>
+        <p:nvSpPr>
+          <p:cNvPr id="45" name="Shape 43"/>
           <p:cNvSpPr/>
           <p:nvPr/>
         </p:nvSpPr>
         <p:spPr>
           <a:xfrm>
             <a:off x="6126480" y="3182112"/>
-            <a:ext cx="2816352" cy="694944"/>
+            <a:ext cx="2816352" cy="713232"/>
           </a:xfrm>
           <a:prstGeom prst="rect">
             <a:avLst/>
@@ -5593,14 +5580,14 @@
       </p:sp>
       <p:sp>
         <p:nvSpPr>
-          <p:cNvPr id="48" name="Text 46"/>
+          <p:cNvPr id="46" name="Text 44"/>
           <p:cNvSpPr/>
           <p:nvPr/>
         </p:nvSpPr>
         <p:spPr>
           <a:xfrm>
             <a:off x="6181344" y="3236976"/>
-            <a:ext cx="2706624" cy="585216"/>
+            <a:ext cx="2706624" cy="603504"/>
           </a:xfrm>
           <a:prstGeom prst="rect">
             <a:avLst/>
@@ -5616,46 +5603,46 @@
               <a:buNone/>
             </a:pPr>
             <a:r>
-              <a:rPr lang="en-US" sz="1050" dirty="0">
+              <a:rPr lang="en-US" sz="850" dirty="0">
                 <a:solidFill>
                   <a:srgbClr val="FFFFFF"/>
                 </a:solidFill>
-                <a:latin typeface="Calibri" pitchFamily="34" charset="0"/>
-                <a:ea typeface="Calibri" pitchFamily="34" charset="-122"/>
-                <a:cs typeface="Calibri" pitchFamily="34" charset="-120"/>
-              </a:rPr>
-              <a:t>İç Sıcaklık Simülasyonu</a:t>
-            </a:r>
-            <a:endParaRPr lang="en-US" sz="1050" dirty="0"/>
+                <a:latin typeface="Consolas" pitchFamily="34" charset="0"/>
+                <a:ea typeface="Consolas" pitchFamily="34" charset="-122"/>
+                <a:cs typeface="Consolas" pitchFamily="34" charset="-120"/>
+              </a:rPr>
+              <a:t>Isı Dengesi (γ=2.0 düzeltildi)</a:t>
+            </a:r>
+            <a:endParaRPr lang="en-US" sz="850" dirty="0"/>
           </a:p>
           <a:p>
             <a:pPr algn="ctr" indent="0" marL="0">
               <a:buNone/>
             </a:pPr>
             <a:r>
-              <a:rPr lang="en-US" sz="1050" dirty="0">
+              <a:rPr lang="en-US" sz="850" dirty="0">
                 <a:solidFill>
                   <a:srgbClr val="FFFFFF"/>
                 </a:solidFill>
-                <a:latin typeface="Calibri" pitchFamily="34" charset="0"/>
-                <a:ea typeface="Calibri" pitchFamily="34" charset="-122"/>
-                <a:cs typeface="Calibri" pitchFamily="34" charset="-120"/>
-              </a:rPr>
-              <a:t>(Kapalı döngü — tüm sistemler)</a:t>
-            </a:r>
-            <a:endParaRPr lang="en-US" sz="1050" dirty="0"/>
-          </a:p>
-        </p:txBody>
-      </p:sp>
-      <p:sp>
-        <p:nvSpPr>
-          <p:cNvPr id="49" name="Text 47"/>
-          <p:cNvSpPr/>
-          <p:nvPr/>
-        </p:nvSpPr>
-        <p:spPr>
-          <a:xfrm>
-            <a:off x="7333488" y="3895344"/>
+                <a:latin typeface="Consolas" pitchFamily="34" charset="0"/>
+                <a:ea typeface="Consolas" pitchFamily="34" charset="-122"/>
+                <a:cs typeface="Consolas" pitchFamily="34" charset="-120"/>
+              </a:rPr>
+              <a:t>T_iç[t+1]=T_iç+α(T_dış−T_iç)+β·N−γ·P</a:t>
+            </a:r>
+            <a:endParaRPr lang="en-US" sz="850" dirty="0"/>
+          </a:p>
+        </p:txBody>
+      </p:sp>
+      <p:sp>
+        <p:nvSpPr>
+          <p:cNvPr id="47" name="Text 45"/>
+          <p:cNvSpPr/>
+          <p:nvPr/>
+        </p:nvSpPr>
+        <p:spPr>
+          <a:xfrm>
+            <a:off x="7333488" y="3913632"/>
             <a:ext cx="402336" cy="128016"/>
           </a:xfrm>
           <a:prstGeom prst="rect">
@@ -5685,14 +5672,14 @@
       </p:sp>
       <p:sp>
         <p:nvSpPr>
-          <p:cNvPr id="50" name="Shape 48"/>
+          <p:cNvPr id="48" name="Shape 46"/>
           <p:cNvSpPr/>
           <p:nvPr/>
         </p:nvSpPr>
         <p:spPr>
           <a:xfrm>
             <a:off x="6126480" y="4041648"/>
-            <a:ext cx="2816352" cy="694944"/>
+            <a:ext cx="2816352" cy="713232"/>
           </a:xfrm>
           <a:prstGeom prst="rect">
             <a:avLst/>
@@ -5710,14 +5697,14 @@
       </p:sp>
       <p:sp>
         <p:nvSpPr>
-          <p:cNvPr id="51" name="Text 49"/>
+          <p:cNvPr id="49" name="Text 47"/>
           <p:cNvSpPr/>
           <p:nvPr/>
         </p:nvSpPr>
         <p:spPr>
           <a:xfrm>
             <a:off x="6181344" y="4096512"/>
-            <a:ext cx="2706624" cy="585216"/>
+            <a:ext cx="2706624" cy="603504"/>
           </a:xfrm>
           <a:prstGeom prst="rect">
             <a:avLst/>
@@ -5741,7 +5728,7 @@
                 <a:ea typeface="Calibri" pitchFamily="34" charset="-122"/>
                 <a:cs typeface="Calibri" pitchFamily="34" charset="-120"/>
               </a:rPr>
-              <a:t>Validasyon: MAE · RMSE · R²</a:t>
+              <a:t>Pearson Korelasyon</a:t>
             </a:r>
             <a:endParaRPr lang="en-US" sz="1050" dirty="0"/>
           </a:p>
@@ -5758,7 +5745,7 @@
                 <a:ea typeface="Calibri" pitchFamily="34" charset="-122"/>
                 <a:cs typeface="Calibri" pitchFamily="34" charset="-120"/>
               </a:rPr>
-              <a:t>⚠ P_klima=0 sınırlılığı belgelendi</a:t>
+              <a:t>+ Normalize Profil Karşılaştırması</a:t>
             </a:r>
             <a:endParaRPr lang="en-US" sz="1050" dirty="0"/>
           </a:p>
@@ -5766,7 +5753,7 @@
       </p:sp>
       <p:sp>
         <p:nvSpPr>
-          <p:cNvPr id="52" name="Text 50"/>
+          <p:cNvPr id="50" name="Text 48"/>
           <p:cNvSpPr/>
           <p:nvPr/>
         </p:nvSpPr>
@@ -5802,7 +5789,7 @@
       </p:sp>
       <p:sp>
         <p:nvSpPr>
-          <p:cNvPr id="53" name="Text 51"/>
+          <p:cNvPr id="51" name="Text 49"/>
           <p:cNvSpPr/>
           <p:nvPr/>
         </p:nvSpPr>
@@ -5838,7 +5825,7 @@
       </p:sp>
       <p:sp>
         <p:nvSpPr>
-          <p:cNvPr id="54" name="Text 52"/>
+          <p:cNvPr id="52" name="Text 50"/>
           <p:cNvSpPr/>
           <p:nvPr/>
         </p:nvSpPr>
@@ -5874,7 +5861,7 @@
       </p:sp>
       <p:sp>
         <p:nvSpPr>
-          <p:cNvPr id="55" name="Shape 53"/>
+          <p:cNvPr id="53" name="Shape 51"/>
           <p:cNvSpPr/>
           <p:nvPr/>
         </p:nvSpPr>
@@ -5899,7 +5886,7 @@
       </p:sp>
       <p:sp>
         <p:nvSpPr>
-          <p:cNvPr id="56" name="Text 54"/>
+          <p:cNvPr id="54" name="Text 52"/>
           <p:cNvSpPr/>
           <p:nvPr/>
         </p:nvSpPr>
@@ -6451,7 +6438,7 @@
                 <a:ea typeface="Calibri" pitchFamily="34" charset="-122"/>
                 <a:cs typeface="Calibri" pitchFamily="34" charset="-120"/>
               </a:rPr>
-              <a:t>R²≈0.90</a:t>
+              <a:t>Pearson</a:t>
             </a:r>
             <a:endParaRPr lang="en-US" sz="2200" dirty="0"/>
           </a:p>
@@ -6507,7 +6494,7 @@
                 <a:ea typeface="Calibri" pitchFamily="34" charset="-122"/>
                 <a:cs typeface="Calibri" pitchFamily="34" charset="-120"/>
               </a:rPr>
-              <a:t>Doğruluk Skoru</a:t>
+              <a:t>Korelasyon</a:t>
             </a:r>
             <a:endParaRPr lang="en-US" sz="1100" dirty="0"/>
           </a:p>
@@ -6731,7 +6718,7 @@
         <p:spPr>
           <a:xfrm>
             <a:off x="384048" y="2761488"/>
-            <a:ext cx="4352544" cy="347472"/>
+            <a:ext cx="4352544" cy="320040"/>
           </a:xfrm>
           <a:prstGeom prst="rect">
             <a:avLst/>
@@ -6747,7 +6734,7 @@
               <a:buNone/>
             </a:pPr>
             <a:r>
-              <a:rPr lang="en-US" sz="1300" b="1" dirty="0">
+              <a:rPr lang="en-US" sz="1250" b="1" dirty="0">
                 <a:solidFill>
                   <a:srgbClr val="66BB6A"/>
                 </a:solidFill>
@@ -6755,9 +6742,9 @@
                 <a:ea typeface="Calibri" pitchFamily="34" charset="-122"/>
                 <a:cs typeface="Calibri" pitchFamily="34" charset="-120"/>
               </a:rPr>
-              <a:t>✅  Uygulanan Teknik Düzeltmeler</a:t>
-            </a:r>
-            <a:endParaRPr lang="en-US" sz="1300" dirty="0"/>
+              <a:t>✅  Uygulanan Teknik Düzeltmeler (8 Madde)</a:t>
+            </a:r>
+            <a:endParaRPr lang="en-US" sz="1250" dirty="0"/>
           </a:p>
         </p:txBody>
       </p:sp>
@@ -6769,8 +6756,8 @@
         </p:nvSpPr>
         <p:spPr>
           <a:xfrm>
-            <a:off x="384048" y="3154680"/>
-            <a:ext cx="4352544" cy="365760"/>
+            <a:off x="384048" y="3108960"/>
+            <a:ext cx="4352544" cy="219456"/>
           </a:xfrm>
           <a:prstGeom prst="rect">
             <a:avLst/>
@@ -6786,7 +6773,7 @@
               <a:buNone/>
             </a:pPr>
             <a:r>
-              <a:rPr lang="en-US" sz="1150" dirty="0">
+              <a:rPr lang="en-US" sz="1000" dirty="0">
                 <a:solidFill>
                   <a:srgbClr val="FFFFFF"/>
                 </a:solidFill>
@@ -6794,9 +6781,9 @@
                 <a:ea typeface="Calibri" pitchFamily="34" charset="-122"/>
                 <a:cs typeface="Calibri" pitchFamily="34" charset="-120"/>
               </a:rPr>
-              <a:t>1. ML Kapalı Döngü: T_iç her saatte modele besleniyor</a:t>
-            </a:r>
-            <a:endParaRPr lang="en-US" sz="1150" dirty="0"/>
+              <a:t>1. ML: T_iç özelliği + kapalı döngü eğitim &amp; tahmin</a:t>
+            </a:r>
+            <a:endParaRPr lang="en-US" sz="1000" dirty="0"/>
           </a:p>
         </p:txBody>
       </p:sp>
@@ -6808,8 +6795,47 @@
         </p:nvSpPr>
         <p:spPr>
           <a:xfrm>
+            <a:off x="384048" y="3346704"/>
+            <a:ext cx="4352544" cy="219456"/>
+          </a:xfrm>
+          <a:prstGeom prst="rect">
+            <a:avLst/>
+          </a:prstGeom>
+          <a:noFill/>
+          <a:ln/>
+        </p:spPr>
+        <p:txBody>
+          <a:bodyPr wrap="square" rtlCol="0" anchor="ctr"/>
+          <a:lstStyle/>
+          <a:p>
+            <a:pPr algn="l" indent="0" marL="0">
+              <a:buNone/>
+            </a:pPr>
+            <a:r>
+              <a:rPr lang="en-US" sz="1000" dirty="0">
+                <a:solidFill>
+                  <a:srgbClr val="FFFFFF"/>
+                </a:solidFill>
+                <a:latin typeface="Calibri" pitchFamily="34" charset="0"/>
+                <a:ea typeface="Calibri" pitchFamily="34" charset="-122"/>
+                <a:cs typeface="Calibri" pitchFamily="34" charset="-120"/>
+              </a:rPr>
+              <a:t>2. Geleneksel: histerezis (25°C aç / 22°C kapat)</a:t>
+            </a:r>
+            <a:endParaRPr lang="en-US" sz="1000" dirty="0"/>
+          </a:p>
+        </p:txBody>
+      </p:sp>
+      <p:sp>
+        <p:nvSpPr>
+          <p:cNvPr id="26" name="Text 24"/>
+          <p:cNvSpPr/>
+          <p:nvPr/>
+        </p:nvSpPr>
+        <p:spPr>
+          <a:xfrm>
             <a:off x="384048" y="3584448"/>
-            <a:ext cx="4352544" cy="365760"/>
+            <a:ext cx="4352544" cy="219456"/>
           </a:xfrm>
           <a:prstGeom prst="rect">
             <a:avLst/>
@@ -6825,7 +6851,7 @@
               <a:buNone/>
             </a:pPr>
             <a:r>
-              <a:rPr lang="en-US" sz="1150" dirty="0">
+              <a:rPr lang="en-US" sz="1000" dirty="0">
                 <a:solidFill>
                   <a:srgbClr val="FFFFFF"/>
                 </a:solidFill>
@@ -6833,22 +6859,22 @@
                 <a:ea typeface="Calibri" pitchFamily="34" charset="-122"/>
                 <a:cs typeface="Calibri" pitchFamily="34" charset="-120"/>
               </a:rPr>
-              <a:t>2. T_iç Özelliği: fiyat değil konfor durumu birincil kriter</a:t>
-            </a:r>
-            <a:endParaRPr lang="en-US" sz="1150" dirty="0"/>
-          </a:p>
-        </p:txBody>
-      </p:sp>
-      <p:sp>
-        <p:nvSpPr>
-          <p:cNvPr id="26" name="Text 24"/>
-          <p:cNvSpPr/>
-          <p:nvPr/>
-        </p:nvSpPr>
-        <p:spPr>
-          <a:xfrm>
-            <a:off x="384048" y="4014216"/>
-            <a:ext cx="4352544" cy="365760"/>
+              <a:t>3. Konfor Ajanı: agresif yanıt (bölen 6→2)</a:t>
+            </a:r>
+            <a:endParaRPr lang="en-US" sz="1000" dirty="0"/>
+          </a:p>
+        </p:txBody>
+      </p:sp>
+      <p:sp>
+        <p:nvSpPr>
+          <p:cNvPr id="27" name="Text 25"/>
+          <p:cNvSpPr/>
+          <p:nvPr/>
+        </p:nvSpPr>
+        <p:spPr>
+          <a:xfrm>
+            <a:off x="384048" y="3822192"/>
+            <a:ext cx="4352544" cy="219456"/>
           </a:xfrm>
           <a:prstGeom prst="rect">
             <a:avLst/>
@@ -6864,7 +6890,7 @@
               <a:buNone/>
             </a:pPr>
             <a:r>
-              <a:rPr lang="en-US" sz="1150" dirty="0">
+              <a:rPr lang="en-US" sz="1000" dirty="0">
                 <a:solidFill>
                   <a:srgbClr val="FFFFFF"/>
                 </a:solidFill>
@@ -6872,22 +6898,22 @@
                 <a:ea typeface="Calibri" pitchFamily="34" charset="-122"/>
                 <a:cs typeface="Calibri" pitchFamily="34" charset="-120"/>
               </a:rPr>
-              <a:t>3. Geleneksel Kapalı Döngü: T_dış → T_iç eşiğine geçildi</a:t>
-            </a:r>
-            <a:endParaRPr lang="en-US" sz="1150" dirty="0"/>
-          </a:p>
-        </p:txBody>
-      </p:sp>
-      <p:sp>
-        <p:nvSpPr>
-          <p:cNvPr id="27" name="Text 25"/>
-          <p:cNvSpPr/>
-          <p:nvPr/>
-        </p:nvSpPr>
-        <p:spPr>
-          <a:xfrm>
-            <a:off x="384048" y="4443984"/>
-            <a:ext cx="4352544" cy="365760"/>
+              <a:t>4. Ajan eşikleri hizalandı (24°C→26°C, tutarlı)</a:t>
+            </a:r>
+            <a:endParaRPr lang="en-US" sz="1000" dirty="0"/>
+          </a:p>
+        </p:txBody>
+      </p:sp>
+      <p:sp>
+        <p:nvSpPr>
+          <p:cNvPr id="28" name="Text 26"/>
+          <p:cNvSpPr/>
+          <p:nvPr/>
+        </p:nvSpPr>
+        <p:spPr>
+          <a:xfrm>
+            <a:off x="384048" y="4059936"/>
+            <a:ext cx="4352544" cy="219456"/>
           </a:xfrm>
           <a:prstGeom prst="rect">
             <a:avLst/>
@@ -6903,7 +6929,7 @@
               <a:buNone/>
             </a:pPr>
             <a:r>
-              <a:rPr lang="en-US" sz="1150" dirty="0">
+              <a:rPr lang="en-US" sz="1000" dirty="0">
                 <a:solidFill>
                   <a:srgbClr val="FFFFFF"/>
                 </a:solidFill>
@@ -6911,15 +6937,132 @@
                 <a:ea typeface="Calibri" pitchFamily="34" charset="-122"/>
                 <a:cs typeface="Calibri" pitchFamily="34" charset="-120"/>
               </a:rPr>
-              <a:t>4. UCI Sınırlılık: P_klima=0 belgeli, R² yorumu dürüst</a:t>
-            </a:r>
-            <a:endParaRPr lang="en-US" sz="1150" dirty="0"/>
-          </a:p>
-        </p:txBody>
-      </p:sp>
-      <p:sp>
-        <p:nvSpPr>
-          <p:cNvPr id="28" name="Shape 26"/>
+              <a:t>5. Soğutma katsayısı γ fiziksel düzeltme (0.8→2.0)</a:t>
+            </a:r>
+            <a:endParaRPr lang="en-US" sz="1000" dirty="0"/>
+          </a:p>
+        </p:txBody>
+      </p:sp>
+      <p:sp>
+        <p:nvSpPr>
+          <p:cNvPr id="29" name="Text 27"/>
+          <p:cNvSpPr/>
+          <p:nvPr/>
+        </p:nvSpPr>
+        <p:spPr>
+          <a:xfrm>
+            <a:off x="384048" y="4297680"/>
+            <a:ext cx="4352544" cy="219456"/>
+          </a:xfrm>
+          <a:prstGeom prst="rect">
+            <a:avLst/>
+          </a:prstGeom>
+          <a:noFill/>
+          <a:ln/>
+        </p:spPr>
+        <p:txBody>
+          <a:bodyPr wrap="square" rtlCol="0" anchor="ctr"/>
+          <a:lstStyle/>
+          <a:p>
+            <a:pPr algn="l" indent="0" marL="0">
+              <a:buNone/>
+            </a:pPr>
+            <a:r>
+              <a:rPr lang="en-US" sz="1000" dirty="0">
+                <a:solidFill>
+                  <a:srgbClr val="FFFFFF"/>
+                </a:solidFill>
+                <a:latin typeface="Calibri" pitchFamily="34" charset="0"/>
+                <a:ea typeface="Calibri" pitchFamily="34" charset="-122"/>
+                <a:cs typeface="Calibri" pitchFamily="34" charset="-120"/>
+              </a:rPr>
+              <a:t>6. T_iç sınırlama clip(5°C–60°C), tüm döngüler</a:t>
+            </a:r>
+            <a:endParaRPr lang="en-US" sz="1000" dirty="0"/>
+          </a:p>
+        </p:txBody>
+      </p:sp>
+      <p:sp>
+        <p:nvSpPr>
+          <p:cNvPr id="30" name="Text 28"/>
+          <p:cNvSpPr/>
+          <p:nvPr/>
+        </p:nvSpPr>
+        <p:spPr>
+          <a:xfrm>
+            <a:off x="384048" y="4535424"/>
+            <a:ext cx="4352544" cy="219456"/>
+          </a:xfrm>
+          <a:prstGeom prst="rect">
+            <a:avLst/>
+          </a:prstGeom>
+          <a:noFill/>
+          <a:ln/>
+        </p:spPr>
+        <p:txBody>
+          <a:bodyPr wrap="square" rtlCol="0" anchor="ctr"/>
+          <a:lstStyle/>
+          <a:p>
+            <a:pPr algn="l" indent="0" marL="0">
+              <a:buNone/>
+            </a:pPr>
+            <a:r>
+              <a:rPr lang="en-US" sz="1000" dirty="0">
+                <a:solidFill>
+                  <a:srgbClr val="FFFFFF"/>
+                </a:solidFill>
+                <a:latin typeface="Calibri" pitchFamily="34" charset="0"/>
+                <a:ea typeface="Calibri" pitchFamily="34" charset="-122"/>
+                <a:cs typeface="Calibri" pitchFamily="34" charset="-120"/>
+              </a:rPr>
+              <a:t>7. ML cache key tamamlandı (fiyat, mesai dahil)</a:t>
+            </a:r>
+            <a:endParaRPr lang="en-US" sz="1000" dirty="0"/>
+          </a:p>
+        </p:txBody>
+      </p:sp>
+      <p:sp>
+        <p:nvSpPr>
+          <p:cNvPr id="31" name="Text 29"/>
+          <p:cNvSpPr/>
+          <p:nvPr/>
+        </p:nvSpPr>
+        <p:spPr>
+          <a:xfrm>
+            <a:off x="384048" y="4773168"/>
+            <a:ext cx="4352544" cy="219456"/>
+          </a:xfrm>
+          <a:prstGeom prst="rect">
+            <a:avLst/>
+          </a:prstGeom>
+          <a:noFill/>
+          <a:ln/>
+        </p:spPr>
+        <p:txBody>
+          <a:bodyPr wrap="square" rtlCol="0" anchor="ctr"/>
+          <a:lstStyle/>
+          <a:p>
+            <a:pPr algn="l" indent="0" marL="0">
+              <a:buNone/>
+            </a:pPr>
+            <a:r>
+              <a:rPr lang="en-US" sz="1000" dirty="0">
+                <a:solidFill>
+                  <a:srgbClr val="FFFFFF"/>
+                </a:solidFill>
+                <a:latin typeface="Calibri" pitchFamily="34" charset="0"/>
+                <a:ea typeface="Calibri" pitchFamily="34" charset="-122"/>
+                <a:cs typeface="Calibri" pitchFamily="34" charset="-120"/>
+              </a:rPr>
+              <a:t>8. Pecan Street IoT: güç validasyonu + Pearson kor.</a:t>
+            </a:r>
+            <a:endParaRPr lang="en-US" sz="1000" dirty="0"/>
+          </a:p>
+        </p:txBody>
+      </p:sp>
+      <p:sp>
+        <p:nvSpPr>
+          <p:cNvPr id="32" name="Shape 30"/>
           <p:cNvSpPr/>
           <p:nvPr/>
         </p:nvSpPr>
@@ -6951,7 +7094,7 @@
       </p:sp>
       <p:sp>
         <p:nvSpPr>
-          <p:cNvPr id="29" name="Shape 27"/>
+          <p:cNvPr id="33" name="Shape 31"/>
           <p:cNvSpPr/>
           <p:nvPr/>
         </p:nvSpPr>
@@ -6976,14 +7119,14 @@
       </p:sp>
       <p:sp>
         <p:nvSpPr>
-          <p:cNvPr id="30" name="Text 28"/>
+          <p:cNvPr id="34" name="Text 32"/>
           <p:cNvSpPr/>
           <p:nvPr/>
         </p:nvSpPr>
         <p:spPr>
           <a:xfrm>
             <a:off x="5157216" y="2761488"/>
-            <a:ext cx="3639312" cy="347472"/>
+            <a:ext cx="3639312" cy="320040"/>
           </a:xfrm>
           <a:prstGeom prst="rect">
             <a:avLst/>
@@ -6999,7 +7142,7 @@
               <a:buNone/>
             </a:pPr>
             <a:r>
-              <a:rPr lang="en-US" sz="1300" b="1" dirty="0">
+              <a:rPr lang="en-US" sz="1250" b="1" dirty="0">
                 <a:solidFill>
                   <a:srgbClr val="AB47BC"/>
                 </a:solidFill>
@@ -7009,20 +7152,20 @@
               </a:rPr>
               <a:t>Akademik Katkılar</a:t>
             </a:r>
-            <a:endParaRPr lang="en-US" sz="1300" dirty="0"/>
-          </a:p>
-        </p:txBody>
-      </p:sp>
-      <p:sp>
-        <p:nvSpPr>
-          <p:cNvPr id="31" name="Text 29"/>
-          <p:cNvSpPr/>
-          <p:nvPr/>
-        </p:nvSpPr>
-        <p:spPr>
-          <a:xfrm>
-            <a:off x="5157216" y="3154680"/>
-            <a:ext cx="3639312" cy="365760"/>
+            <a:endParaRPr lang="en-US" sz="1250" dirty="0"/>
+          </a:p>
+        </p:txBody>
+      </p:sp>
+      <p:sp>
+        <p:nvSpPr>
+          <p:cNvPr id="35" name="Text 33"/>
+          <p:cNvSpPr/>
+          <p:nvPr/>
+        </p:nvSpPr>
+        <p:spPr>
+          <a:xfrm>
+            <a:off x="5157216" y="3108960"/>
+            <a:ext cx="3639312" cy="320040"/>
           </a:xfrm>
           <a:prstGeom prst="rect">
             <a:avLst/>
@@ -7054,14 +7197,14 @@
       </p:sp>
       <p:sp>
         <p:nvSpPr>
-          <p:cNvPr id="32" name="Text 30"/>
-          <p:cNvSpPr/>
-          <p:nvPr/>
-        </p:nvSpPr>
-        <p:spPr>
-          <a:xfrm>
-            <a:off x="5157216" y="3557016"/>
-            <a:ext cx="3639312" cy="365760"/>
+          <p:cNvPr id="36" name="Text 34"/>
+          <p:cNvSpPr/>
+          <p:nvPr/>
+        </p:nvSpPr>
+        <p:spPr>
+          <a:xfrm>
+            <a:off x="5157216" y="3456432"/>
+            <a:ext cx="3639312" cy="320040"/>
           </a:xfrm>
           <a:prstGeom prst="rect">
             <a:avLst/>
@@ -7093,14 +7236,14 @@
       </p:sp>
       <p:sp>
         <p:nvSpPr>
-          <p:cNvPr id="33" name="Text 31"/>
-          <p:cNvSpPr/>
-          <p:nvPr/>
-        </p:nvSpPr>
-        <p:spPr>
-          <a:xfrm>
-            <a:off x="5157216" y="3959352"/>
-            <a:ext cx="3639312" cy="365760"/>
+          <p:cNvPr id="37" name="Text 35"/>
+          <p:cNvSpPr/>
+          <p:nvPr/>
+        </p:nvSpPr>
+        <p:spPr>
+          <a:xfrm>
+            <a:off x="5157216" y="3803904"/>
+            <a:ext cx="3639312" cy="320040"/>
           </a:xfrm>
           <a:prstGeom prst="rect">
             <a:avLst/>
@@ -7132,14 +7275,14 @@
       </p:sp>
       <p:sp>
         <p:nvSpPr>
-          <p:cNvPr id="34" name="Text 32"/>
-          <p:cNvSpPr/>
-          <p:nvPr/>
-        </p:nvSpPr>
-        <p:spPr>
-          <a:xfrm>
-            <a:off x="5157216" y="4361688"/>
-            <a:ext cx="3639312" cy="365760"/>
+          <p:cNvPr id="38" name="Text 36"/>
+          <p:cNvSpPr/>
+          <p:nvPr/>
+        </p:nvSpPr>
+        <p:spPr>
+          <a:xfrm>
+            <a:off x="5157216" y="4151376"/>
+            <a:ext cx="3639312" cy="320040"/>
           </a:xfrm>
           <a:prstGeom prst="rect">
             <a:avLst/>
@@ -7163,7 +7306,7 @@
                 <a:ea typeface="Calibri" pitchFamily="34" charset="-122"/>
                 <a:cs typeface="Calibri" pitchFamily="34" charset="-120"/>
               </a:rPr>
-              <a:t>• Gerçek IoT validasyonu + belgelenmiş sınırlılıklar</a:t>
+              <a:t>• Pecan Street IoT: güç profili validasyonu</a:t>
             </a:r>
             <a:endParaRPr lang="en-US" sz="1100" dirty="0"/>
           </a:p>
@@ -7171,14 +7314,14 @@
       </p:sp>
       <p:sp>
         <p:nvSpPr>
-          <p:cNvPr id="35" name="Text 33"/>
-          <p:cNvSpPr/>
-          <p:nvPr/>
-        </p:nvSpPr>
-        <p:spPr>
-          <a:xfrm>
-            <a:off x="5157216" y="4764024"/>
-            <a:ext cx="3639312" cy="365760"/>
+          <p:cNvPr id="39" name="Text 37"/>
+          <p:cNvSpPr/>
+          <p:nvPr/>
+        </p:nvSpPr>
+        <p:spPr>
+          <a:xfrm>
+            <a:off x="5157216" y="4498848"/>
+            <a:ext cx="3639312" cy="320040"/>
           </a:xfrm>
           <a:prstGeom prst="rect">
             <a:avLst/>
@@ -7194,7 +7337,46 @@
               <a:buNone/>
             </a:pPr>
             <a:r>
-              <a:rPr lang="en-US" sz="950" dirty="0">
+              <a:rPr lang="en-US" sz="1100" dirty="0">
+                <a:solidFill>
+                  <a:srgbClr val="FFFFFF"/>
+                </a:solidFill>
+                <a:latin typeface="Calibri" pitchFamily="34" charset="0"/>
+                <a:ea typeface="Calibri" pitchFamily="34" charset="-122"/>
+                <a:cs typeface="Calibri" pitchFamily="34" charset="-120"/>
+              </a:rPr>
+              <a:t>• Metrik: Pearson korelasyon (ölçekten bağımsız)</a:t>
+            </a:r>
+            <a:endParaRPr lang="en-US" sz="1100" dirty="0"/>
+          </a:p>
+        </p:txBody>
+      </p:sp>
+      <p:sp>
+        <p:nvSpPr>
+          <p:cNvPr id="40" name="Text 38"/>
+          <p:cNvSpPr/>
+          <p:nvPr/>
+        </p:nvSpPr>
+        <p:spPr>
+          <a:xfrm>
+            <a:off x="5157216" y="4846320"/>
+            <a:ext cx="3639312" cy="320040"/>
+          </a:xfrm>
+          <a:prstGeom prst="rect">
+            <a:avLst/>
+          </a:prstGeom>
+          <a:noFill/>
+          <a:ln/>
+        </p:spPr>
+        <p:txBody>
+          <a:bodyPr wrap="square" rtlCol="0" anchor="ctr"/>
+          <a:lstStyle/>
+          <a:p>
+            <a:pPr algn="l" indent="0" marL="0">
+              <a:buNone/>
+            </a:pPr>
+            <a:r>
+              <a:rPr lang="en-US" sz="900" dirty="0">
                 <a:solidFill>
                   <a:srgbClr val="8AB4D4"/>
                 </a:solidFill>
@@ -7202,15 +7384,15 @@
                 <a:ea typeface="Calibri" pitchFamily="34" charset="-122"/>
                 <a:cs typeface="Calibri" pitchFamily="34" charset="-120"/>
               </a:rPr>
-              <a:t>  (MAE / RMSE / R² / P_klima=0 şeffaflığı)</a:t>
-            </a:r>
-            <a:endParaRPr lang="en-US" sz="950" dirty="0"/>
-          </a:p>
-        </p:txBody>
-      </p:sp>
-      <p:sp>
-        <p:nvSpPr>
-          <p:cNvPr id="36" name="Shape 34"/>
+              <a:t>  R² negatif → beklenen (farklı bina ölçeği)</a:t>
+            </a:r>
+            <a:endParaRPr lang="en-US" sz="900" dirty="0"/>
+          </a:p>
+        </p:txBody>
+      </p:sp>
+      <p:sp>
+        <p:nvSpPr>
+          <p:cNvPr id="41" name="Shape 39"/>
           <p:cNvSpPr/>
           <p:nvPr/>
         </p:nvSpPr>
@@ -7235,7 +7417,7 @@
       </p:sp>
       <p:sp>
         <p:nvSpPr>
-          <p:cNvPr id="37" name="Text 35"/>
+          <p:cNvPr id="42" name="Text 40"/>
           <p:cNvSpPr/>
           <p:nvPr/>
         </p:nvSpPr>
@@ -7266,7 +7448,7 @@
                 <a:ea typeface="Calibri" pitchFamily="34" charset="-122"/>
                 <a:cs typeface="Calibri" pitchFamily="34" charset="-120"/>
               </a:rPr>
-              <a:t>Python  ·  Streamlit  ·  Scikit-learn  ·  Plotly  ·  UCI ML Repository</a:t>
+              <a:t>Python  ·  Streamlit  ·  Scikit-learn  ·  Plotly  ·  Pecan Street Dataport  ·  UCI ML Repository</a:t>
             </a:r>
             <a:endParaRPr lang="en-US" sz="1000" dirty="0"/>
           </a:p>
@@ -7274,7 +7456,7 @@
       </p:sp>
       <p:sp>
         <p:nvSpPr>
-          <p:cNvPr id="38" name="Shape 36"/>
+          <p:cNvPr id="43" name="Shape 41"/>
           <p:cNvSpPr/>
           <p:nvPr/>
         </p:nvSpPr>

</xml_diff>